<commit_message>
chore(supplier-deck): recover wip2 deck-builder rework from stash
Stale-but-not-superseded stash (stashed 2026-05-06, pre repo-reorg #24).
Verified the only post-stash change to the builder was the reorg's pure
file move (content identical), so this is current main + a self-contained
+280/-91 rework of build_supplier_shortlist_deck.py and the regenerated
Aplomb_Supplier_Shortlist_v1.pptx, faithfully mapped onto current-layout
paths. Preserved on this branch for review/continuation; not merged.

Co-Authored-By: Claude Opus 4.7 <noreply@anthropic.com>
</commit_message>
<xml_diff>
--- a/business-documents/supplier-analysis/correspondence/aplomb-supplier-shortlist-v1.pptx
+++ b/business-documents/supplier-analysis/correspondence/aplomb-supplier-shortlist-v1.pptx
@@ -18,6 +18,8 @@
     <p:sldId id="266" r:id="rId17"/>
     <p:sldId id="267" r:id="rId18"/>
     <p:sldId id="268" r:id="rId19"/>
+    <p:sldId id="269" r:id="rId20"/>
+    <p:sldId id="270" r:id="rId21"/>
   </p:sldIdLst>
   <p:sldSz cx="12192000" cy="6858000" type="screen4x3"/>
   <p:notesSz cx="6858000" cy="9144000"/>
@@ -300,7 +302,7 @@
           <a:p>
             <a:fld id="{5BCAD085-E8A6-8845-BD4E-CB4CCA059FC4}" type="datetimeFigureOut">
               <a:rPr lang="en-US"/>
-              <a:t>5/4/26</a:t>
+              <a:t>5/5/26</a:t>
             </a:fld>
             <a:endParaRPr lang="en-US"/>
           </a:p>
@@ -470,7 +472,7 @@
           <a:p>
             <a:fld id="{5BCAD085-E8A6-8845-BD4E-CB4CCA059FC4}" type="datetimeFigureOut">
               <a:rPr lang="en-US"/>
-              <a:t>5/4/26</a:t>
+              <a:t>5/5/26</a:t>
             </a:fld>
             <a:endParaRPr lang="en-US"/>
           </a:p>
@@ -650,7 +652,7 @@
           <a:p>
             <a:fld id="{5BCAD085-E8A6-8845-BD4E-CB4CCA059FC4}" type="datetimeFigureOut">
               <a:rPr lang="en-US"/>
-              <a:t>5/4/26</a:t>
+              <a:t>5/5/26</a:t>
             </a:fld>
             <a:endParaRPr lang="en-US"/>
           </a:p>
@@ -820,7 +822,7 @@
           <a:p>
             <a:fld id="{5BCAD085-E8A6-8845-BD4E-CB4CCA059FC4}" type="datetimeFigureOut">
               <a:rPr lang="en-US"/>
-              <a:t>5/4/26</a:t>
+              <a:t>5/5/26</a:t>
             </a:fld>
             <a:endParaRPr lang="en-US"/>
           </a:p>
@@ -1066,7 +1068,7 @@
           <a:p>
             <a:fld id="{5BCAD085-E8A6-8845-BD4E-CB4CCA059FC4}" type="datetimeFigureOut">
               <a:rPr lang="en-US"/>
-              <a:t>5/4/26</a:t>
+              <a:t>5/5/26</a:t>
             </a:fld>
             <a:endParaRPr lang="en-US"/>
           </a:p>
@@ -1354,7 +1356,7 @@
           <a:p>
             <a:fld id="{5BCAD085-E8A6-8845-BD4E-CB4CCA059FC4}" type="datetimeFigureOut">
               <a:rPr lang="en-US"/>
-              <a:t>5/4/26</a:t>
+              <a:t>5/5/26</a:t>
             </a:fld>
             <a:endParaRPr lang="en-US"/>
           </a:p>
@@ -1776,7 +1778,7 @@
           <a:p>
             <a:fld id="{5BCAD085-E8A6-8845-BD4E-CB4CCA059FC4}" type="datetimeFigureOut">
               <a:rPr lang="en-US"/>
-              <a:t>5/4/26</a:t>
+              <a:t>5/5/26</a:t>
             </a:fld>
             <a:endParaRPr lang="en-US"/>
           </a:p>
@@ -1894,7 +1896,7 @@
           <a:p>
             <a:fld id="{5BCAD085-E8A6-8845-BD4E-CB4CCA059FC4}" type="datetimeFigureOut">
               <a:rPr lang="en-US"/>
-              <a:t>5/4/26</a:t>
+              <a:t>5/5/26</a:t>
             </a:fld>
             <a:endParaRPr lang="en-US"/>
           </a:p>
@@ -1989,7 +1991,7 @@
           <a:p>
             <a:fld id="{5BCAD085-E8A6-8845-BD4E-CB4CCA059FC4}" type="datetimeFigureOut">
               <a:rPr lang="en-US"/>
-              <a:t>5/4/26</a:t>
+              <a:t>5/5/26</a:t>
             </a:fld>
             <a:endParaRPr lang="en-US"/>
           </a:p>
@@ -2266,7 +2268,7 @@
           <a:p>
             <a:fld id="{5BCAD085-E8A6-8845-BD4E-CB4CCA059FC4}" type="datetimeFigureOut">
               <a:rPr lang="en-US"/>
-              <a:t>5/4/26</a:t>
+              <a:t>5/5/26</a:t>
             </a:fld>
             <a:endParaRPr lang="en-US"/>
           </a:p>
@@ -2519,7 +2521,7 @@
           <a:p>
             <a:fld id="{5BCAD085-E8A6-8845-BD4E-CB4CCA059FC4}" type="datetimeFigureOut">
               <a:rPr lang="en-US"/>
-              <a:t>5/4/26</a:t>
+              <a:t>5/5/26</a:t>
             </a:fld>
             <a:endParaRPr lang="en-US"/>
           </a:p>
@@ -2732,7 +2734,7 @@
           <a:p>
             <a:fld id="{5BCAD085-E8A6-8845-BD4E-CB4CCA059FC4}" type="datetimeFigureOut">
               <a:rPr lang="en-US"/>
-              <a:t>5/4/26</a:t>
+              <a:t>5/5/26</a:t>
             </a:fld>
             <a:endParaRPr lang="en-US"/>
           </a:p>
@@ -3282,7 +3284,7 @@
         <p:spPr>
           <a:xfrm>
             <a:off x="548640" y="1828800"/>
-            <a:ext cx="7315200" cy="365760"/>
+            <a:ext cx="10058400" cy="365760"/>
           </a:xfrm>
           <a:prstGeom prst="rect">
             <a:avLst/>
@@ -3307,7 +3309,7 @@
                 </a:solidFill>
                 <a:latin typeface="IBM Plex Sans"/>
               </a:rPr>
-              <a:t>MVP supplier shortlist · 5 side effects · 12 stock-formula vendors</a:t>
+              <a:t>MVP supplier shortlist · 5 side effects · 12 stock-formula vendors · + outer-packaging mailer system (6 vendors)</a:t>
             </a:r>
           </a:p>
         </p:txBody>
@@ -3618,7 +3620,7 @@
                 </a:solidFill>
                 <a:latin typeface="IBM Plex Sans"/>
               </a:rPr>
-              <a:t>For Zachary Poll · Prepared 2026-05-04 · Confidential</a:t>
+              <a:t>For Zachary Poll · Prepared 2026-05-05 · Confidential</a:t>
             </a:r>
           </a:p>
         </p:txBody>
@@ -3657,7 +3659,7 @@
                 </a:solidFill>
                 <a:latin typeface="IBM Plex Sans"/>
               </a:rPr>
-              <a:t>01 / 13</a:t>
+              <a:t>01 / 15</a:t>
             </a:r>
           </a:p>
         </p:txBody>
@@ -4470,7 +4472,7 @@
                           </a:solidFill>
                           <a:latin typeface="IBM Plex Sans"/>
                         </a:rPr>
-                        <a:t>Gingerbon (Alibaba sourced)</a:t>
+                        <a:t>Shaanxi VitaHall Biotechnology</a:t>
                       </a:r>
                     </a:p>
                   </a:txBody>
@@ -4498,7 +4500,7 @@
                           <a:latin typeface="IBM Plex Sans"/>
                           <a:hlinkClick r:id="rId4"/>
                         </a:rPr>
-                        <a:t>alibaba.com/showroom/ginge…</a:t>
+                        <a:t>alibaba.com/product-detail…</a:t>
                       </a:r>
                     </a:p>
                   </a:txBody>
@@ -4525,7 +4527,7 @@
                           </a:solidFill>
                           <a:latin typeface="IBM Plex Sans"/>
                         </a:rPr>
-                        <a:t>Vietnamese ginger candy chew, private-label wrap; B6 add-on possible on custom run</a:t>
+                        <a:t>Vegan ginger root extract gummies, private-label OEM/ODM; chewable digestion-support format</a:t>
                       </a:r>
                     </a:p>
                   </a:txBody>
@@ -4553,7 +4555,7 @@
                           <a:latin typeface="IBM Plex Sans"/>
                           <a:hlinkClick r:id="rId4"/>
                         </a:rPr>
-                        <a:t>Gingerbon Candy Wholesale</a:t>
+                        <a:t>VitaHall Ginger Root Extract Gummies</a:t>
                       </a:r>
                     </a:p>
                   </a:txBody>
@@ -4580,7 +4582,7 @@
                           </a:solidFill>
                           <a:latin typeface="IBM Plex Sans"/>
                         </a:rPr>
-                        <a:t>100</a:t>
+                        <a:t>10</a:t>
                       </a:r>
                     </a:p>
                   </a:txBody>
@@ -4607,7 +4609,7 @@
                           </a:solidFill>
                           <a:latin typeface="IBM Plex Sans"/>
                         </a:rPr>
-                        <a:t>$2.40</a:t>
+                        <a:t>$5.00</a:t>
                       </a:r>
                     </a:p>
                   </a:txBody>
@@ -4634,7 +4636,7 @@
                           </a:solidFill>
                           <a:latin typeface="IBM Plex Sans"/>
                         </a:rPr>
-                        <a:t>$240</a:t>
+                        <a:t>$50</a:t>
                       </a:r>
                     </a:p>
                   </a:txBody>
@@ -4661,7 +4663,7 @@
                           </a:solidFill>
                           <a:latin typeface="IBM Plex Sans"/>
                         </a:rPr>
-                        <a:t>72</a:t>
+                        <a:t>70</a:t>
                       </a:r>
                     </a:p>
                   </a:txBody>
@@ -4688,7 +4690,7 @@
                           </a:solidFill>
                           <a:latin typeface="IBM Plex Sans"/>
                         </a:rPr>
-                        <a:t>Vietnam confectioner via Alibaba. Traditional ginger chew; well-tolerated; B6 not in stock blend — request custom for nausea positioning. Confirm specific seller before PO.</a:t>
+                        <a:t>Shaanxi, China. MOQ 10 bottles (verified on product page) — lowest published in category. Unit price uses high-end of observed $1.70–5 range as conservative low-qty tier. Ginger-as-hero stock SKU; B6 add-on via custom run.</a:t>
                       </a:r>
                     </a:p>
                   </a:txBody>
@@ -4717,7 +4719,7 @@
                           </a:solidFill>
                           <a:latin typeface="IBM Plex Sans"/>
                         </a:rPr>
-                        <a:t>Generic Asian ginger chew (Alibaba)</a:t>
+                        <a:t>Shaanxi Suni Green</a:t>
                       </a:r>
                     </a:p>
                   </a:txBody>
@@ -4745,7 +4747,7 @@
                           <a:latin typeface="IBM Plex Sans"/>
                           <a:hlinkClick r:id="rId5"/>
                         </a:rPr>
-                        <a:t>alibaba.com/showroom/ginge…</a:t>
+                        <a:t>alibaba.com/product-detail…</a:t>
                       </a:r>
                     </a:p>
                   </a:txBody>
@@ -4772,7 +4774,7 @@
                           </a:solidFill>
                           <a:latin typeface="IBM Plex Sans"/>
                         </a:rPr>
-                        <a:t>Private-label ginger chew, custom B6 + ginger blend; 66 suppliers in category</a:t>
+                        <a:t>Organic ginger root extract gummies, private-label OEM/ODM; chewable digestion-support format</a:t>
                       </a:r>
                     </a:p>
                   </a:txBody>
@@ -4800,7 +4802,7 @@
                           <a:latin typeface="IBM Plex Sans"/>
                           <a:hlinkClick r:id="rId5"/>
                         </a:rPr>
-                        <a:t>Ginger Chew OEM Listings</a:t>
+                        <a:t>SUNI Organic Ginger Root Extract Gummies</a:t>
                       </a:r>
                     </a:p>
                   </a:txBody>
@@ -4854,7 +4856,7 @@
                           </a:solidFill>
                           <a:latin typeface="IBM Plex Sans"/>
                         </a:rPr>
-                        <a:t>$2.00</a:t>
+                        <a:t>$2.20</a:t>
                       </a:r>
                     </a:p>
                   </a:txBody>
@@ -4881,7 +4883,7 @@
                           </a:solidFill>
                           <a:latin typeface="IBM Plex Sans"/>
                         </a:rPr>
-                        <a:t>$200</a:t>
+                        <a:t>$220</a:t>
                       </a:r>
                     </a:p>
                   </a:txBody>
@@ -4908,7 +4910,7 @@
                           </a:solidFill>
                           <a:latin typeface="IBM Plex Sans"/>
                         </a:rPr>
-                        <a:t>68</a:t>
+                        <a:t>66</a:t>
                       </a:r>
                     </a:p>
                   </a:txBody>
@@ -4935,7 +4937,7 @@
                           </a:solidFill>
                           <a:latin typeface="IBM Plex Sans"/>
                         </a:rPr>
-                        <a:t>147 ginger chew SKUs across 66 suppliers (most China). Request RFQ from 3-5 sellers; pick best MOQ + B6 spec. ISO9001 + HACCP common.</a:t>
+                        <a:t>Shaanxi, China. MOQ 100 bottles (verified on product page). Unit price $2.20 is high-end of observed $1.55–2.20 range. Vegan + organic certs. Direct competitor to VitaHall.</a:t>
                       </a:r>
                     </a:p>
                   </a:txBody>
@@ -5003,7 +5005,7 @@
         </p:nvSpPr>
         <p:spPr>
           <a:xfrm>
-            <a:off x="777240" y="5577840"/>
+            <a:off x="777240" y="5532120"/>
             <a:ext cx="10607040" cy="640080"/>
           </a:xfrm>
           <a:prstGeom prst="rect">
@@ -5160,7 +5162,7 @@
                 </a:solidFill>
                 <a:latin typeface="IBM Plex Sans"/>
               </a:rPr>
-              <a:t>10 / 13</a:t>
+              <a:t>10 / 15</a:t>
             </a:r>
           </a:p>
         </p:txBody>
@@ -6120,7 +6122,7 @@
                 </a:solidFill>
                 <a:latin typeface="IBM Plex Sans"/>
               </a:rPr>
-              <a:t>11 / 13</a:t>
+              <a:t>11 / 15</a:t>
             </a:r>
           </a:p>
         </p:txBody>
@@ -6350,7 +6352,7 @@
                 </a:solidFill>
                 <a:latin typeface="Cormorant Garamond"/>
               </a:rPr>
-              <a:t>Nutrient Depletion — 3 shortlisted suppliers</a:t>
+              <a:t>Nutrient Depletion — 1 shortlisted supplier</a:t>
             </a:r>
           </a:p>
         </p:txBody>
@@ -6423,7 +6425,7 @@
                 <a:gridCol w="600798"/>
                 <a:gridCol w="3188855"/>
               </a:tblGrid>
-              <a:tr h="800100">
+              <a:tr h="1600200">
                 <a:tc>
                   <a:txBody>
                     <a:bodyPr lIns="45000" rIns="45000" tIns="40000" bIns="40000" wrap="square"/>
@@ -6668,7 +6670,7 @@
                   </a:tcPr>
                 </a:tc>
               </a:tr>
-              <a:tr h="800100">
+              <a:tr h="1600200">
                 <a:tc>
                   <a:txBody>
                     <a:bodyPr lIns="45000" rIns="45000" tIns="40000" bIns="40000" wrap="square"/>
@@ -6915,7 +6917,1917 @@
                   </a:tcPr>
                 </a:tc>
               </a:tr>
-              <a:tr h="800100">
+            </a:tbl>
+          </a:graphicData>
+        </a:graphic>
+      </p:graphicFrame>
+      <p:sp>
+        <p:nvSpPr>
+          <p:cNvPr id="9" name="Rectangle 8"/>
+          <p:cNvSpPr/>
+          <p:nvPr/>
+        </p:nvSpPr>
+        <p:spPr>
+          <a:xfrm>
+            <a:off x="548640" y="5440680"/>
+            <a:ext cx="11091672" cy="868680"/>
+          </a:xfrm>
+          <a:prstGeom prst="rect">
+            <a:avLst/>
+          </a:prstGeom>
+          <a:solidFill>
+            <a:srgbClr val="F7F1E6"/>
+          </a:solidFill>
+          <a:ln>
+            <a:noFill/>
+          </a:ln>
+          <a:effectLst/>
+        </p:spPr>
+        <p:style>
+          <a:lnRef idx="1">
+            <a:schemeClr val="accent1"/>
+          </a:lnRef>
+          <a:fillRef idx="3">
+            <a:schemeClr val="accent1"/>
+          </a:fillRef>
+          <a:effectRef idx="2">
+            <a:schemeClr val="accent1"/>
+          </a:effectRef>
+          <a:fontRef idx="minor">
+            <a:schemeClr val="lt1"/>
+          </a:fontRef>
+        </p:style>
+        <p:txBody>
+          <a:bodyPr rtlCol="0" anchor="ctr"/>
+          <a:lstStyle/>
+          <a:p>
+            <a:pPr algn="ctr"/>
+            <a:endParaRPr/>
+          </a:p>
+        </p:txBody>
+      </p:sp>
+      <p:sp>
+        <p:nvSpPr>
+          <p:cNvPr id="10" name="TextBox 9"/>
+          <p:cNvSpPr txBox="1"/>
+          <p:nvPr/>
+        </p:nvSpPr>
+        <p:spPr>
+          <a:xfrm>
+            <a:off x="777240" y="5532120"/>
+            <a:ext cx="10607040" cy="640080"/>
+          </a:xfrm>
+          <a:prstGeom prst="rect">
+            <a:avLst/>
+          </a:prstGeom>
+          <a:noFill/>
+        </p:spPr>
+        <p:txBody>
+          <a:bodyPr wrap="square" lIns="0" rIns="0" tIns="0" bIns="0" anchor="t">
+            <a:spAutoFit/>
+          </a:bodyPr>
+          <a:lstStyle/>
+          <a:p>
+            <a:pPr algn="l">
+              <a:lnSpc>
+                <a:spcPct val="118000"/>
+              </a:lnSpc>
+            </a:pPr>
+            <a:r>
+              <a:rPr sz="850" b="1" i="0">
+                <a:solidFill>
+                  <a:srgbClr val="7A3D14"/>
+                </a:solidFill>
+                <a:latin typeface="IBM Plex Sans"/>
+              </a:rPr>
+              <a:t>RECOMMENDED LEAD  </a:t>
+            </a:r>
+            <a:r>
+              <a:rPr sz="1200" b="1" i="0">
+                <a:solidFill>
+                  <a:srgbClr val="1A1512"/>
+                </a:solidFill>
+                <a:latin typeface="IBM Plex Sans"/>
+              </a:rPr>
+              <a:t>Aogubio (Xi'an)</a:t>
+            </a:r>
+            <a:r>
+              <a:rPr sz="1100" b="0" i="0">
+                <a:solidFill>
+                  <a:srgbClr val="1A1512"/>
+                </a:solidFill>
+                <a:latin typeface="IBM Plex Sans"/>
+              </a:rPr>
+              <a:t> · score 71/100 · MOQ 100 · $1.75/unit · total $175</a:t>
+            </a:r>
+          </a:p>
+        </p:txBody>
+      </p:sp>
+      <p:cxnSp>
+        <p:nvCxnSpPr>
+          <p:cNvPr id="11" name="Connector 10"/>
+          <p:cNvCxnSpPr/>
+          <p:nvPr/>
+        </p:nvCxnSpPr>
+        <p:spPr>
+          <a:xfrm>
+            <a:off x="548640" y="6446520"/>
+            <a:ext cx="11091672" cy="0"/>
+          </a:xfrm>
+          <a:prstGeom prst="line">
+            <a:avLst/>
+          </a:prstGeom>
+          <a:ln w="9525">
+            <a:solidFill>
+              <a:srgbClr val="D9CFBD"/>
+            </a:solidFill>
+          </a:ln>
+        </p:spPr>
+        <p:style>
+          <a:lnRef idx="2">
+            <a:schemeClr val="accent1"/>
+          </a:lnRef>
+          <a:fillRef idx="0">
+            <a:schemeClr val="accent1"/>
+          </a:fillRef>
+          <a:effectRef idx="1">
+            <a:schemeClr val="accent1"/>
+          </a:effectRef>
+          <a:fontRef idx="minor">
+            <a:schemeClr val="tx1"/>
+          </a:fontRef>
+        </p:style>
+      </p:cxnSp>
+      <p:sp>
+        <p:nvSpPr>
+          <p:cNvPr id="12" name="TextBox 11"/>
+          <p:cNvSpPr txBox="1"/>
+          <p:nvPr/>
+        </p:nvSpPr>
+        <p:spPr>
+          <a:xfrm>
+            <a:off x="548640" y="6519672"/>
+            <a:ext cx="7315200" cy="274320"/>
+          </a:xfrm>
+          <a:prstGeom prst="rect">
+            <a:avLst/>
+          </a:prstGeom>
+          <a:noFill/>
+        </p:spPr>
+        <p:txBody>
+          <a:bodyPr wrap="square" lIns="0" rIns="0" tIns="0" bIns="0" anchor="t">
+            <a:spAutoFit/>
+          </a:bodyPr>
+          <a:lstStyle/>
+          <a:p>
+            <a:pPr algn="l">
+              <a:lnSpc>
+                <a:spcPct val="118000"/>
+              </a:lnSpc>
+            </a:pPr>
+            <a:r>
+              <a:rPr sz="800" b="0" i="0">
+                <a:solidFill>
+                  <a:srgbClr val="6B5D4C"/>
+                </a:solidFill>
+                <a:latin typeface="IBM Plex Sans"/>
+              </a:rPr>
+              <a:t>Aplomb — Supplier shortlist for MVP market test · For Zachary Poll · Confidential</a:t>
+            </a:r>
+          </a:p>
+        </p:txBody>
+      </p:sp>
+      <p:sp>
+        <p:nvSpPr>
+          <p:cNvPr id="13" name="TextBox 12"/>
+          <p:cNvSpPr txBox="1"/>
+          <p:nvPr/>
+        </p:nvSpPr>
+        <p:spPr>
+          <a:xfrm>
+            <a:off x="10332720" y="6519672"/>
+            <a:ext cx="1371600" cy="274320"/>
+          </a:xfrm>
+          <a:prstGeom prst="rect">
+            <a:avLst/>
+          </a:prstGeom>
+          <a:noFill/>
+        </p:spPr>
+        <p:txBody>
+          <a:bodyPr wrap="square" lIns="0" rIns="0" tIns="0" bIns="0" anchor="t">
+            <a:spAutoFit/>
+          </a:bodyPr>
+          <a:lstStyle/>
+          <a:p>
+            <a:pPr algn="r">
+              <a:lnSpc>
+                <a:spcPct val="118000"/>
+              </a:lnSpc>
+            </a:pPr>
+            <a:r>
+              <a:rPr sz="800" b="0" i="0">
+                <a:solidFill>
+                  <a:srgbClr val="6B5D4C"/>
+                </a:solidFill>
+                <a:latin typeface="IBM Plex Sans"/>
+              </a:rPr>
+              <a:t>12 / 15</a:t>
+            </a:r>
+          </a:p>
+        </p:txBody>
+      </p:sp>
+    </p:spTree>
+  </p:cSld>
+  <p:clrMapOvr>
+    <a:masterClrMapping/>
+  </p:clrMapOvr>
+</p:sld>
+</file>
+
+<file path=ppt/slides/slide13.xml><?xml version="1.0" encoding="utf-8"?>
+<p:sld xmlns:a="http://schemas.openxmlformats.org/drawingml/2006/main" xmlns:p="http://schemas.openxmlformats.org/presentationml/2006/main" xmlns:r="http://schemas.openxmlformats.org/officeDocument/2006/relationships">
+  <p:cSld>
+    <p:spTree>
+      <p:nvGrpSpPr>
+        <p:cNvPr id="1" name=""/>
+        <p:cNvGrpSpPr/>
+        <p:nvPr/>
+      </p:nvGrpSpPr>
+      <p:grpSpPr>
+        <a:xfrm>
+          <a:off x="0" y="0"/>
+          <a:ext cx="0" cy="0"/>
+          <a:chOff x="0" y="0"/>
+          <a:chExt cx="0" cy="0"/>
+        </a:xfrm>
+      </p:grpSpPr>
+      <p:sp>
+        <p:nvSpPr>
+          <p:cNvPr id="2" name="Rectangle 1"/>
+          <p:cNvSpPr/>
+          <p:nvPr/>
+        </p:nvSpPr>
+        <p:spPr>
+          <a:xfrm>
+            <a:off x="0" y="0"/>
+            <a:ext cx="12192000" cy="6858000"/>
+          </a:xfrm>
+          <a:prstGeom prst="rect">
+            <a:avLst/>
+          </a:prstGeom>
+          <a:solidFill>
+            <a:srgbClr val="EFE8DC"/>
+          </a:solidFill>
+          <a:ln>
+            <a:noFill/>
+          </a:ln>
+        </p:spPr>
+        <p:style>
+          <a:lnRef idx="1">
+            <a:schemeClr val="accent1"/>
+          </a:lnRef>
+          <a:fillRef idx="3">
+            <a:schemeClr val="accent1"/>
+          </a:fillRef>
+          <a:effectRef idx="2">
+            <a:schemeClr val="accent1"/>
+          </a:effectRef>
+          <a:fontRef idx="minor">
+            <a:schemeClr val="lt1"/>
+          </a:fontRef>
+        </p:style>
+        <p:txBody>
+          <a:bodyPr rtlCol="0" anchor="ctr"/>
+          <a:lstStyle/>
+          <a:p>
+            <a:pPr algn="ctr"/>
+            <a:endParaRPr/>
+          </a:p>
+        </p:txBody>
+      </p:sp>
+      <p:cxnSp>
+        <p:nvCxnSpPr>
+          <p:cNvPr id="3" name="Connector 2"/>
+          <p:cNvCxnSpPr/>
+          <p:nvPr/>
+        </p:nvCxnSpPr>
+        <p:spPr>
+          <a:xfrm>
+            <a:off x="548640" y="502920"/>
+            <a:ext cx="11091672" cy="0"/>
+          </a:xfrm>
+          <a:prstGeom prst="line">
+            <a:avLst/>
+          </a:prstGeom>
+          <a:ln w="9525">
+            <a:solidFill>
+              <a:srgbClr val="D9CFBD"/>
+            </a:solidFill>
+          </a:ln>
+        </p:spPr>
+        <p:style>
+          <a:lnRef idx="2">
+            <a:schemeClr val="accent1"/>
+          </a:lnRef>
+          <a:fillRef idx="0">
+            <a:schemeClr val="accent1"/>
+          </a:fillRef>
+          <a:effectRef idx="1">
+            <a:schemeClr val="accent1"/>
+          </a:effectRef>
+          <a:fontRef idx="minor">
+            <a:schemeClr val="tx1"/>
+          </a:fontRef>
+        </p:style>
+      </p:cxnSp>
+      <p:sp>
+        <p:nvSpPr>
+          <p:cNvPr id="4" name="TextBox 3"/>
+          <p:cNvSpPr txBox="1"/>
+          <p:nvPr/>
+        </p:nvSpPr>
+        <p:spPr>
+          <a:xfrm>
+            <a:off x="548640" y="164592"/>
+            <a:ext cx="7315200" cy="274320"/>
+          </a:xfrm>
+          <a:prstGeom prst="rect">
+            <a:avLst/>
+          </a:prstGeom>
+          <a:noFill/>
+        </p:spPr>
+        <p:txBody>
+          <a:bodyPr wrap="square" lIns="0" rIns="0" tIns="0" bIns="0" anchor="t">
+            <a:spAutoFit/>
+          </a:bodyPr>
+          <a:lstStyle/>
+          <a:p>
+            <a:pPr algn="l">
+              <a:lnSpc>
+                <a:spcPct val="118000"/>
+              </a:lnSpc>
+            </a:pPr>
+            <a:r>
+              <a:rPr sz="900" b="0" i="0">
+                <a:solidFill>
+                  <a:srgbClr val="7A3D14"/>
+                </a:solidFill>
+                <a:latin typeface="IBM Plex Sans"/>
+              </a:rPr>
+              <a:t>§ 06 · Add-on · Two-SKU folding-mailer system</a:t>
+            </a:r>
+          </a:p>
+        </p:txBody>
+      </p:sp>
+      <p:sp>
+        <p:nvSpPr>
+          <p:cNvPr id="5" name="TextBox 4"/>
+          <p:cNvSpPr txBox="1"/>
+          <p:nvPr/>
+        </p:nvSpPr>
+        <p:spPr>
+          <a:xfrm>
+            <a:off x="10058400" y="164592"/>
+            <a:ext cx="1645920" cy="274320"/>
+          </a:xfrm>
+          <a:prstGeom prst="rect">
+            <a:avLst/>
+          </a:prstGeom>
+          <a:noFill/>
+        </p:spPr>
+        <p:txBody>
+          <a:bodyPr wrap="square" lIns="0" rIns="0" tIns="0" bIns="0" anchor="t">
+            <a:spAutoFit/>
+          </a:bodyPr>
+          <a:lstStyle/>
+          <a:p>
+            <a:pPr algn="r">
+              <a:lnSpc>
+                <a:spcPct val="118000"/>
+              </a:lnSpc>
+            </a:pPr>
+            <a:r>
+              <a:rPr sz="1100" b="0" i="1">
+                <a:solidFill>
+                  <a:srgbClr val="1A1512"/>
+                </a:solidFill>
+                <a:latin typeface="Cormorant Garamond"/>
+              </a:rPr>
+              <a:t>Aplomb</a:t>
+            </a:r>
+            <a:r>
+              <a:rPr sz="1100" b="1" i="1">
+                <a:solidFill>
+                  <a:srgbClr val="7A3D14"/>
+                </a:solidFill>
+                <a:latin typeface="Cormorant Garamond"/>
+              </a:rPr>
+              <a:t>.</a:t>
+            </a:r>
+          </a:p>
+        </p:txBody>
+      </p:sp>
+      <p:sp>
+        <p:nvSpPr>
+          <p:cNvPr id="6" name="TextBox 5"/>
+          <p:cNvSpPr txBox="1"/>
+          <p:nvPr/>
+        </p:nvSpPr>
+        <p:spPr>
+          <a:xfrm>
+            <a:off x="548640" y="777240"/>
+            <a:ext cx="10972800" cy="1097280"/>
+          </a:xfrm>
+          <a:prstGeom prst="rect">
+            <a:avLst/>
+          </a:prstGeom>
+          <a:noFill/>
+        </p:spPr>
+        <p:txBody>
+          <a:bodyPr wrap="square" lIns="0" rIns="0" tIns="0" bIns="0" anchor="t">
+            <a:spAutoFit/>
+          </a:bodyPr>
+          <a:lstStyle/>
+          <a:p>
+            <a:pPr algn="l">
+              <a:lnSpc>
+                <a:spcPct val="105000"/>
+              </a:lnSpc>
+            </a:pPr>
+            <a:r>
+              <a:rPr sz="3800" b="0" i="0">
+                <a:solidFill>
+                  <a:srgbClr val="1A1512"/>
+                </a:solidFill>
+                <a:latin typeface="Cormorant Garamond"/>
+              </a:rPr>
+              <a:t>Outer Packaging</a:t>
+            </a:r>
+          </a:p>
+        </p:txBody>
+      </p:sp>
+      <p:sp>
+        <p:nvSpPr>
+          <p:cNvPr id="7" name="Rectangle 6"/>
+          <p:cNvSpPr/>
+          <p:nvPr/>
+        </p:nvSpPr>
+        <p:spPr>
+          <a:xfrm>
+            <a:off x="548640" y="1828800"/>
+            <a:ext cx="5349240" cy="4434840"/>
+          </a:xfrm>
+          <a:prstGeom prst="rect">
+            <a:avLst/>
+          </a:prstGeom>
+          <a:solidFill>
+            <a:srgbClr val="F7F1E6"/>
+          </a:solidFill>
+          <a:ln>
+            <a:noFill/>
+          </a:ln>
+          <a:effectLst/>
+        </p:spPr>
+        <p:style>
+          <a:lnRef idx="1">
+            <a:schemeClr val="accent1"/>
+          </a:lnRef>
+          <a:fillRef idx="3">
+            <a:schemeClr val="accent1"/>
+          </a:fillRef>
+          <a:effectRef idx="2">
+            <a:schemeClr val="accent1"/>
+          </a:effectRef>
+          <a:fontRef idx="minor">
+            <a:schemeClr val="lt1"/>
+          </a:fontRef>
+        </p:style>
+        <p:txBody>
+          <a:bodyPr rtlCol="0" anchor="ctr"/>
+          <a:lstStyle/>
+          <a:p>
+            <a:pPr algn="ctr"/>
+            <a:endParaRPr/>
+          </a:p>
+        </p:txBody>
+      </p:sp>
+      <p:sp>
+        <p:nvSpPr>
+          <p:cNvPr id="8" name="TextBox 7"/>
+          <p:cNvSpPr txBox="1"/>
+          <p:nvPr/>
+        </p:nvSpPr>
+        <p:spPr>
+          <a:xfrm>
+            <a:off x="777240" y="1993392"/>
+            <a:ext cx="4937760" cy="365760"/>
+          </a:xfrm>
+          <a:prstGeom prst="rect">
+            <a:avLst/>
+          </a:prstGeom>
+          <a:noFill/>
+        </p:spPr>
+        <p:txBody>
+          <a:bodyPr wrap="square" lIns="0" rIns="0" tIns="0" bIns="0" anchor="t">
+            <a:spAutoFit/>
+          </a:bodyPr>
+          <a:lstStyle/>
+          <a:p>
+            <a:pPr algn="l">
+              <a:lnSpc>
+                <a:spcPct val="118000"/>
+              </a:lnSpc>
+            </a:pPr>
+            <a:r>
+              <a:rPr sz="850" b="1" i="0">
+                <a:solidFill>
+                  <a:srgbClr val="7A3D14"/>
+                </a:solidFill>
+                <a:latin typeface="IBM Plex Sans"/>
+              </a:rPr>
+              <a:t>THE BRIEF</a:t>
+            </a:r>
+          </a:p>
+        </p:txBody>
+      </p:sp>
+      <p:cxnSp>
+        <p:nvCxnSpPr>
+          <p:cNvPr id="9" name="Connector 8"/>
+          <p:cNvCxnSpPr/>
+          <p:nvPr/>
+        </p:nvCxnSpPr>
+        <p:spPr>
+          <a:xfrm>
+            <a:off x="777240" y="2304288"/>
+            <a:ext cx="4937760" cy="0"/>
+          </a:xfrm>
+          <a:prstGeom prst="line">
+            <a:avLst/>
+          </a:prstGeom>
+          <a:ln w="6350">
+            <a:solidFill>
+              <a:srgbClr val="D9CFBD"/>
+            </a:solidFill>
+          </a:ln>
+        </p:spPr>
+        <p:style>
+          <a:lnRef idx="2">
+            <a:schemeClr val="accent1"/>
+          </a:lnRef>
+          <a:fillRef idx="0">
+            <a:schemeClr val="accent1"/>
+          </a:fillRef>
+          <a:effectRef idx="1">
+            <a:schemeClr val="accent1"/>
+          </a:effectRef>
+          <a:fontRef idx="minor">
+            <a:schemeClr val="tx1"/>
+          </a:fontRef>
+        </p:style>
+      </p:cxnSp>
+      <p:sp>
+        <p:nvSpPr>
+          <p:cNvPr id="10" name="TextBox 9"/>
+          <p:cNvSpPr txBox="1"/>
+          <p:nvPr/>
+        </p:nvSpPr>
+        <p:spPr>
+          <a:xfrm>
+            <a:off x="777240" y="2423160"/>
+            <a:ext cx="4937760" cy="2377440"/>
+          </a:xfrm>
+          <a:prstGeom prst="rect">
+            <a:avLst/>
+          </a:prstGeom>
+          <a:noFill/>
+        </p:spPr>
+        <p:txBody>
+          <a:bodyPr wrap="square" lIns="0" rIns="0" tIns="0" bIns="0" anchor="t">
+            <a:spAutoFit/>
+          </a:bodyPr>
+          <a:lstStyle/>
+          <a:p>
+            <a:pPr algn="l">
+              <a:lnSpc>
+                <a:spcPct val="145000"/>
+              </a:lnSpc>
+            </a:pPr>
+            <a:r>
+              <a:rPr sz="1100" b="0" i="0">
+                <a:solidFill>
+                  <a:srgbClr val="1A1512"/>
+                </a:solidFill>
+                <a:latin typeface="IBM Plex Sans"/>
+              </a:rPr>
+              <a:t>Every Aplomb SKU needs an outer mailer that ships flat, weighs almost nothing, and reads editorial — not generic corrugated. Reference: Musely's matte mauve folding-carton mailer (single-color exterior, branded interior message, soft tactile paperboard). Two carton SKUs cover the line: a small mailer for the serum, capsule bottles, and lozenge tin; a large mailer for the Calm kit.</a:t>
+            </a:r>
+          </a:p>
+        </p:txBody>
+      </p:sp>
+      <p:cxnSp>
+        <p:nvCxnSpPr>
+          <p:cNvPr id="11" name="Connector 10"/>
+          <p:cNvCxnSpPr/>
+          <p:nvPr/>
+        </p:nvCxnSpPr>
+        <p:spPr>
+          <a:xfrm>
+            <a:off x="777240" y="4846320"/>
+            <a:ext cx="4937760" cy="0"/>
+          </a:xfrm>
+          <a:prstGeom prst="line">
+            <a:avLst/>
+          </a:prstGeom>
+          <a:ln w="6350">
+            <a:solidFill>
+              <a:srgbClr val="D9CFBD"/>
+            </a:solidFill>
+          </a:ln>
+        </p:spPr>
+        <p:style>
+          <a:lnRef idx="2">
+            <a:schemeClr val="accent1"/>
+          </a:lnRef>
+          <a:fillRef idx="0">
+            <a:schemeClr val="accent1"/>
+          </a:fillRef>
+          <a:effectRef idx="1">
+            <a:schemeClr val="accent1"/>
+          </a:effectRef>
+          <a:fontRef idx="minor">
+            <a:schemeClr val="tx1"/>
+          </a:fontRef>
+        </p:style>
+      </p:cxnSp>
+      <p:sp>
+        <p:nvSpPr>
+          <p:cNvPr id="12" name="TextBox 11"/>
+          <p:cNvSpPr txBox="1"/>
+          <p:nvPr/>
+        </p:nvSpPr>
+        <p:spPr>
+          <a:xfrm>
+            <a:off x="777240" y="4937760"/>
+            <a:ext cx="4937760" cy="365760"/>
+          </a:xfrm>
+          <a:prstGeom prst="rect">
+            <a:avLst/>
+          </a:prstGeom>
+          <a:noFill/>
+        </p:spPr>
+        <p:txBody>
+          <a:bodyPr wrap="square" lIns="0" rIns="0" tIns="0" bIns="0" anchor="t">
+            <a:spAutoFit/>
+          </a:bodyPr>
+          <a:lstStyle/>
+          <a:p>
+            <a:pPr algn="l">
+              <a:lnSpc>
+                <a:spcPct val="118000"/>
+              </a:lnSpc>
+            </a:pPr>
+            <a:r>
+              <a:rPr sz="850" b="1" i="0">
+                <a:solidFill>
+                  <a:srgbClr val="7A3D14"/>
+                </a:solidFill>
+                <a:latin typeface="IBM Plex Sans"/>
+              </a:rPr>
+              <a:t>MUSELY INTELLIGENCE</a:t>
+            </a:r>
+          </a:p>
+        </p:txBody>
+      </p:sp>
+      <p:sp>
+        <p:nvSpPr>
+          <p:cNvPr id="13" name="TextBox 12"/>
+          <p:cNvSpPr txBox="1"/>
+          <p:nvPr/>
+        </p:nvSpPr>
+        <p:spPr>
+          <a:xfrm>
+            <a:off x="777240" y="5230368"/>
+            <a:ext cx="4937760" cy="1097280"/>
+          </a:xfrm>
+          <a:prstGeom prst="rect">
+            <a:avLst/>
+          </a:prstGeom>
+          <a:noFill/>
+        </p:spPr>
+        <p:txBody>
+          <a:bodyPr wrap="square" lIns="0" rIns="0" tIns="0" bIns="0" anchor="t">
+            <a:spAutoFit/>
+          </a:bodyPr>
+          <a:lstStyle/>
+          <a:p>
+            <a:pPr algn="l">
+              <a:lnSpc>
+                <a:spcPct val="140000"/>
+              </a:lnSpc>
+            </a:pPr>
+            <a:r>
+              <a:rPr sz="950" b="0" i="0">
+                <a:solidFill>
+                  <a:srgbClr val="1A1512"/>
+                </a:solidFill>
+                <a:latin typeface="IBM Plex Sans"/>
+              </a:rPr>
+              <a:t>Musely (telehealth dermatology, founded 2013) commissioned its brand evolution from White and Salt design studio. Musely's specific carton vendor is not public; the closest production-format match for the same paperboard mailer at MOQ 200-400 is Arka or noissue. RFQ both as the path of least resistance to a Musely-equivalent first run.</a:t>
+            </a:r>
+          </a:p>
+        </p:txBody>
+      </p:sp>
+      <p:sp>
+        <p:nvSpPr>
+          <p:cNvPr id="14" name="Rectangle 13"/>
+          <p:cNvSpPr/>
+          <p:nvPr/>
+        </p:nvSpPr>
+        <p:spPr>
+          <a:xfrm>
+            <a:off x="6035040" y="1828800"/>
+            <a:ext cx="5605272" cy="2697480"/>
+          </a:xfrm>
+          <a:prstGeom prst="rect">
+            <a:avLst/>
+          </a:prstGeom>
+          <a:solidFill>
+            <a:srgbClr val="F7F1E6"/>
+          </a:solidFill>
+          <a:ln>
+            <a:noFill/>
+          </a:ln>
+          <a:effectLst/>
+        </p:spPr>
+        <p:style>
+          <a:lnRef idx="1">
+            <a:schemeClr val="accent1"/>
+          </a:lnRef>
+          <a:fillRef idx="3">
+            <a:schemeClr val="accent1"/>
+          </a:fillRef>
+          <a:effectRef idx="2">
+            <a:schemeClr val="accent1"/>
+          </a:effectRef>
+          <a:fontRef idx="minor">
+            <a:schemeClr val="lt1"/>
+          </a:fontRef>
+        </p:style>
+        <p:txBody>
+          <a:bodyPr rtlCol="0" anchor="ctr"/>
+          <a:lstStyle/>
+          <a:p>
+            <a:pPr algn="ctr"/>
+            <a:endParaRPr/>
+          </a:p>
+        </p:txBody>
+      </p:sp>
+      <p:sp>
+        <p:nvSpPr>
+          <p:cNvPr id="15" name="TextBox 14"/>
+          <p:cNvSpPr txBox="1"/>
+          <p:nvPr/>
+        </p:nvSpPr>
+        <p:spPr>
+          <a:xfrm>
+            <a:off x="6263640" y="1993392"/>
+            <a:ext cx="5212080" cy="365760"/>
+          </a:xfrm>
+          <a:prstGeom prst="rect">
+            <a:avLst/>
+          </a:prstGeom>
+          <a:noFill/>
+        </p:spPr>
+        <p:txBody>
+          <a:bodyPr wrap="square" lIns="0" rIns="0" tIns="0" bIns="0" anchor="t">
+            <a:spAutoFit/>
+          </a:bodyPr>
+          <a:lstStyle/>
+          <a:p>
+            <a:pPr algn="l">
+              <a:lnSpc>
+                <a:spcPct val="118000"/>
+              </a:lnSpc>
+            </a:pPr>
+            <a:r>
+              <a:rPr sz="850" b="1" i="0">
+                <a:solidFill>
+                  <a:srgbClr val="7A3D14"/>
+                </a:solidFill>
+                <a:latin typeface="IBM Plex Sans"/>
+              </a:rPr>
+              <a:t>CARTON SPEC</a:t>
+            </a:r>
+          </a:p>
+        </p:txBody>
+      </p:sp>
+      <p:cxnSp>
+        <p:nvCxnSpPr>
+          <p:cNvPr id="16" name="Connector 15"/>
+          <p:cNvCxnSpPr/>
+          <p:nvPr/>
+        </p:nvCxnSpPr>
+        <p:spPr>
+          <a:xfrm>
+            <a:off x="6263640" y="2304288"/>
+            <a:ext cx="5212080" cy="0"/>
+          </a:xfrm>
+          <a:prstGeom prst="line">
+            <a:avLst/>
+          </a:prstGeom>
+          <a:ln w="6350">
+            <a:solidFill>
+              <a:srgbClr val="D9CFBD"/>
+            </a:solidFill>
+          </a:ln>
+        </p:spPr>
+        <p:style>
+          <a:lnRef idx="2">
+            <a:schemeClr val="accent1"/>
+          </a:lnRef>
+          <a:fillRef idx="0">
+            <a:schemeClr val="accent1"/>
+          </a:fillRef>
+          <a:effectRef idx="1">
+            <a:schemeClr val="accent1"/>
+          </a:effectRef>
+          <a:fontRef idx="minor">
+            <a:schemeClr val="tx1"/>
+          </a:fontRef>
+        </p:style>
+      </p:cxnSp>
+      <p:sp>
+        <p:nvSpPr>
+          <p:cNvPr id="17" name="TextBox 16"/>
+          <p:cNvSpPr txBox="1"/>
+          <p:nvPr/>
+        </p:nvSpPr>
+        <p:spPr>
+          <a:xfrm>
+            <a:off x="6263640" y="2395728"/>
+            <a:ext cx="5212080" cy="2121408"/>
+          </a:xfrm>
+          <a:prstGeom prst="rect">
+            <a:avLst/>
+          </a:prstGeom>
+          <a:noFill/>
+        </p:spPr>
+        <p:txBody>
+          <a:bodyPr wrap="square" lIns="0" rIns="0" tIns="0" bIns="0" anchor="t">
+            <a:spAutoFit/>
+          </a:bodyPr>
+          <a:lstStyle/>
+          <a:p>
+            <a:pPr algn="l">
+              <a:lnSpc>
+                <a:spcPct val="132000"/>
+              </a:lnSpc>
+            </a:pPr>
+            <a:r>
+              <a:rPr sz="1050" b="1" i="0">
+                <a:solidFill>
+                  <a:srgbClr val="7A3D14"/>
+                </a:solidFill>
+                <a:latin typeface="IBM Plex Sans"/>
+              </a:rPr>
+              <a:t>•  </a:t>
+            </a:r>
+            <a:r>
+              <a:rPr sz="1050" b="0" i="0">
+                <a:solidFill>
+                  <a:srgbClr val="1A1512"/>
+                </a:solidFill>
+                <a:latin typeface="IBM Plex Sans"/>
+              </a:rPr>
+              <a:t>Small carton — ~120 × 60 × 60 mm interior · fits Serum, Daily, Roots, Composure tin</a:t>
+            </a:r>
+          </a:p>
+          <a:p>
+            <a:pPr algn="l">
+              <a:lnSpc>
+                <a:spcPct val="132000"/>
+              </a:lnSpc>
+            </a:pPr>
+            <a:r>
+              <a:rPr sz="1050" b="1" i="0">
+                <a:solidFill>
+                  <a:srgbClr val="7A3D14"/>
+                </a:solidFill>
+                <a:latin typeface="IBM Plex Sans"/>
+              </a:rPr>
+              <a:t>•  </a:t>
+            </a:r>
+            <a:r>
+              <a:rPr sz="1050" b="0" i="0">
+                <a:solidFill>
+                  <a:srgbClr val="1A1512"/>
+                </a:solidFill>
+                <a:latin typeface="IBM Plex Sans"/>
+              </a:rPr>
+              <a:t>Large carton — ~180 × 110 × 50 mm interior · fits Calm kit (largest single SKU footprint)</a:t>
+            </a:r>
+          </a:p>
+          <a:p>
+            <a:pPr algn="l">
+              <a:lnSpc>
+                <a:spcPct val="132000"/>
+              </a:lnSpc>
+            </a:pPr>
+            <a:r>
+              <a:rPr sz="1050" b="1" i="0">
+                <a:solidFill>
+                  <a:srgbClr val="7A3D14"/>
+                </a:solidFill>
+                <a:latin typeface="IBM Plex Sans"/>
+              </a:rPr>
+              <a:t>•  </a:t>
+            </a:r>
+            <a:r>
+              <a:rPr sz="1050" b="0" i="0">
+                <a:solidFill>
+                  <a:srgbClr val="1A1512"/>
+                </a:solidFill>
+                <a:latin typeface="IBM Plex Sans"/>
+              </a:rPr>
+              <a:t>Style — roll-end tuck-top (RETT) or auto-bottom paperboard mailer · matte uncoated · single-color exterior in amber #7A3D14 on bone #F7F1E6 · interior message in Cormorant Garamond italic</a:t>
+            </a:r>
+          </a:p>
+          <a:p>
+            <a:pPr algn="l">
+              <a:lnSpc>
+                <a:spcPct val="132000"/>
+              </a:lnSpc>
+            </a:pPr>
+            <a:r>
+              <a:rPr sz="1050" b="1" i="0">
+                <a:solidFill>
+                  <a:srgbClr val="7A3D14"/>
+                </a:solidFill>
+                <a:latin typeface="IBM Plex Sans"/>
+              </a:rPr>
+              <a:t>•  </a:t>
+            </a:r>
+            <a:r>
+              <a:rPr sz="1050" b="0" i="0">
+                <a:solidFill>
+                  <a:srgbClr val="1A1512"/>
+                </a:solidFill>
+                <a:latin typeface="IBM Plex Sans"/>
+              </a:rPr>
+              <a:t>MOQ band — 200-400 per carton SKU (so 400-800 cartons total across both die lines for first run)</a:t>
+            </a:r>
+          </a:p>
+          <a:p>
+            <a:pPr algn="l">
+              <a:lnSpc>
+                <a:spcPct val="132000"/>
+              </a:lnSpc>
+            </a:pPr>
+            <a:r>
+              <a:rPr sz="1050" b="1" i="0">
+                <a:solidFill>
+                  <a:srgbClr val="7A3D14"/>
+                </a:solidFill>
+                <a:latin typeface="IBM Plex Sans"/>
+              </a:rPr>
+              <a:t>•  </a:t>
+            </a:r>
+            <a:r>
+              <a:rPr sz="1050" b="0" i="0">
+                <a:solidFill>
+                  <a:srgbClr val="1A1512"/>
+                </a:solidFill>
+                <a:latin typeface="IBM Plex Sans"/>
+              </a:rPr>
+              <a:t>Hard gates — US production · custom interior print · MOQ ≤ 400 per SKU · willing to run two die lines on same project</a:t>
+            </a:r>
+          </a:p>
+        </p:txBody>
+      </p:sp>
+      <p:sp>
+        <p:nvSpPr>
+          <p:cNvPr id="18" name="Rectangle 17"/>
+          <p:cNvSpPr/>
+          <p:nvPr/>
+        </p:nvSpPr>
+        <p:spPr>
+          <a:xfrm>
+            <a:off x="6035040" y="4617720"/>
+            <a:ext cx="5605272" cy="1645920"/>
+          </a:xfrm>
+          <a:prstGeom prst="rect">
+            <a:avLst/>
+          </a:prstGeom>
+          <a:solidFill>
+            <a:srgbClr val="F7F1E6"/>
+          </a:solidFill>
+          <a:ln>
+            <a:noFill/>
+          </a:ln>
+          <a:effectLst/>
+        </p:spPr>
+        <p:style>
+          <a:lnRef idx="1">
+            <a:schemeClr val="accent1"/>
+          </a:lnRef>
+          <a:fillRef idx="3">
+            <a:schemeClr val="accent1"/>
+          </a:fillRef>
+          <a:effectRef idx="2">
+            <a:schemeClr val="accent1"/>
+          </a:effectRef>
+          <a:fontRef idx="minor">
+            <a:schemeClr val="lt1"/>
+          </a:fontRef>
+        </p:style>
+        <p:txBody>
+          <a:bodyPr rtlCol="0" anchor="ctr"/>
+          <a:lstStyle/>
+          <a:p>
+            <a:pPr algn="ctr"/>
+            <a:endParaRPr/>
+          </a:p>
+        </p:txBody>
+      </p:sp>
+      <p:sp>
+        <p:nvSpPr>
+          <p:cNvPr id="19" name="TextBox 18"/>
+          <p:cNvSpPr txBox="1"/>
+          <p:nvPr/>
+        </p:nvSpPr>
+        <p:spPr>
+          <a:xfrm>
+            <a:off x="6263640" y="4754880"/>
+            <a:ext cx="5212080" cy="365760"/>
+          </a:xfrm>
+          <a:prstGeom prst="rect">
+            <a:avLst/>
+          </a:prstGeom>
+          <a:noFill/>
+        </p:spPr>
+        <p:txBody>
+          <a:bodyPr wrap="square" lIns="0" rIns="0" tIns="0" bIns="0" anchor="t">
+            <a:spAutoFit/>
+          </a:bodyPr>
+          <a:lstStyle/>
+          <a:p>
+            <a:pPr algn="l">
+              <a:lnSpc>
+                <a:spcPct val="118000"/>
+              </a:lnSpc>
+            </a:pPr>
+            <a:r>
+              <a:rPr sz="850" b="1" i="0">
+                <a:solidFill>
+                  <a:srgbClr val="7A3D14"/>
+                </a:solidFill>
+                <a:latin typeface="IBM Plex Sans"/>
+              </a:rPr>
+              <a:t>SCORING RUBRIC (0-100)</a:t>
+            </a:r>
+          </a:p>
+        </p:txBody>
+      </p:sp>
+      <p:cxnSp>
+        <p:nvCxnSpPr>
+          <p:cNvPr id="20" name="Connector 19"/>
+          <p:cNvCxnSpPr/>
+          <p:nvPr/>
+        </p:nvCxnSpPr>
+        <p:spPr>
+          <a:xfrm>
+            <a:off x="6263640" y="5047488"/>
+            <a:ext cx="5212080" cy="0"/>
+          </a:xfrm>
+          <a:prstGeom prst="line">
+            <a:avLst/>
+          </a:prstGeom>
+          <a:ln w="6350">
+            <a:solidFill>
+              <a:srgbClr val="D9CFBD"/>
+            </a:solidFill>
+          </a:ln>
+        </p:spPr>
+        <p:style>
+          <a:lnRef idx="2">
+            <a:schemeClr val="accent1"/>
+          </a:lnRef>
+          <a:fillRef idx="0">
+            <a:schemeClr val="accent1"/>
+          </a:fillRef>
+          <a:effectRef idx="1">
+            <a:schemeClr val="accent1"/>
+          </a:effectRef>
+          <a:fontRef idx="minor">
+            <a:schemeClr val="tx1"/>
+          </a:fontRef>
+        </p:style>
+      </p:cxnSp>
+      <p:sp>
+        <p:nvSpPr>
+          <p:cNvPr id="21" name="TextBox 20"/>
+          <p:cNvSpPr txBox="1"/>
+          <p:nvPr/>
+        </p:nvSpPr>
+        <p:spPr>
+          <a:xfrm>
+            <a:off x="6263640" y="5120640"/>
+            <a:ext cx="5212080" cy="1143000"/>
+          </a:xfrm>
+          <a:prstGeom prst="rect">
+            <a:avLst/>
+          </a:prstGeom>
+          <a:noFill/>
+        </p:spPr>
+        <p:txBody>
+          <a:bodyPr wrap="square" lIns="0" rIns="0" tIns="0" bIns="0" anchor="t">
+            <a:spAutoFit/>
+          </a:bodyPr>
+          <a:lstStyle/>
+          <a:p>
+            <a:pPr algn="l">
+              <a:lnSpc>
+                <a:spcPct val="130000"/>
+              </a:lnSpc>
+            </a:pPr>
+            <a:r>
+              <a:rPr sz="900" b="1" i="0">
+                <a:solidFill>
+                  <a:srgbClr val="7A3D14"/>
+                </a:solidFill>
+                <a:latin typeface="IBM Plex Sans"/>
+              </a:rPr>
+              <a:t>•  </a:t>
+            </a:r>
+            <a:r>
+              <a:rPr sz="900" b="0" i="0">
+                <a:solidFill>
+                  <a:srgbClr val="1A1512"/>
+                </a:solidFill>
+                <a:latin typeface="IBM Plex Sans"/>
+              </a:rPr>
+              <a:t>30% Customization fidelity — exterior + interior print, matte uncoated, finishes (foil/deboss optional) — Musely-quality reference match</a:t>
+            </a:r>
+          </a:p>
+          <a:p>
+            <a:pPr algn="l">
+              <a:lnSpc>
+                <a:spcPct val="130000"/>
+              </a:lnSpc>
+            </a:pPr>
+            <a:r>
+              <a:rPr sz="900" b="1" i="0">
+                <a:solidFill>
+                  <a:srgbClr val="7A3D14"/>
+                </a:solidFill>
+                <a:latin typeface="IBM Plex Sans"/>
+              </a:rPr>
+              <a:t>•  </a:t>
+            </a:r>
+            <a:r>
+              <a:rPr sz="900" b="0" i="0">
+                <a:solidFill>
+                  <a:srgbClr val="1A1512"/>
+                </a:solidFill>
+                <a:latin typeface="IBM Plex Sans"/>
+              </a:rPr>
+              <a:t>25% MOQ fit at 200-400 per SKU</a:t>
+            </a:r>
+          </a:p>
+          <a:p>
+            <a:pPr algn="l">
+              <a:lnSpc>
+                <a:spcPct val="130000"/>
+              </a:lnSpc>
+            </a:pPr>
+            <a:r>
+              <a:rPr sz="900" b="1" i="0">
+                <a:solidFill>
+                  <a:srgbClr val="7A3D14"/>
+                </a:solidFill>
+                <a:latin typeface="IBM Plex Sans"/>
+              </a:rPr>
+              <a:t>•  </a:t>
+            </a:r>
+            <a:r>
+              <a:rPr sz="900" b="0" i="0">
+                <a:solidFill>
+                  <a:srgbClr val="1A1512"/>
+                </a:solidFill>
+                <a:latin typeface="IBM Plex Sans"/>
+              </a:rPr>
+              <a:t>20% Lead time + reliability — sub-4-week production ideal</a:t>
+            </a:r>
+          </a:p>
+          <a:p>
+            <a:pPr algn="l">
+              <a:lnSpc>
+                <a:spcPct val="130000"/>
+              </a:lnSpc>
+            </a:pPr>
+            <a:r>
+              <a:rPr sz="900" b="1" i="0">
+                <a:solidFill>
+                  <a:srgbClr val="7A3D14"/>
+                </a:solidFill>
+                <a:latin typeface="IBM Plex Sans"/>
+              </a:rPr>
+              <a:t>•  </a:t>
+            </a:r>
+            <a:r>
+              <a:rPr sz="900" b="0" i="0">
+                <a:solidFill>
+                  <a:srgbClr val="1A1512"/>
+                </a:solidFill>
+                <a:latin typeface="IBM Plex Sans"/>
+              </a:rPr>
+              <a:t>15% Cost at MOQ — combined small + large at 300/300</a:t>
+            </a:r>
+          </a:p>
+          <a:p>
+            <a:pPr algn="l">
+              <a:lnSpc>
+                <a:spcPct val="130000"/>
+              </a:lnSpc>
+            </a:pPr>
+            <a:r>
+              <a:rPr sz="900" b="1" i="0">
+                <a:solidFill>
+                  <a:srgbClr val="7A3D14"/>
+                </a:solidFill>
+                <a:latin typeface="IBM Plex Sans"/>
+              </a:rPr>
+              <a:t>•  </a:t>
+            </a:r>
+            <a:r>
+              <a:rPr sz="900" b="0" i="0">
+                <a:solidFill>
+                  <a:srgbClr val="1A1512"/>
+                </a:solidFill>
+                <a:latin typeface="IBM Plex Sans"/>
+              </a:rPr>
+              <a:t>10% Sustainability + brand fit — FSC / recycled paperboard preferred (not gated)</a:t>
+            </a:r>
+          </a:p>
+        </p:txBody>
+      </p:sp>
+      <p:cxnSp>
+        <p:nvCxnSpPr>
+          <p:cNvPr id="22" name="Connector 21"/>
+          <p:cNvCxnSpPr/>
+          <p:nvPr/>
+        </p:nvCxnSpPr>
+        <p:spPr>
+          <a:xfrm>
+            <a:off x="548640" y="6446520"/>
+            <a:ext cx="11091672" cy="0"/>
+          </a:xfrm>
+          <a:prstGeom prst="line">
+            <a:avLst/>
+          </a:prstGeom>
+          <a:ln w="9525">
+            <a:solidFill>
+              <a:srgbClr val="D9CFBD"/>
+            </a:solidFill>
+          </a:ln>
+        </p:spPr>
+        <p:style>
+          <a:lnRef idx="2">
+            <a:schemeClr val="accent1"/>
+          </a:lnRef>
+          <a:fillRef idx="0">
+            <a:schemeClr val="accent1"/>
+          </a:fillRef>
+          <a:effectRef idx="1">
+            <a:schemeClr val="accent1"/>
+          </a:effectRef>
+          <a:fontRef idx="minor">
+            <a:schemeClr val="tx1"/>
+          </a:fontRef>
+        </p:style>
+      </p:cxnSp>
+      <p:sp>
+        <p:nvSpPr>
+          <p:cNvPr id="23" name="TextBox 22"/>
+          <p:cNvSpPr txBox="1"/>
+          <p:nvPr/>
+        </p:nvSpPr>
+        <p:spPr>
+          <a:xfrm>
+            <a:off x="548640" y="6519672"/>
+            <a:ext cx="7315200" cy="274320"/>
+          </a:xfrm>
+          <a:prstGeom prst="rect">
+            <a:avLst/>
+          </a:prstGeom>
+          <a:noFill/>
+        </p:spPr>
+        <p:txBody>
+          <a:bodyPr wrap="square" lIns="0" rIns="0" tIns="0" bIns="0" anchor="t">
+            <a:spAutoFit/>
+          </a:bodyPr>
+          <a:lstStyle/>
+          <a:p>
+            <a:pPr algn="l">
+              <a:lnSpc>
+                <a:spcPct val="118000"/>
+              </a:lnSpc>
+            </a:pPr>
+            <a:r>
+              <a:rPr sz="800" b="0" i="0">
+                <a:solidFill>
+                  <a:srgbClr val="6B5D4C"/>
+                </a:solidFill>
+                <a:latin typeface="IBM Plex Sans"/>
+              </a:rPr>
+              <a:t>Aplomb — Supplier shortlist for MVP market test · For Zachary Poll · Confidential</a:t>
+            </a:r>
+          </a:p>
+        </p:txBody>
+      </p:sp>
+      <p:sp>
+        <p:nvSpPr>
+          <p:cNvPr id="24" name="TextBox 23"/>
+          <p:cNvSpPr txBox="1"/>
+          <p:nvPr/>
+        </p:nvSpPr>
+        <p:spPr>
+          <a:xfrm>
+            <a:off x="10332720" y="6519672"/>
+            <a:ext cx="1371600" cy="274320"/>
+          </a:xfrm>
+          <a:prstGeom prst="rect">
+            <a:avLst/>
+          </a:prstGeom>
+          <a:noFill/>
+        </p:spPr>
+        <p:txBody>
+          <a:bodyPr wrap="square" lIns="0" rIns="0" tIns="0" bIns="0" anchor="t">
+            <a:spAutoFit/>
+          </a:bodyPr>
+          <a:lstStyle/>
+          <a:p>
+            <a:pPr algn="r">
+              <a:lnSpc>
+                <a:spcPct val="118000"/>
+              </a:lnSpc>
+            </a:pPr>
+            <a:r>
+              <a:rPr sz="800" b="0" i="0">
+                <a:solidFill>
+                  <a:srgbClr val="6B5D4C"/>
+                </a:solidFill>
+                <a:latin typeface="IBM Plex Sans"/>
+              </a:rPr>
+              <a:t>13 / 15</a:t>
+            </a:r>
+          </a:p>
+        </p:txBody>
+      </p:sp>
+    </p:spTree>
+  </p:cSld>
+  <p:clrMapOvr>
+    <a:masterClrMapping/>
+  </p:clrMapOvr>
+</p:sld>
+</file>
+
+<file path=ppt/slides/slide14.xml><?xml version="1.0" encoding="utf-8"?>
+<p:sld xmlns:a="http://schemas.openxmlformats.org/drawingml/2006/main" xmlns:p="http://schemas.openxmlformats.org/presentationml/2006/main" xmlns:r="http://schemas.openxmlformats.org/officeDocument/2006/relationships">
+  <p:cSld>
+    <p:spTree>
+      <p:nvGrpSpPr>
+        <p:cNvPr id="1" name=""/>
+        <p:cNvGrpSpPr/>
+        <p:nvPr/>
+      </p:nvGrpSpPr>
+      <p:grpSpPr>
+        <a:xfrm>
+          <a:off x="0" y="0"/>
+          <a:ext cx="0" cy="0"/>
+          <a:chOff x="0" y="0"/>
+          <a:chExt cx="0" cy="0"/>
+        </a:xfrm>
+      </p:grpSpPr>
+      <p:sp>
+        <p:nvSpPr>
+          <p:cNvPr id="2" name="Rectangle 1"/>
+          <p:cNvSpPr/>
+          <p:nvPr/>
+        </p:nvSpPr>
+        <p:spPr>
+          <a:xfrm>
+            <a:off x="0" y="0"/>
+            <a:ext cx="12192000" cy="6858000"/>
+          </a:xfrm>
+          <a:prstGeom prst="rect">
+            <a:avLst/>
+          </a:prstGeom>
+          <a:solidFill>
+            <a:srgbClr val="EFE8DC"/>
+          </a:solidFill>
+          <a:ln>
+            <a:noFill/>
+          </a:ln>
+        </p:spPr>
+        <p:style>
+          <a:lnRef idx="1">
+            <a:schemeClr val="accent1"/>
+          </a:lnRef>
+          <a:fillRef idx="3">
+            <a:schemeClr val="accent1"/>
+          </a:fillRef>
+          <a:effectRef idx="2">
+            <a:schemeClr val="accent1"/>
+          </a:effectRef>
+          <a:fontRef idx="minor">
+            <a:schemeClr val="lt1"/>
+          </a:fontRef>
+        </p:style>
+        <p:txBody>
+          <a:bodyPr rtlCol="0" anchor="ctr"/>
+          <a:lstStyle/>
+          <a:p>
+            <a:pPr algn="ctr"/>
+            <a:endParaRPr/>
+          </a:p>
+        </p:txBody>
+      </p:sp>
+      <p:cxnSp>
+        <p:nvCxnSpPr>
+          <p:cNvPr id="3" name="Connector 2"/>
+          <p:cNvCxnSpPr/>
+          <p:nvPr/>
+        </p:nvCxnSpPr>
+        <p:spPr>
+          <a:xfrm>
+            <a:off x="548640" y="502920"/>
+            <a:ext cx="11091672" cy="0"/>
+          </a:xfrm>
+          <a:prstGeom prst="line">
+            <a:avLst/>
+          </a:prstGeom>
+          <a:ln w="9525">
+            <a:solidFill>
+              <a:srgbClr val="D9CFBD"/>
+            </a:solidFill>
+          </a:ln>
+        </p:spPr>
+        <p:style>
+          <a:lnRef idx="2">
+            <a:schemeClr val="accent1"/>
+          </a:lnRef>
+          <a:fillRef idx="0">
+            <a:schemeClr val="accent1"/>
+          </a:fillRef>
+          <a:effectRef idx="1">
+            <a:schemeClr val="accent1"/>
+          </a:effectRef>
+          <a:fontRef idx="minor">
+            <a:schemeClr val="tx1"/>
+          </a:fontRef>
+        </p:style>
+      </p:cxnSp>
+      <p:sp>
+        <p:nvSpPr>
+          <p:cNvPr id="4" name="TextBox 3"/>
+          <p:cNvSpPr txBox="1"/>
+          <p:nvPr/>
+        </p:nvSpPr>
+        <p:spPr>
+          <a:xfrm>
+            <a:off x="548640" y="164592"/>
+            <a:ext cx="7315200" cy="274320"/>
+          </a:xfrm>
+          <a:prstGeom prst="rect">
+            <a:avLst/>
+          </a:prstGeom>
+          <a:noFill/>
+        </p:spPr>
+        <p:txBody>
+          <a:bodyPr wrap="square" lIns="0" rIns="0" tIns="0" bIns="0" anchor="t">
+            <a:spAutoFit/>
+          </a:bodyPr>
+          <a:lstStyle/>
+          <a:p>
+            <a:pPr algn="l">
+              <a:lnSpc>
+                <a:spcPct val="118000"/>
+              </a:lnSpc>
+            </a:pPr>
+            <a:r>
+              <a:rPr sz="900" b="0" i="0">
+                <a:solidFill>
+                  <a:srgbClr val="7A3D14"/>
+                </a:solidFill>
+                <a:latin typeface="IBM Plex Sans"/>
+              </a:rPr>
+              <a:t>§ 06 · Add-on · Two-SKU folding-mailer system</a:t>
+            </a:r>
+          </a:p>
+        </p:txBody>
+      </p:sp>
+      <p:sp>
+        <p:nvSpPr>
+          <p:cNvPr id="5" name="TextBox 4"/>
+          <p:cNvSpPr txBox="1"/>
+          <p:nvPr/>
+        </p:nvSpPr>
+        <p:spPr>
+          <a:xfrm>
+            <a:off x="10058400" y="164592"/>
+            <a:ext cx="1645920" cy="274320"/>
+          </a:xfrm>
+          <a:prstGeom prst="rect">
+            <a:avLst/>
+          </a:prstGeom>
+          <a:noFill/>
+        </p:spPr>
+        <p:txBody>
+          <a:bodyPr wrap="square" lIns="0" rIns="0" tIns="0" bIns="0" anchor="t">
+            <a:spAutoFit/>
+          </a:bodyPr>
+          <a:lstStyle/>
+          <a:p>
+            <a:pPr algn="r">
+              <a:lnSpc>
+                <a:spcPct val="118000"/>
+              </a:lnSpc>
+            </a:pPr>
+            <a:r>
+              <a:rPr sz="1100" b="0" i="1">
+                <a:solidFill>
+                  <a:srgbClr val="1A1512"/>
+                </a:solidFill>
+                <a:latin typeface="Cormorant Garamond"/>
+              </a:rPr>
+              <a:t>Aplomb</a:t>
+            </a:r>
+            <a:r>
+              <a:rPr sz="1100" b="1" i="1">
+                <a:solidFill>
+                  <a:srgbClr val="7A3D14"/>
+                </a:solidFill>
+                <a:latin typeface="Cormorant Garamond"/>
+              </a:rPr>
+              <a:t>.</a:t>
+            </a:r>
+          </a:p>
+        </p:txBody>
+      </p:sp>
+      <p:sp>
+        <p:nvSpPr>
+          <p:cNvPr id="6" name="TextBox 5"/>
+          <p:cNvSpPr txBox="1"/>
+          <p:nvPr/>
+        </p:nvSpPr>
+        <p:spPr>
+          <a:xfrm>
+            <a:off x="548640" y="777240"/>
+            <a:ext cx="10972800" cy="1097280"/>
+          </a:xfrm>
+          <a:prstGeom prst="rect">
+            <a:avLst/>
+          </a:prstGeom>
+          <a:noFill/>
+        </p:spPr>
+        <p:txBody>
+          <a:bodyPr wrap="square" lIns="0" rIns="0" tIns="0" bIns="0" anchor="t">
+            <a:spAutoFit/>
+          </a:bodyPr>
+          <a:lstStyle/>
+          <a:p>
+            <a:pPr algn="l">
+              <a:lnSpc>
+                <a:spcPct val="105000"/>
+              </a:lnSpc>
+            </a:pPr>
+            <a:r>
+              <a:rPr sz="3000" b="0" i="0">
+                <a:solidFill>
+                  <a:srgbClr val="1A1512"/>
+                </a:solidFill>
+                <a:latin typeface="Cormorant Garamond"/>
+              </a:rPr>
+              <a:t>Outer Packaging — 5 shortlisted suppliers</a:t>
+            </a:r>
+          </a:p>
+        </p:txBody>
+      </p:sp>
+      <p:sp>
+        <p:nvSpPr>
+          <p:cNvPr id="7" name="TextBox 6"/>
+          <p:cNvSpPr txBox="1"/>
+          <p:nvPr/>
+        </p:nvSpPr>
+        <p:spPr>
+          <a:xfrm>
+            <a:off x="548640" y="1508760"/>
+            <a:ext cx="10972800" cy="365760"/>
+          </a:xfrm>
+          <a:prstGeom prst="rect">
+            <a:avLst/>
+          </a:prstGeom>
+          <a:noFill/>
+        </p:spPr>
+        <p:txBody>
+          <a:bodyPr wrap="square" lIns="0" rIns="0" tIns="0" bIns="0" anchor="t">
+            <a:spAutoFit/>
+          </a:bodyPr>
+          <a:lstStyle/>
+          <a:p>
+            <a:pPr algn="l">
+              <a:lnSpc>
+                <a:spcPct val="118000"/>
+              </a:lnSpc>
+            </a:pPr>
+            <a:r>
+              <a:rPr sz="1000" b="0" i="0">
+                <a:solidFill>
+                  <a:srgbClr val="6B5D4C"/>
+                </a:solidFill>
+                <a:latin typeface="IBM Plex Sans"/>
+              </a:rPr>
+              <a:t>US folding-mailer vendors at MOQ 200-400 per SKU. Pricing reflects 300-unit run of EACH die line (small + large) — combined cost of first order.</a:t>
+            </a:r>
+          </a:p>
+        </p:txBody>
+      </p:sp>
+      <p:graphicFrame>
+        <p:nvGraphicFramePr>
+          <p:cNvPr id="8" name="Table 7"/>
+          <p:cNvGraphicFramePr>
+            <a:graphicFrameLocks noGrp="1"/>
+          </p:cNvGraphicFramePr>
+          <p:nvPr/>
+        </p:nvGraphicFramePr>
+        <p:xfrm>
+          <a:off x="548640" y="1965960"/>
+          <a:ext cx="11091667" cy="3931920"/>
+        </p:xfrm>
+        <a:graphic>
+          <a:graphicData uri="http://schemas.openxmlformats.org/drawingml/2006/table">
+            <a:tbl>
+              <a:tblPr firstRow="1" bandRow="1">
+                <a:tableStyleId>{5C22544A-7EE6-4342-B048-85BDC9FD1C3A}</a:tableStyleId>
+              </a:tblPr>
+              <a:tblGrid>
+                <a:gridCol w="1016736"/>
+                <a:gridCol w="1109167"/>
+                <a:gridCol w="1663750"/>
+                <a:gridCol w="1432674"/>
+                <a:gridCol w="508368"/>
+                <a:gridCol w="693229"/>
+                <a:gridCol w="878090"/>
+                <a:gridCol w="600798"/>
+                <a:gridCol w="3188855"/>
+              </a:tblGrid>
+              <a:tr h="655320">
+                <a:tc>
+                  <a:txBody>
+                    <a:bodyPr lIns="45000" rIns="45000" tIns="40000" bIns="40000" wrap="square"/>
+                    <a:lstStyle/>
+                    <a:p>
+                      <a:pPr algn="l">
+                        <a:lnSpc>
+                          <a:spcPct val="112000"/>
+                        </a:lnSpc>
+                      </a:pPr>
+                      <a:r>
+                        <a:rPr sz="850" b="1">
+                          <a:solidFill>
+                            <a:srgbClr val="EFE8DC"/>
+                          </a:solidFill>
+                          <a:latin typeface="IBM Plex Sans"/>
+                        </a:rPr>
+                        <a:t>Company</a:t>
+                      </a:r>
+                    </a:p>
+                  </a:txBody>
+                  <a:tcPr>
+                    <a:solidFill>
+                      <a:srgbClr val="1A1512"/>
+                    </a:solidFill>
+                  </a:tcPr>
+                </a:tc>
+                <a:tc>
+                  <a:txBody>
+                    <a:bodyPr lIns="45000" rIns="45000" tIns="40000" bIns="40000" wrap="square"/>
+                    <a:lstStyle/>
+                    <a:p>
+                      <a:pPr algn="l">
+                        <a:lnSpc>
+                          <a:spcPct val="112000"/>
+                        </a:lnSpc>
+                      </a:pPr>
+                      <a:r>
+                        <a:rPr sz="850" b="1">
+                          <a:solidFill>
+                            <a:srgbClr val="EFE8DC"/>
+                          </a:solidFill>
+                          <a:latin typeface="IBM Plex Sans"/>
+                        </a:rPr>
+                        <a:t>Website</a:t>
+                      </a:r>
+                    </a:p>
+                  </a:txBody>
+                  <a:tcPr>
+                    <a:solidFill>
+                      <a:srgbClr val="1A1512"/>
+                    </a:solidFill>
+                  </a:tcPr>
+                </a:tc>
+                <a:tc>
+                  <a:txBody>
+                    <a:bodyPr lIns="45000" rIns="45000" tIns="40000" bIns="40000" wrap="square"/>
+                    <a:lstStyle/>
+                    <a:p>
+                      <a:pPr algn="l">
+                        <a:lnSpc>
+                          <a:spcPct val="112000"/>
+                        </a:lnSpc>
+                      </a:pPr>
+                      <a:r>
+                        <a:rPr sz="850" b="1">
+                          <a:solidFill>
+                            <a:srgbClr val="EFE8DC"/>
+                          </a:solidFill>
+                          <a:latin typeface="IBM Plex Sans"/>
+                        </a:rPr>
+                        <a:t>Product</a:t>
+                      </a:r>
+                    </a:p>
+                  </a:txBody>
+                  <a:tcPr>
+                    <a:solidFill>
+                      <a:srgbClr val="1A1512"/>
+                    </a:solidFill>
+                  </a:tcPr>
+                </a:tc>
+                <a:tc>
+                  <a:txBody>
+                    <a:bodyPr lIns="45000" rIns="45000" tIns="40000" bIns="40000" wrap="square"/>
+                    <a:lstStyle/>
+                    <a:p>
+                      <a:pPr algn="l">
+                        <a:lnSpc>
+                          <a:spcPct val="112000"/>
+                        </a:lnSpc>
+                      </a:pPr>
+                      <a:r>
+                        <a:rPr sz="850" b="1">
+                          <a:solidFill>
+                            <a:srgbClr val="EFE8DC"/>
+                          </a:solidFill>
+                          <a:latin typeface="IBM Plex Sans"/>
+                        </a:rPr>
+                        <a:t>Product page</a:t>
+                      </a:r>
+                    </a:p>
+                  </a:txBody>
+                  <a:tcPr>
+                    <a:solidFill>
+                      <a:srgbClr val="1A1512"/>
+                    </a:solidFill>
+                  </a:tcPr>
+                </a:tc>
+                <a:tc>
+                  <a:txBody>
+                    <a:bodyPr lIns="45000" rIns="45000" tIns="40000" bIns="40000" wrap="square"/>
+                    <a:lstStyle/>
+                    <a:p>
+                      <a:pPr algn="l">
+                        <a:lnSpc>
+                          <a:spcPct val="112000"/>
+                        </a:lnSpc>
+                      </a:pPr>
+                      <a:r>
+                        <a:rPr sz="850" b="1">
+                          <a:solidFill>
+                            <a:srgbClr val="EFE8DC"/>
+                          </a:solidFill>
+                          <a:latin typeface="IBM Plex Sans"/>
+                        </a:rPr>
+                        <a:t>MOQ</a:t>
+                      </a:r>
+                    </a:p>
+                  </a:txBody>
+                  <a:tcPr>
+                    <a:solidFill>
+                      <a:srgbClr val="1A1512"/>
+                    </a:solidFill>
+                  </a:tcPr>
+                </a:tc>
+                <a:tc>
+                  <a:txBody>
+                    <a:bodyPr lIns="45000" rIns="45000" tIns="40000" bIns="40000" wrap="square"/>
+                    <a:lstStyle/>
+                    <a:p>
+                      <a:pPr algn="l">
+                        <a:lnSpc>
+                          <a:spcPct val="112000"/>
+                        </a:lnSpc>
+                      </a:pPr>
+                      <a:r>
+                        <a:rPr sz="850" b="1">
+                          <a:solidFill>
+                            <a:srgbClr val="EFE8DC"/>
+                          </a:solidFill>
+                          <a:latin typeface="IBM Plex Sans"/>
+                        </a:rPr>
+                        <a:t>$/unit</a:t>
+                      </a:r>
+                    </a:p>
+                  </a:txBody>
+                  <a:tcPr>
+                    <a:solidFill>
+                      <a:srgbClr val="1A1512"/>
+                    </a:solidFill>
+                  </a:tcPr>
+                </a:tc>
+                <a:tc>
+                  <a:txBody>
+                    <a:bodyPr lIns="45000" rIns="45000" tIns="40000" bIns="40000" wrap="square"/>
+                    <a:lstStyle/>
+                    <a:p>
+                      <a:pPr algn="l">
+                        <a:lnSpc>
+                          <a:spcPct val="112000"/>
+                        </a:lnSpc>
+                      </a:pPr>
+                      <a:r>
+                        <a:rPr sz="850" b="1">
+                          <a:solidFill>
+                            <a:srgbClr val="EFE8DC"/>
+                          </a:solidFill>
+                          <a:latin typeface="IBM Plex Sans"/>
+                        </a:rPr>
+                        <a:t>Total MOQ$</a:t>
+                      </a:r>
+                    </a:p>
+                  </a:txBody>
+                  <a:tcPr>
+                    <a:solidFill>
+                      <a:srgbClr val="1A1512"/>
+                    </a:solidFill>
+                  </a:tcPr>
+                </a:tc>
+                <a:tc>
+                  <a:txBody>
+                    <a:bodyPr lIns="45000" rIns="45000" tIns="40000" bIns="40000" wrap="square"/>
+                    <a:lstStyle/>
+                    <a:p>
+                      <a:pPr algn="l">
+                        <a:lnSpc>
+                          <a:spcPct val="112000"/>
+                        </a:lnSpc>
+                      </a:pPr>
+                      <a:r>
+                        <a:rPr sz="850" b="1">
+                          <a:solidFill>
+                            <a:srgbClr val="EFE8DC"/>
+                          </a:solidFill>
+                          <a:latin typeface="IBM Plex Sans"/>
+                        </a:rPr>
+                        <a:t>Score</a:t>
+                      </a:r>
+                    </a:p>
+                  </a:txBody>
+                  <a:tcPr>
+                    <a:solidFill>
+                      <a:srgbClr val="1A1512"/>
+                    </a:solidFill>
+                  </a:tcPr>
+                </a:tc>
+                <a:tc>
+                  <a:txBody>
+                    <a:bodyPr lIns="45000" rIns="45000" tIns="40000" bIns="40000" wrap="square"/>
+                    <a:lstStyle/>
+                    <a:p>
+                      <a:pPr algn="l">
+                        <a:lnSpc>
+                          <a:spcPct val="112000"/>
+                        </a:lnSpc>
+                      </a:pPr>
+                      <a:r>
+                        <a:rPr sz="850" b="1">
+                          <a:solidFill>
+                            <a:srgbClr val="EFE8DC"/>
+                          </a:solidFill>
+                          <a:latin typeface="IBM Plex Sans"/>
+                        </a:rPr>
+                        <a:t>Notes</a:t>
+                      </a:r>
+                    </a:p>
+                  </a:txBody>
+                  <a:tcPr>
+                    <a:solidFill>
+                      <a:srgbClr val="1A1512"/>
+                    </a:solidFill>
+                  </a:tcPr>
+                </a:tc>
+              </a:tr>
+              <a:tr h="655320">
                 <a:tc>
                   <a:txBody>
                     <a:bodyPr lIns="45000" rIns="45000" tIns="40000" bIns="40000" wrap="square"/>
@@ -6933,7 +8845,254 @@
                           </a:solidFill>
                           <a:latin typeface="IBM Plex Sans"/>
                         </a:rPr>
-                        <a:t>Nutribl</a:t>
+                        <a:t>Arka (Packlane)</a:t>
+                      </a:r>
+                    </a:p>
+                  </a:txBody>
+                  <a:tcPr>
+                    <a:solidFill>
+                      <a:srgbClr val="EFE8DC"/>
+                    </a:solidFill>
+                  </a:tcPr>
+                </a:tc>
+                <a:tc>
+                  <a:txBody>
+                    <a:bodyPr lIns="45000" rIns="45000" tIns="40000" bIns="40000" wrap="square"/>
+                    <a:lstStyle/>
+                    <a:p>
+                      <a:pPr algn="l">
+                        <a:lnSpc>
+                          <a:spcPct val="112000"/>
+                        </a:lnSpc>
+                      </a:pPr>
+                      <a:r>
+                        <a:rPr sz="800" b="0" u="sng">
+                          <a:solidFill>
+                            <a:srgbClr val="7A3D14"/>
+                          </a:solidFill>
+                          <a:latin typeface="IBM Plex Sans"/>
+                          <a:hlinkClick r:id="rId2"/>
+                        </a:rPr>
+                        <a:t>packlane.com</a:t>
+                      </a:r>
+                    </a:p>
+                  </a:txBody>
+                  <a:tcPr>
+                    <a:solidFill>
+                      <a:srgbClr val="EFE8DC"/>
+                    </a:solidFill>
+                  </a:tcPr>
+                </a:tc>
+                <a:tc>
+                  <a:txBody>
+                    <a:bodyPr lIns="45000" rIns="45000" tIns="40000" bIns="40000" wrap="square"/>
+                    <a:lstStyle/>
+                    <a:p>
+                      <a:pPr algn="l">
+                        <a:lnSpc>
+                          <a:spcPct val="112000"/>
+                        </a:lnSpc>
+                      </a:pPr>
+                      <a:r>
+                        <a:rPr sz="750" b="0">
+                          <a:solidFill>
+                            <a:srgbClr val="1A1512"/>
+                          </a:solidFill>
+                          <a:latin typeface="IBM Plex Sans"/>
+                        </a:rPr>
+                        <a:t>Custom paperboard mailer · full-color in/out · matte / satin / Dreamcoat finishes · custom dies</a:t>
+                      </a:r>
+                    </a:p>
+                  </a:txBody>
+                  <a:tcPr>
+                    <a:solidFill>
+                      <a:srgbClr val="EFE8DC"/>
+                    </a:solidFill>
+                  </a:tcPr>
+                </a:tc>
+                <a:tc>
+                  <a:txBody>
+                    <a:bodyPr lIns="45000" rIns="45000" tIns="40000" bIns="40000" wrap="square"/>
+                    <a:lstStyle/>
+                    <a:p>
+                      <a:pPr algn="l">
+                        <a:lnSpc>
+                          <a:spcPct val="112000"/>
+                        </a:lnSpc>
+                      </a:pPr>
+                      <a:r>
+                        <a:rPr sz="800" b="0" u="sng">
+                          <a:solidFill>
+                            <a:srgbClr val="7A3D14"/>
+                          </a:solidFill>
+                          <a:latin typeface="IBM Plex Sans"/>
+                          <a:hlinkClick r:id="rId3"/>
+                        </a:rPr>
+                        <a:t>Mailer Box (custom)</a:t>
+                      </a:r>
+                    </a:p>
+                  </a:txBody>
+                  <a:tcPr>
+                    <a:solidFill>
+                      <a:srgbClr val="EFE8DC"/>
+                    </a:solidFill>
+                  </a:tcPr>
+                </a:tc>
+                <a:tc>
+                  <a:txBody>
+                    <a:bodyPr lIns="45000" rIns="45000" tIns="40000" bIns="40000" wrap="square"/>
+                    <a:lstStyle/>
+                    <a:p>
+                      <a:pPr algn="ctr">
+                        <a:lnSpc>
+                          <a:spcPct val="112000"/>
+                        </a:lnSpc>
+                      </a:pPr>
+                      <a:r>
+                        <a:rPr sz="850" b="0">
+                          <a:solidFill>
+                            <a:srgbClr val="1A1512"/>
+                          </a:solidFill>
+                          <a:latin typeface="IBM Plex Sans"/>
+                        </a:rPr>
+                        <a:t>200</a:t>
+                      </a:r>
+                    </a:p>
+                  </a:txBody>
+                  <a:tcPr>
+                    <a:solidFill>
+                      <a:srgbClr val="EFE8DC"/>
+                    </a:solidFill>
+                  </a:tcPr>
+                </a:tc>
+                <a:tc>
+                  <a:txBody>
+                    <a:bodyPr lIns="45000" rIns="45000" tIns="40000" bIns="40000" wrap="square"/>
+                    <a:lstStyle/>
+                    <a:p>
+                      <a:pPr algn="r">
+                        <a:lnSpc>
+                          <a:spcPct val="112000"/>
+                        </a:lnSpc>
+                      </a:pPr>
+                      <a:r>
+                        <a:rPr sz="850" b="0">
+                          <a:solidFill>
+                            <a:srgbClr val="1A1512"/>
+                          </a:solidFill>
+                          <a:latin typeface="IBM Plex Sans"/>
+                        </a:rPr>
+                        <a:t>$3.40</a:t>
+                      </a:r>
+                    </a:p>
+                  </a:txBody>
+                  <a:tcPr>
+                    <a:solidFill>
+                      <a:srgbClr val="EFE8DC"/>
+                    </a:solidFill>
+                  </a:tcPr>
+                </a:tc>
+                <a:tc>
+                  <a:txBody>
+                    <a:bodyPr lIns="45000" rIns="45000" tIns="40000" bIns="40000" wrap="square"/>
+                    <a:lstStyle/>
+                    <a:p>
+                      <a:pPr algn="r">
+                        <a:lnSpc>
+                          <a:spcPct val="112000"/>
+                        </a:lnSpc>
+                      </a:pPr>
+                      <a:r>
+                        <a:rPr sz="850" b="0">
+                          <a:solidFill>
+                            <a:srgbClr val="1A1512"/>
+                          </a:solidFill>
+                          <a:latin typeface="IBM Plex Sans"/>
+                        </a:rPr>
+                        <a:t>$2,040</a:t>
+                      </a:r>
+                    </a:p>
+                  </a:txBody>
+                  <a:tcPr>
+                    <a:solidFill>
+                      <a:srgbClr val="EFE8DC"/>
+                    </a:solidFill>
+                  </a:tcPr>
+                </a:tc>
+                <a:tc>
+                  <a:txBody>
+                    <a:bodyPr lIns="45000" rIns="45000" tIns="40000" bIns="40000" wrap="square"/>
+                    <a:lstStyle/>
+                    <a:p>
+                      <a:pPr algn="ctr">
+                        <a:lnSpc>
+                          <a:spcPct val="112000"/>
+                        </a:lnSpc>
+                      </a:pPr>
+                      <a:r>
+                        <a:rPr sz="1000" b="1">
+                          <a:solidFill>
+                            <a:srgbClr val="1A1512"/>
+                          </a:solidFill>
+                          <a:latin typeface="IBM Plex Sans"/>
+                        </a:rPr>
+                        <a:t>88</a:t>
+                      </a:r>
+                    </a:p>
+                  </a:txBody>
+                  <a:tcPr>
+                    <a:solidFill>
+                      <a:srgbClr val="E6C99C"/>
+                    </a:solidFill>
+                  </a:tcPr>
+                </a:tc>
+                <a:tc>
+                  <a:txBody>
+                    <a:bodyPr lIns="45000" rIns="45000" tIns="40000" bIns="40000" wrap="square"/>
+                    <a:lstStyle/>
+                    <a:p>
+                      <a:pPr algn="l">
+                        <a:lnSpc>
+                          <a:spcPct val="112000"/>
+                        </a:lnSpc>
+                      </a:pPr>
+                      <a:r>
+                        <a:rPr sz="750" b="0">
+                          <a:solidFill>
+                            <a:srgbClr val="1A1512"/>
+                          </a:solidFill>
+                          <a:latin typeface="IBM Plex Sans"/>
+                        </a:rPr>
+                        <a:t>San Francisco · MOQ 1+ (so 200/400 trivial) · 100% US-made · ~10-day standard lead, 7-day rush · instant online proof · Shopify/WMS integration. Combined cost = 300 small + 300 large @ ~$3.40 weighted avg. RECOMMENDED lead — fastest path to Musely-style sample.</a:t>
+                      </a:r>
+                    </a:p>
+                  </a:txBody>
+                  <a:tcPr>
+                    <a:solidFill>
+                      <a:srgbClr val="EFE8DC"/>
+                    </a:solidFill>
+                  </a:tcPr>
+                </a:tc>
+              </a:tr>
+              <a:tr h="655320">
+                <a:tc>
+                  <a:txBody>
+                    <a:bodyPr lIns="45000" rIns="45000" tIns="40000" bIns="40000" wrap="square"/>
+                    <a:lstStyle/>
+                    <a:p>
+                      <a:pPr algn="l">
+                        <a:lnSpc>
+                          <a:spcPct val="112000"/>
+                        </a:lnSpc>
+                      </a:pPr>
+                      <a:r>
+                        <a:rPr sz="850" b="1">
+                          <a:solidFill>
+                            <a:srgbClr val="1A1512"/>
+                          </a:solidFill>
+                          <a:latin typeface="IBM Plex Sans"/>
+                        </a:rPr>
+                        <a:t>EcoEnclose</a:t>
                       </a:r>
                     </a:p>
                   </a:txBody>
@@ -6961,7 +9120,7 @@
                           <a:latin typeface="IBM Plex Sans"/>
                           <a:hlinkClick r:id="rId4"/>
                         </a:rPr>
-                        <a:t>nutribl.com</a:t>
+                        <a:t>ecoenclose.com</a:t>
                       </a:r>
                     </a:p>
                   </a:txBody>
@@ -6988,7 +9147,7 @@
                           </a:solidFill>
                           <a:latin typeface="IBM Plex Sans"/>
                         </a:rPr>
-                        <a:t>Stock multivitamin capsule (120+ blends with B-complex, Mg, D3); private label</a:t>
+                        <a:t>Custom shipping box · 100% recycled FSC kraft (95% post-consumer) · multi-panel interior print up to 2 colors</a:t>
                       </a:r>
                     </a:p>
                   </a:txBody>
@@ -7016,7 +9175,7 @@
                           <a:latin typeface="IBM Plex Sans"/>
                           <a:hlinkClick r:id="rId5"/>
                         </a:rPr>
-                        <a:t>Vitamin B-Complex Daily 120ct</a:t>
+                        <a:t>Custom Shipping Box</a:t>
                       </a:r>
                     </a:p>
                   </a:txBody>
@@ -7043,7 +9202,7 @@
                           </a:solidFill>
                           <a:latin typeface="IBM Plex Sans"/>
                         </a:rPr>
-                        <a:t>10</a:t>
+                        <a:t>100</a:t>
                       </a:r>
                     </a:p>
                   </a:txBody>
@@ -7070,7 +9229,7 @@
                           </a:solidFill>
                           <a:latin typeface="IBM Plex Sans"/>
                         </a:rPr>
-                        <a:t>$3.50</a:t>
+                        <a:t>$3.85</a:t>
                       </a:r>
                     </a:p>
                   </a:txBody>
@@ -7097,7 +9256,7 @@
                           </a:solidFill>
                           <a:latin typeface="IBM Plex Sans"/>
                         </a:rPr>
-                        <a:t>$35</a:t>
+                        <a:t>$2,310</a:t>
                       </a:r>
                     </a:p>
                   </a:txBody>
@@ -7124,13 +9283,13 @@
                           </a:solidFill>
                           <a:latin typeface="IBM Plex Sans"/>
                         </a:rPr>
-                        <a:t>64</a:t>
+                        <a:t>81</a:t>
                       </a:r>
                     </a:p>
                   </a:txBody>
                   <a:tcPr>
                     <a:solidFill>
-                      <a:srgbClr val="F7F1E6"/>
+                      <a:srgbClr val="E6C99C"/>
                     </a:solidFill>
                   </a:tcPr>
                 </a:tc>
@@ -7151,7 +9310,7 @@
                           </a:solidFill>
                           <a:latin typeface="IBM Plex Sans"/>
                         </a:rPr>
-                        <a:t>Lowest MOQ in market (10 units, stock formulas). UK-based; pricing behind login. Custom blends jump to £4-10K formulation cost. Stock blend works for MVP test.</a:t>
+                        <a:t>Colorado · 100% recycled · FSC SCS-COC-009926 · HydroSoy/Black-Algae inks (no plastic lamination) · made in USA. Best sustainability story; kraft-only exterior reads less Musely-velvet, more clinical/honest.</a:t>
                       </a:r>
                     </a:p>
                   </a:txBody>
@@ -7162,7 +9321,7 @@
                   </a:tcPr>
                 </a:tc>
               </a:tr>
-              <a:tr h="800100">
+              <a:tr h="655320">
                 <a:tc>
                   <a:txBody>
                     <a:bodyPr lIns="45000" rIns="45000" tIns="40000" bIns="40000" wrap="square"/>
@@ -7180,7 +9339,7 @@
                           </a:solidFill>
                           <a:latin typeface="IBM Plex Sans"/>
                         </a:rPr>
-                        <a:t>Custom Nutra</a:t>
+                        <a:t>Refine Packaging</a:t>
                       </a:r>
                     </a:p>
                   </a:txBody>
@@ -7208,7 +9367,7 @@
                           <a:latin typeface="IBM Plex Sans"/>
                           <a:hlinkClick r:id="rId6"/>
                         </a:rPr>
-                        <a:t>customnutra.com</a:t>
+                        <a:t>refinepackaging.com</a:t>
                       </a:r>
                     </a:p>
                   </a:txBody>
@@ -7235,7 +9394,7 @@
                           </a:solidFill>
                           <a:latin typeface="IBM Plex Sans"/>
                         </a:rPr>
-                        <a:t>Multivitamin capsule (250+ stock blends incl. B-complex + Mg + electrolytes)</a:t>
+                        <a:t>Custom mailer box · 10-28pt board (kraft / cardstock / e-flute corrugated) · gloss / matte / spot UV finishes · interior + exterior print</a:t>
                       </a:r>
                     </a:p>
                   </a:txBody>
@@ -7263,7 +9422,7 @@
                           <a:latin typeface="IBM Plex Sans"/>
                           <a:hlinkClick r:id="rId7"/>
                         </a:rPr>
-                        <a:t>Multivitamins PL Catalog</a:t>
+                        <a:t>Custom Mailer Box</a:t>
                       </a:r>
                     </a:p>
                   </a:txBody>
@@ -7290,7 +9449,7 @@
                           </a:solidFill>
                           <a:latin typeface="IBM Plex Sans"/>
                         </a:rPr>
-                        <a:t>48</a:t>
+                        <a:t>100</a:t>
                       </a:r>
                     </a:p>
                   </a:txBody>
@@ -7317,7 +9476,7 @@
                           </a:solidFill>
                           <a:latin typeface="IBM Plex Sans"/>
                         </a:rPr>
-                        <a:t>$2.25</a:t>
+                        <a:t>$3.20</a:t>
                       </a:r>
                     </a:p>
                   </a:txBody>
@@ -7344,7 +9503,7 @@
                           </a:solidFill>
                           <a:latin typeface="IBM Plex Sans"/>
                         </a:rPr>
-                        <a:t>$108</a:t>
+                        <a:t>$1,920</a:t>
                       </a:r>
                     </a:p>
                   </a:txBody>
@@ -7371,7 +9530,91 @@
                           </a:solidFill>
                           <a:latin typeface="IBM Plex Sans"/>
                         </a:rPr>
-                        <a:t>62</a:t>
+                        <a:t>80</a:t>
+                      </a:r>
+                    </a:p>
+                  </a:txBody>
+                  <a:tcPr>
+                    <a:solidFill>
+                      <a:srgbClr val="E6C99C"/>
+                    </a:solidFill>
+                  </a:tcPr>
+                </a:tc>
+                <a:tc>
+                  <a:txBody>
+                    <a:bodyPr lIns="45000" rIns="45000" tIns="40000" bIns="40000" wrap="square"/>
+                    <a:lstStyle/>
+                    <a:p>
+                      <a:pPr algn="l">
+                        <a:lnSpc>
+                          <a:spcPct val="112000"/>
+                        </a:lnSpc>
+                      </a:pPr>
+                      <a:r>
+                        <a:rPr sz="750" b="0">
+                          <a:solidFill>
+                            <a:srgbClr val="1A1512"/>
+                          </a:solidFill>
+                          <a:latin typeface="IBM Plex Sans"/>
+                        </a:rPr>
+                        <a:t>US-based · MOQ 100 · ~$2-5/unit at 100-500 · 8-10 day standard, 4-6 day rush · free US shipping · pre-production mockup included. Best $/unit at MOQ 200-400.</a:t>
+                      </a:r>
+                    </a:p>
+                  </a:txBody>
+                  <a:tcPr>
+                    <a:solidFill>
+                      <a:srgbClr val="EFE8DC"/>
+                    </a:solidFill>
+                  </a:tcPr>
+                </a:tc>
+              </a:tr>
+              <a:tr h="655320">
+                <a:tc>
+                  <a:txBody>
+                    <a:bodyPr lIns="45000" rIns="45000" tIns="40000" bIns="40000" wrap="square"/>
+                    <a:lstStyle/>
+                    <a:p>
+                      <a:pPr algn="l">
+                        <a:lnSpc>
+                          <a:spcPct val="112000"/>
+                        </a:lnSpc>
+                      </a:pPr>
+                      <a:r>
+                        <a:rPr sz="850" b="1">
+                          <a:solidFill>
+                            <a:srgbClr val="1A1512"/>
+                          </a:solidFill>
+                          <a:latin typeface="IBM Plex Sans"/>
+                        </a:rPr>
+                        <a:t>noissue</a:t>
+                      </a:r>
+                    </a:p>
+                  </a:txBody>
+                  <a:tcPr>
+                    <a:solidFill>
+                      <a:srgbClr val="F7F1E6"/>
+                    </a:solidFill>
+                  </a:tcPr>
+                </a:tc>
+                <a:tc>
+                  <a:txBody>
+                    <a:bodyPr lIns="45000" rIns="45000" tIns="40000" bIns="40000" wrap="square"/>
+                    <a:lstStyle/>
+                    <a:p>
+                      <a:pPr algn="l">
+                        <a:lnSpc>
+                          <a:spcPct val="112000"/>
+                        </a:lnSpc>
+                      </a:pPr>
+                      <a:r>
+                        <a:rPr sz="800" b="0" u="sng">
+                          <a:solidFill>
+                            <a:srgbClr val="7A3D14"/>
+                          </a:solidFill>
+                          <a:latin typeface="IBM Plex Sans"/>
+                          <a:hlinkClick r:id="rId8"/>
+                        </a:rPr>
+                        <a:t>noissue.co</a:t>
                       </a:r>
                     </a:p>
                   </a:txBody>
@@ -7398,7 +9641,417 @@
                           </a:solidFill>
                           <a:latin typeface="IBM Plex Sans"/>
                         </a:rPr>
-                        <a:t>Florida cGMP, FDA-registered. Stock blends only at 48 MOQ; custom GLP-1-targeted blend jumps to 1,000+ MOQ. Same supplier as hair-loss section if bundle SKUs.</a:t>
+                        <a:t>Custom mailer box · FSC-certified recycled paperboard · full color in/out · branded-DTC focus</a:t>
+                      </a:r>
+                    </a:p>
+                  </a:txBody>
+                  <a:tcPr>
+                    <a:solidFill>
+                      <a:srgbClr val="F7F1E6"/>
+                    </a:solidFill>
+                  </a:tcPr>
+                </a:tc>
+                <a:tc>
+                  <a:txBody>
+                    <a:bodyPr lIns="45000" rIns="45000" tIns="40000" bIns="40000" wrap="square"/>
+                    <a:lstStyle/>
+                    <a:p>
+                      <a:pPr algn="l">
+                        <a:lnSpc>
+                          <a:spcPct val="112000"/>
+                        </a:lnSpc>
+                      </a:pPr>
+                      <a:r>
+                        <a:rPr sz="800" b="0" u="sng">
+                          <a:solidFill>
+                            <a:srgbClr val="7A3D14"/>
+                          </a:solidFill>
+                          <a:latin typeface="IBM Plex Sans"/>
+                          <a:hlinkClick r:id="rId9"/>
+                        </a:rPr>
+                        <a:t>Custom Mailer Box</a:t>
+                      </a:r>
+                    </a:p>
+                  </a:txBody>
+                  <a:tcPr>
+                    <a:solidFill>
+                      <a:srgbClr val="F7F1E6"/>
+                    </a:solidFill>
+                  </a:tcPr>
+                </a:tc>
+                <a:tc>
+                  <a:txBody>
+                    <a:bodyPr lIns="45000" rIns="45000" tIns="40000" bIns="40000" wrap="square"/>
+                    <a:lstStyle/>
+                    <a:p>
+                      <a:pPr algn="ctr">
+                        <a:lnSpc>
+                          <a:spcPct val="112000"/>
+                        </a:lnSpc>
+                      </a:pPr>
+                      <a:r>
+                        <a:rPr sz="850" b="0">
+                          <a:solidFill>
+                            <a:srgbClr val="1A1512"/>
+                          </a:solidFill>
+                          <a:latin typeface="IBM Plex Sans"/>
+                        </a:rPr>
+                        <a:t>100</a:t>
+                      </a:r>
+                    </a:p>
+                  </a:txBody>
+                  <a:tcPr>
+                    <a:solidFill>
+                      <a:srgbClr val="F7F1E6"/>
+                    </a:solidFill>
+                  </a:tcPr>
+                </a:tc>
+                <a:tc>
+                  <a:txBody>
+                    <a:bodyPr lIns="45000" rIns="45000" tIns="40000" bIns="40000" wrap="square"/>
+                    <a:lstStyle/>
+                    <a:p>
+                      <a:pPr algn="r">
+                        <a:lnSpc>
+                          <a:spcPct val="112000"/>
+                        </a:lnSpc>
+                      </a:pPr>
+                      <a:r>
+                        <a:rPr sz="850" b="0">
+                          <a:solidFill>
+                            <a:srgbClr val="1A1512"/>
+                          </a:solidFill>
+                          <a:latin typeface="IBM Plex Sans"/>
+                        </a:rPr>
+                        <a:t>$4.10</a:t>
+                      </a:r>
+                    </a:p>
+                  </a:txBody>
+                  <a:tcPr>
+                    <a:solidFill>
+                      <a:srgbClr val="F7F1E6"/>
+                    </a:solidFill>
+                  </a:tcPr>
+                </a:tc>
+                <a:tc>
+                  <a:txBody>
+                    <a:bodyPr lIns="45000" rIns="45000" tIns="40000" bIns="40000" wrap="square"/>
+                    <a:lstStyle/>
+                    <a:p>
+                      <a:pPr algn="r">
+                        <a:lnSpc>
+                          <a:spcPct val="112000"/>
+                        </a:lnSpc>
+                      </a:pPr>
+                      <a:r>
+                        <a:rPr sz="850" b="0">
+                          <a:solidFill>
+                            <a:srgbClr val="1A1512"/>
+                          </a:solidFill>
+                          <a:latin typeface="IBM Plex Sans"/>
+                        </a:rPr>
+                        <a:t>$2,460</a:t>
+                      </a:r>
+                    </a:p>
+                  </a:txBody>
+                  <a:tcPr>
+                    <a:solidFill>
+                      <a:srgbClr val="F7F1E6"/>
+                    </a:solidFill>
+                  </a:tcPr>
+                </a:tc>
+                <a:tc>
+                  <a:txBody>
+                    <a:bodyPr lIns="45000" rIns="45000" tIns="40000" bIns="40000" wrap="square"/>
+                    <a:lstStyle/>
+                    <a:p>
+                      <a:pPr algn="ctr">
+                        <a:lnSpc>
+                          <a:spcPct val="112000"/>
+                        </a:lnSpc>
+                      </a:pPr>
+                      <a:r>
+                        <a:rPr sz="1000" b="1">
+                          <a:solidFill>
+                            <a:srgbClr val="1A1512"/>
+                          </a:solidFill>
+                          <a:latin typeface="IBM Plex Sans"/>
+                        </a:rPr>
+                        <a:t>78</a:t>
+                      </a:r>
+                    </a:p>
+                  </a:txBody>
+                  <a:tcPr>
+                    <a:solidFill>
+                      <a:srgbClr val="F7F1E6"/>
+                    </a:solidFill>
+                  </a:tcPr>
+                </a:tc>
+                <a:tc>
+                  <a:txBody>
+                    <a:bodyPr lIns="45000" rIns="45000" tIns="40000" bIns="40000" wrap="square"/>
+                    <a:lstStyle/>
+                    <a:p>
+                      <a:pPr algn="l">
+                        <a:lnSpc>
+                          <a:spcPct val="112000"/>
+                        </a:lnSpc>
+                      </a:pPr>
+                      <a:r>
+                        <a:rPr sz="750" b="0">
+                          <a:solidFill>
+                            <a:srgbClr val="1A1512"/>
+                          </a:solidFill>
+                          <a:latin typeface="IBM Plex Sans"/>
+                        </a:rPr>
+                        <a:t>US distribution · MOQ 100 · FSC + carbon-neutral · in-house brand-design support (closest to Musely's White-and-Salt-led aesthetic). 4-6 wk lead is the trade-off vs. Arka. Premium feel.</a:t>
+                      </a:r>
+                    </a:p>
+                  </a:txBody>
+                  <a:tcPr>
+                    <a:solidFill>
+                      <a:srgbClr val="F7F1E6"/>
+                    </a:solidFill>
+                  </a:tcPr>
+                </a:tc>
+              </a:tr>
+              <a:tr h="655320">
+                <a:tc>
+                  <a:txBody>
+                    <a:bodyPr lIns="45000" rIns="45000" tIns="40000" bIns="40000" wrap="square"/>
+                    <a:lstStyle/>
+                    <a:p>
+                      <a:pPr algn="l">
+                        <a:lnSpc>
+                          <a:spcPct val="112000"/>
+                        </a:lnSpc>
+                      </a:pPr>
+                      <a:r>
+                        <a:rPr sz="850" b="1">
+                          <a:solidFill>
+                            <a:srgbClr val="1A1512"/>
+                          </a:solidFill>
+                          <a:latin typeface="IBM Plex Sans"/>
+                        </a:rPr>
+                        <a:t>PakFactory</a:t>
+                      </a:r>
+                    </a:p>
+                  </a:txBody>
+                  <a:tcPr>
+                    <a:solidFill>
+                      <a:srgbClr val="EFE8DC"/>
+                    </a:solidFill>
+                  </a:tcPr>
+                </a:tc>
+                <a:tc>
+                  <a:txBody>
+                    <a:bodyPr lIns="45000" rIns="45000" tIns="40000" bIns="40000" wrap="square"/>
+                    <a:lstStyle/>
+                    <a:p>
+                      <a:pPr algn="l">
+                        <a:lnSpc>
+                          <a:spcPct val="112000"/>
+                        </a:lnSpc>
+                      </a:pPr>
+                      <a:r>
+                        <a:rPr sz="800" b="0" u="sng">
+                          <a:solidFill>
+                            <a:srgbClr val="7A3D14"/>
+                          </a:solidFill>
+                          <a:latin typeface="IBM Plex Sans"/>
+                          <a:hlinkClick r:id="rId10"/>
+                        </a:rPr>
+                        <a:t>pakfactory.com</a:t>
+                      </a:r>
+                    </a:p>
+                  </a:txBody>
+                  <a:tcPr>
+                    <a:solidFill>
+                      <a:srgbClr val="EFE8DC"/>
+                    </a:solidFill>
+                  </a:tcPr>
+                </a:tc>
+                <a:tc>
+                  <a:txBody>
+                    <a:bodyPr lIns="45000" rIns="45000" tIns="40000" bIns="40000" wrap="square"/>
+                    <a:lstStyle/>
+                    <a:p>
+                      <a:pPr algn="l">
+                        <a:lnSpc>
+                          <a:spcPct val="112000"/>
+                        </a:lnSpc>
+                      </a:pPr>
+                      <a:r>
+                        <a:rPr sz="750" b="0">
+                          <a:solidFill>
+                            <a:srgbClr val="1A1512"/>
+                          </a:solidFill>
+                          <a:latin typeface="IBM Plex Sans"/>
+                        </a:rPr>
+                        <a:t>Custom folding paperboard carton · premium finishes (soft-touch, foil, emboss, UV) · multiple paperboard substrates</a:t>
+                      </a:r>
+                    </a:p>
+                  </a:txBody>
+                  <a:tcPr>
+                    <a:solidFill>
+                      <a:srgbClr val="EFE8DC"/>
+                    </a:solidFill>
+                  </a:tcPr>
+                </a:tc>
+                <a:tc>
+                  <a:txBody>
+                    <a:bodyPr lIns="45000" rIns="45000" tIns="40000" bIns="40000" wrap="square"/>
+                    <a:lstStyle/>
+                    <a:p>
+                      <a:pPr algn="l">
+                        <a:lnSpc>
+                          <a:spcPct val="112000"/>
+                        </a:lnSpc>
+                      </a:pPr>
+                      <a:r>
+                        <a:rPr sz="800" b="0" u="sng">
+                          <a:solidFill>
+                            <a:srgbClr val="7A3D14"/>
+                          </a:solidFill>
+                          <a:latin typeface="IBM Plex Sans"/>
+                          <a:hlinkClick r:id="rId11"/>
+                        </a:rPr>
+                        <a:t>Folding Carton &amp; Paperboard Boxes</a:t>
+                      </a:r>
+                    </a:p>
+                  </a:txBody>
+                  <a:tcPr>
+                    <a:solidFill>
+                      <a:srgbClr val="EFE8DC"/>
+                    </a:solidFill>
+                  </a:tcPr>
+                </a:tc>
+                <a:tc>
+                  <a:txBody>
+                    <a:bodyPr lIns="45000" rIns="45000" tIns="40000" bIns="40000" wrap="square"/>
+                    <a:lstStyle/>
+                    <a:p>
+                      <a:pPr algn="ctr">
+                        <a:lnSpc>
+                          <a:spcPct val="112000"/>
+                        </a:lnSpc>
+                      </a:pPr>
+                      <a:r>
+                        <a:rPr sz="850" b="0">
+                          <a:solidFill>
+                            <a:srgbClr val="1A1512"/>
+                          </a:solidFill>
+                          <a:latin typeface="IBM Plex Sans"/>
+                        </a:rPr>
+                        <a:t>100</a:t>
+                      </a:r>
+                    </a:p>
+                  </a:txBody>
+                  <a:tcPr>
+                    <a:solidFill>
+                      <a:srgbClr val="EFE8DC"/>
+                    </a:solidFill>
+                  </a:tcPr>
+                </a:tc>
+                <a:tc>
+                  <a:txBody>
+                    <a:bodyPr lIns="45000" rIns="45000" tIns="40000" bIns="40000" wrap="square"/>
+                    <a:lstStyle/>
+                    <a:p>
+                      <a:pPr algn="r">
+                        <a:lnSpc>
+                          <a:spcPct val="112000"/>
+                        </a:lnSpc>
+                      </a:pPr>
+                      <a:r>
+                        <a:rPr sz="850" b="0">
+                          <a:solidFill>
+                            <a:srgbClr val="1A1512"/>
+                          </a:solidFill>
+                          <a:latin typeface="IBM Plex Sans"/>
+                        </a:rPr>
+                        <a:t>$2.95</a:t>
+                      </a:r>
+                    </a:p>
+                  </a:txBody>
+                  <a:tcPr>
+                    <a:solidFill>
+                      <a:srgbClr val="EFE8DC"/>
+                    </a:solidFill>
+                  </a:tcPr>
+                </a:tc>
+                <a:tc>
+                  <a:txBody>
+                    <a:bodyPr lIns="45000" rIns="45000" tIns="40000" bIns="40000" wrap="square"/>
+                    <a:lstStyle/>
+                    <a:p>
+                      <a:pPr algn="r">
+                        <a:lnSpc>
+                          <a:spcPct val="112000"/>
+                        </a:lnSpc>
+                      </a:pPr>
+                      <a:r>
+                        <a:rPr sz="850" b="0">
+                          <a:solidFill>
+                            <a:srgbClr val="1A1512"/>
+                          </a:solidFill>
+                          <a:latin typeface="IBM Plex Sans"/>
+                        </a:rPr>
+                        <a:t>$1,770</a:t>
+                      </a:r>
+                    </a:p>
+                  </a:txBody>
+                  <a:tcPr>
+                    <a:solidFill>
+                      <a:srgbClr val="EFE8DC"/>
+                    </a:solidFill>
+                  </a:tcPr>
+                </a:tc>
+                <a:tc>
+                  <a:txBody>
+                    <a:bodyPr lIns="45000" rIns="45000" tIns="40000" bIns="40000" wrap="square"/>
+                    <a:lstStyle/>
+                    <a:p>
+                      <a:pPr algn="ctr">
+                        <a:lnSpc>
+                          <a:spcPct val="112000"/>
+                        </a:lnSpc>
+                      </a:pPr>
+                      <a:r>
+                        <a:rPr sz="1000" b="1">
+                          <a:solidFill>
+                            <a:srgbClr val="1A1512"/>
+                          </a:solidFill>
+                          <a:latin typeface="IBM Plex Sans"/>
+                        </a:rPr>
+                        <a:t>75</a:t>
+                      </a:r>
+                    </a:p>
+                  </a:txBody>
+                  <a:tcPr>
+                    <a:solidFill>
+                      <a:srgbClr val="F7F1E6"/>
+                    </a:solidFill>
+                  </a:tcPr>
+                </a:tc>
+                <a:tc>
+                  <a:txBody>
+                    <a:bodyPr lIns="45000" rIns="45000" tIns="40000" bIns="40000" wrap="square"/>
+                    <a:lstStyle/>
+                    <a:p>
+                      <a:pPr algn="l">
+                        <a:lnSpc>
+                          <a:spcPct val="112000"/>
+                        </a:lnSpc>
+                      </a:pPr>
+                      <a:r>
+                        <a:rPr sz="750" b="0">
+                          <a:solidFill>
+                            <a:srgbClr val="1A1512"/>
+                          </a:solidFill>
+                          <a:latin typeface="IBM Plex Sans"/>
+                        </a:rPr>
+                        <a:t>HQ Markham, Ontario (Canada — soft-fails the US-only gate; included for cost-comparison). Best premium-finish range (soft-touch matches Musely's tactile feel). 3-4 wk lead. Pakible (US, RFQ-only) is a sixth alternative if needed.</a:t>
                       </a:r>
                     </a:p>
                   </a:txBody>
@@ -7421,8 +10074,8 @@
         </p:nvSpPr>
         <p:spPr>
           <a:xfrm>
-            <a:off x="548640" y="5440680"/>
-            <a:ext cx="11091672" cy="868680"/>
+            <a:off x="548640" y="5943600"/>
+            <a:ext cx="11091672" cy="502920"/>
           </a:xfrm>
           <a:prstGeom prst="rect">
             <a:avLst/>
@@ -7466,7 +10119,7 @@
         </p:nvSpPr>
         <p:spPr>
           <a:xfrm>
-            <a:off x="777240" y="5577840"/>
+            <a:off x="777240" y="6035040"/>
             <a:ext cx="10607040" cy="640080"/>
           </a:xfrm>
           <a:prstGeom prst="rect">
@@ -7501,7 +10154,7 @@
                 </a:solidFill>
                 <a:latin typeface="IBM Plex Sans"/>
               </a:rPr>
-              <a:t>Aogubio (Xi'an)</a:t>
+              <a:t>Arka (Packlane)</a:t>
             </a:r>
             <a:r>
               <a:rPr sz="1100" b="0" i="0">
@@ -7510,7 +10163,7 @@
                 </a:solidFill>
                 <a:latin typeface="IBM Plex Sans"/>
               </a:rPr>
-              <a:t> · score 71/100 · MOQ 100 · $1.75/unit · total $175</a:t>
+              <a:t> · score 88/100 · MOQ 200 · $3.40/unit · total $2,040</a:t>
             </a:r>
           </a:p>
         </p:txBody>
@@ -7623,7 +10276,7 @@
                 </a:solidFill>
                 <a:latin typeface="IBM Plex Sans"/>
               </a:rPr>
-              <a:t>12 / 13</a:t>
+              <a:t>14 / 15</a:t>
             </a:r>
           </a:p>
         </p:txBody>
@@ -7636,7 +10289,7 @@
 </p:sld>
 </file>
 
-<file path=ppt/slides/slide13.xml><?xml version="1.0" encoding="utf-8"?>
+<file path=ppt/slides/slide15.xml><?xml version="1.0" encoding="utf-8"?>
 <p:sld xmlns:a="http://schemas.openxmlformats.org/drawingml/2006/main" xmlns:p="http://schemas.openxmlformats.org/presentationml/2006/main" xmlns:r="http://schemas.openxmlformats.org/officeDocument/2006/relationships">
   <p:cSld>
     <p:spTree>
@@ -7766,7 +10419,7 @@
                 </a:solidFill>
                 <a:latin typeface="IBM Plex Sans"/>
               </a:rPr>
-              <a:t>§ 06 · Next steps</a:t>
+              <a:t>§ 07 · Next steps</a:t>
             </a:r>
           </a:p>
         </p:txBody>
@@ -8168,6 +10821,40 @@
               <a:t>  ·  score 71/100  ·  MOQ 100  ·  total $175</a:t>
             </a:r>
           </a:p>
+          <a:p>
+            <a:pPr algn="l">
+              <a:lnSpc>
+                <a:spcPct val="155000"/>
+              </a:lnSpc>
+            </a:pPr>
+            <a:r>
+              <a:rPr sz="1100" b="0" i="0">
+                <a:solidFill>
+                  <a:srgbClr val="6B5D4C"/>
+                </a:solidFill>
+                <a:latin typeface="IBM Plex Sans"/>
+              </a:rPr>
+              <a:t>Outer Packaging          </a:t>
+            </a:r>
+            <a:r>
+              <a:rPr sz="1200" b="1" i="0">
+                <a:solidFill>
+                  <a:srgbClr val="1A1512"/>
+                </a:solidFill>
+                <a:latin typeface="IBM Plex Sans"/>
+              </a:rPr>
+              <a:t>Arka (Packlane)</a:t>
+            </a:r>
+            <a:r>
+              <a:rPr sz="1050" b="0" i="0">
+                <a:solidFill>
+                  <a:srgbClr val="6B5D4C"/>
+                </a:solidFill>
+                <a:latin typeface="IBM Plex Sans"/>
+              </a:rPr>
+              <a:t>  ·  score 88/100  ·  MOQ 200  ·  total $2,040</a:t>
+            </a:r>
+          </a:p>
         </p:txBody>
       </p:sp>
       <p:sp>
@@ -8332,7 +11019,7 @@
                 </a:solidFill>
                 <a:latin typeface="IBM Plex Sans"/>
               </a:rPr>
-              <a:t>Send the RFQ template (in AFTER_supplier_directory_v1.xlsx Sheet 5) to all 5 lead suppliers this week.</a:t>
+              <a:t>Send the RFQ template (in AFTER_supplier_directory_v1.xlsx Sheet 5) to all 6 lead suppliers this week — five formula vendors plus the packaging lead (Arka).</a:t>
             </a:r>
           </a:p>
           <a:p>
@@ -8357,7 +11044,7 @@
                 </a:solidFill>
                 <a:latin typeface="IBM Plex Sans"/>
               </a:rPr>
-              <a:t>Negotiate sample units (3–5 per SKU) for in-house QC before committing to MOQ runs.</a:t>
+              <a:t>Order packaging samples in parallel with formula RFQs: one small carton + one large carton from the top two packaging vendors (Arka + Refine Packaging) at $0 commitment to validate the Musely-style tactile quality.</a:t>
             </a:r>
           </a:p>
           <a:p>
@@ -8382,7 +11069,7 @@
                 </a:solidFill>
                 <a:latin typeface="IBM Plex Sans"/>
               </a:rPr>
-              <a:t>Lock packaging + label artwork with the brand designer before the first PO — fastest path to shippable inventory.</a:t>
+              <a:t>Negotiate sample units (3–5 per SKU) for in-house QC before committing to MOQ runs on the formula side.</a:t>
             </a:r>
           </a:p>
           <a:p>
@@ -8399,6 +11086,31 @@
                 <a:latin typeface="IBM Plex Sans"/>
               </a:rPr>
               <a:t>4.  </a:t>
+            </a:r>
+            <a:r>
+              <a:rPr sz="1050" b="0" i="0">
+                <a:solidFill>
+                  <a:srgbClr val="1A1512"/>
+                </a:solidFill>
+                <a:latin typeface="IBM Plex Sans"/>
+              </a:rPr>
+              <a:t>Lock packaging + label artwork with the brand designer before the first PO — fastest path to shippable inventory.</a:t>
+            </a:r>
+          </a:p>
+          <a:p>
+            <a:pPr algn="l">
+              <a:lnSpc>
+                <a:spcPct val="140000"/>
+              </a:lnSpc>
+            </a:pPr>
+            <a:r>
+              <a:rPr sz="1050" b="1" i="0">
+                <a:solidFill>
+                  <a:srgbClr val="7A3D14"/>
+                </a:solidFill>
+                <a:latin typeface="IBM Plex Sans"/>
+              </a:rPr>
+              <a:t>5.  </a:t>
             </a:r>
             <a:r>
               <a:rPr sz="1050" b="0" i="0">
@@ -8520,7 +11232,7 @@
                 </a:solidFill>
                 <a:latin typeface="IBM Plex Sans"/>
               </a:rPr>
-              <a:t>13 / 13</a:t>
+              <a:t>15 / 15</a:t>
             </a:r>
           </a:p>
         </p:txBody>
@@ -9565,7 +12277,7 @@
                 </a:solidFill>
                 <a:latin typeface="IBM Plex Sans"/>
               </a:rPr>
-              <a:t>02 / 13</a:t>
+              <a:t>02 / 15</a:t>
             </a:r>
           </a:p>
         </p:txBody>
@@ -10525,7 +13237,7 @@
                 </a:solidFill>
                 <a:latin typeface="IBM Plex Sans"/>
               </a:rPr>
-              <a:t>03 / 13</a:t>
+              <a:t>03 / 15</a:t>
             </a:r>
           </a:p>
         </p:txBody>
@@ -11871,7 +14583,7 @@
         </p:nvSpPr>
         <p:spPr>
           <a:xfrm>
-            <a:off x="777240" y="5577840"/>
+            <a:off x="777240" y="5532120"/>
             <a:ext cx="10607040" cy="640080"/>
           </a:xfrm>
           <a:prstGeom prst="rect">
@@ -12028,7 +14740,7 @@
                 </a:solidFill>
                 <a:latin typeface="IBM Plex Sans"/>
               </a:rPr>
-              <a:t>04 / 13</a:t>
+              <a:t>04 / 15</a:t>
             </a:r>
           </a:p>
         </p:txBody>
@@ -12988,7 +15700,7 @@
                 </a:solidFill>
                 <a:latin typeface="IBM Plex Sans"/>
               </a:rPr>
-              <a:t>05 / 13</a:t>
+              <a:t>05 / 15</a:t>
             </a:r>
           </a:p>
         </p:txBody>
@@ -13840,7 +16552,7 @@
         </p:nvSpPr>
         <p:spPr>
           <a:xfrm>
-            <a:off x="777240" y="5577840"/>
+            <a:off x="777240" y="5532120"/>
             <a:ext cx="10607040" cy="640080"/>
           </a:xfrm>
           <a:prstGeom prst="rect">
@@ -13997,7 +16709,7 @@
                 </a:solidFill>
                 <a:latin typeface="IBM Plex Sans"/>
               </a:rPr>
-              <a:t>06 / 13</a:t>
+              <a:t>06 / 15</a:t>
             </a:r>
           </a:p>
         </p:txBody>
@@ -14957,7 +17669,7 @@
                 </a:solidFill>
                 <a:latin typeface="IBM Plex Sans"/>
               </a:rPr>
-              <a:t>07 / 13</a:t>
+              <a:t>07 / 15</a:t>
             </a:r>
           </a:p>
         </p:txBody>
@@ -15187,7 +17899,7 @@
                 </a:solidFill>
                 <a:latin typeface="Cormorant Garamond"/>
               </a:rPr>
-              <a:t>Hair Loss — 2 shortlisted suppliers</a:t>
+              <a:t>Hair Loss — 1 shortlisted supplier</a:t>
             </a:r>
           </a:p>
         </p:txBody>
@@ -15260,7 +17972,7 @@
                 <a:gridCol w="600798"/>
                 <a:gridCol w="3188855"/>
               </a:tblGrid>
-              <a:tr h="1066800">
+              <a:tr h="1600200">
                 <a:tc>
                   <a:txBody>
                     <a:bodyPr lIns="45000" rIns="45000" tIns="40000" bIns="40000" wrap="square"/>
@@ -15505,7 +18217,7 @@
                   </a:tcPr>
                 </a:tc>
               </a:tr>
-              <a:tr h="1066800">
+              <a:tr h="1600200">
                 <a:tc>
                   <a:txBody>
                     <a:bodyPr lIns="45000" rIns="45000" tIns="40000" bIns="40000" wrap="square"/>
@@ -15752,253 +18464,6 @@
                   </a:tcPr>
                 </a:tc>
               </a:tr>
-              <a:tr h="1066800">
-                <a:tc>
-                  <a:txBody>
-                    <a:bodyPr lIns="45000" rIns="45000" tIns="40000" bIns="40000" wrap="square"/>
-                    <a:lstStyle/>
-                    <a:p>
-                      <a:pPr algn="l">
-                        <a:lnSpc>
-                          <a:spcPct val="112000"/>
-                        </a:lnSpc>
-                      </a:pPr>
-                      <a:r>
-                        <a:rPr sz="850" b="1">
-                          <a:solidFill>
-                            <a:srgbClr val="1A1512"/>
-                          </a:solidFill>
-                          <a:latin typeface="IBM Plex Sans"/>
-                        </a:rPr>
-                        <a:t>Custom Nutra</a:t>
-                      </a:r>
-                    </a:p>
-                  </a:txBody>
-                  <a:tcPr>
-                    <a:solidFill>
-                      <a:srgbClr val="F7F1E6"/>
-                    </a:solidFill>
-                  </a:tcPr>
-                </a:tc>
-                <a:tc>
-                  <a:txBody>
-                    <a:bodyPr lIns="45000" rIns="45000" tIns="40000" bIns="40000" wrap="square"/>
-                    <a:lstStyle/>
-                    <a:p>
-                      <a:pPr algn="l">
-                        <a:lnSpc>
-                          <a:spcPct val="112000"/>
-                        </a:lnSpc>
-                      </a:pPr>
-                      <a:r>
-                        <a:rPr sz="800" b="0" u="sng">
-                          <a:solidFill>
-                            <a:srgbClr val="7A3D14"/>
-                          </a:solidFill>
-                          <a:latin typeface="IBM Plex Sans"/>
-                          <a:hlinkClick r:id="rId4"/>
-                        </a:rPr>
-                        <a:t>customnutra.com</a:t>
-                      </a:r>
-                    </a:p>
-                  </a:txBody>
-                  <a:tcPr>
-                    <a:solidFill>
-                      <a:srgbClr val="F7F1E6"/>
-                    </a:solidFill>
-                  </a:tcPr>
-                </a:tc>
-                <a:tc>
-                  <a:txBody>
-                    <a:bodyPr lIns="45000" rIns="45000" tIns="40000" bIns="40000" wrap="square"/>
-                    <a:lstStyle/>
-                    <a:p>
-                      <a:pPr algn="l">
-                        <a:lnSpc>
-                          <a:spcPct val="112000"/>
-                        </a:lnSpc>
-                      </a:pPr>
-                      <a:r>
-                        <a:rPr sz="750" b="0">
-                          <a:solidFill>
-                            <a:srgbClr val="1A1512"/>
-                          </a:solidFill>
-                          <a:latin typeface="IBM Plex Sans"/>
-                        </a:rPr>
-                        <a:t>Biotin + collagen capsule (250+ stock blends); custom B-vitamin add-on</a:t>
-                      </a:r>
-                    </a:p>
-                  </a:txBody>
-                  <a:tcPr>
-                    <a:solidFill>
-                      <a:srgbClr val="F7F1E6"/>
-                    </a:solidFill>
-                  </a:tcPr>
-                </a:tc>
-                <a:tc>
-                  <a:txBody>
-                    <a:bodyPr lIns="45000" rIns="45000" tIns="40000" bIns="40000" wrap="square"/>
-                    <a:lstStyle/>
-                    <a:p>
-                      <a:pPr algn="l">
-                        <a:lnSpc>
-                          <a:spcPct val="112000"/>
-                        </a:lnSpc>
-                      </a:pPr>
-                      <a:r>
-                        <a:rPr sz="800" b="0" u="sng">
-                          <a:solidFill>
-                            <a:srgbClr val="7A3D14"/>
-                          </a:solidFill>
-                          <a:latin typeface="IBM Plex Sans"/>
-                          <a:hlinkClick r:id="rId5"/>
-                        </a:rPr>
-                        <a:t>Hair, Skin &amp; Nail PL Catalog</a:t>
-                      </a:r>
-                    </a:p>
-                  </a:txBody>
-                  <a:tcPr>
-                    <a:solidFill>
-                      <a:srgbClr val="F7F1E6"/>
-                    </a:solidFill>
-                  </a:tcPr>
-                </a:tc>
-                <a:tc>
-                  <a:txBody>
-                    <a:bodyPr lIns="45000" rIns="45000" tIns="40000" bIns="40000" wrap="square"/>
-                    <a:lstStyle/>
-                    <a:p>
-                      <a:pPr algn="ctr">
-                        <a:lnSpc>
-                          <a:spcPct val="112000"/>
-                        </a:lnSpc>
-                      </a:pPr>
-                      <a:r>
-                        <a:rPr sz="850" b="0">
-                          <a:solidFill>
-                            <a:srgbClr val="1A1512"/>
-                          </a:solidFill>
-                          <a:latin typeface="IBM Plex Sans"/>
-                        </a:rPr>
-                        <a:t>48</a:t>
-                      </a:r>
-                    </a:p>
-                  </a:txBody>
-                  <a:tcPr>
-                    <a:solidFill>
-                      <a:srgbClr val="F7F1E6"/>
-                    </a:solidFill>
-                  </a:tcPr>
-                </a:tc>
-                <a:tc>
-                  <a:txBody>
-                    <a:bodyPr lIns="45000" rIns="45000" tIns="40000" bIns="40000" wrap="square"/>
-                    <a:lstStyle/>
-                    <a:p>
-                      <a:pPr algn="r">
-                        <a:lnSpc>
-                          <a:spcPct val="112000"/>
-                        </a:lnSpc>
-                      </a:pPr>
-                      <a:r>
-                        <a:rPr sz="850" b="0">
-                          <a:solidFill>
-                            <a:srgbClr val="1A1512"/>
-                          </a:solidFill>
-                          <a:latin typeface="IBM Plex Sans"/>
-                        </a:rPr>
-                        <a:t>$2.50</a:t>
-                      </a:r>
-                    </a:p>
-                  </a:txBody>
-                  <a:tcPr>
-                    <a:solidFill>
-                      <a:srgbClr val="F7F1E6"/>
-                    </a:solidFill>
-                  </a:tcPr>
-                </a:tc>
-                <a:tc>
-                  <a:txBody>
-                    <a:bodyPr lIns="45000" rIns="45000" tIns="40000" bIns="40000" wrap="square"/>
-                    <a:lstStyle/>
-                    <a:p>
-                      <a:pPr algn="r">
-                        <a:lnSpc>
-                          <a:spcPct val="112000"/>
-                        </a:lnSpc>
-                      </a:pPr>
-                      <a:r>
-                        <a:rPr sz="850" b="0">
-                          <a:solidFill>
-                            <a:srgbClr val="1A1512"/>
-                          </a:solidFill>
-                          <a:latin typeface="IBM Plex Sans"/>
-                        </a:rPr>
-                        <a:t>$120</a:t>
-                      </a:r>
-                    </a:p>
-                  </a:txBody>
-                  <a:tcPr>
-                    <a:solidFill>
-                      <a:srgbClr val="F7F1E6"/>
-                    </a:solidFill>
-                  </a:tcPr>
-                </a:tc>
-                <a:tc>
-                  <a:txBody>
-                    <a:bodyPr lIns="45000" rIns="45000" tIns="40000" bIns="40000" wrap="square"/>
-                    <a:lstStyle/>
-                    <a:p>
-                      <a:pPr algn="ctr">
-                        <a:lnSpc>
-                          <a:spcPct val="112000"/>
-                        </a:lnSpc>
-                      </a:pPr>
-                      <a:r>
-                        <a:rPr sz="1000" b="1">
-                          <a:solidFill>
-                            <a:srgbClr val="1A1512"/>
-                          </a:solidFill>
-                          <a:latin typeface="IBM Plex Sans"/>
-                        </a:rPr>
-                        <a:t>64</a:t>
-                      </a:r>
-                    </a:p>
-                  </a:txBody>
-                  <a:tcPr>
-                    <a:solidFill>
-                      <a:srgbClr val="F7F1E6"/>
-                    </a:solidFill>
-                  </a:tcPr>
-                </a:tc>
-                <a:tc>
-                  <a:txBody>
-                    <a:bodyPr lIns="45000" rIns="45000" tIns="40000" bIns="40000" wrap="square"/>
-                    <a:lstStyle/>
-                    <a:p>
-                      <a:pPr algn="l">
-                        <a:lnSpc>
-                          <a:spcPct val="112000"/>
-                        </a:lnSpc>
-                      </a:pPr>
-                      <a:r>
-                        <a:rPr sz="750" b="0">
-                          <a:solidFill>
-                            <a:srgbClr val="1A1512"/>
-                          </a:solidFill>
-                          <a:latin typeface="IBM Plex Sans"/>
-                        </a:rPr>
-                        <a:t>Florida cGMP, FDA-registered. Lowest published stock-formula MOQ (48). Custom (vs stock) blends jump to 1,000+ MOQ. Stock biotin/collagen blend works for an MVP test.</a:t>
-                      </a:r>
-                    </a:p>
-                  </a:txBody>
-                  <a:tcPr>
-                    <a:solidFill>
-                      <a:srgbClr val="F7F1E6"/>
-                    </a:solidFill>
-                  </a:tcPr>
-                </a:tc>
-              </a:tr>
             </a:tbl>
           </a:graphicData>
         </a:graphic>
@@ -16056,7 +18521,7 @@
         </p:nvSpPr>
         <p:spPr>
           <a:xfrm>
-            <a:off x="777240" y="5577840"/>
+            <a:off x="777240" y="5532120"/>
             <a:ext cx="10607040" cy="640080"/>
           </a:xfrm>
           <a:prstGeom prst="rect">
@@ -16213,7 +18678,7 @@
                 </a:solidFill>
                 <a:latin typeface="IBM Plex Sans"/>
               </a:rPr>
-              <a:t>08 / 13</a:t>
+              <a:t>08 / 15</a:t>
             </a:r>
           </a:p>
         </p:txBody>
@@ -17173,7 +19638,7 @@
                 </a:solidFill>
                 <a:latin typeface="IBM Plex Sans"/>
               </a:rPr>
-              <a:t>09 / 13</a:t>
+              <a:t>09 / 15</a:t>
             </a:r>
           </a:p>
         </p:txBody>

</xml_diff>

<commit_message>
chore(supplier-deck): recover wip2 deck-builder rework from stash (#59)
Stale-but-not-superseded stash (stashed 2026-05-06, pre repo-reorg #24).
Verified the only post-stash change to the builder was the reorg's pure
file move (content identical), so this is current main + a self-contained
+280/-91 rework of build_supplier_shortlist_deck.py and the regenerated
Aplomb_Supplier_Shortlist_v1.pptx, faithfully mapped onto current-layout
paths. Preserved on this branch for review/continuation; not merged.

Co-authored-by: Claude Opus 4.7 <noreply@anthropic.com>
</commit_message>
<xml_diff>
--- a/business-documents/supplier-analysis/correspondence/aplomb-supplier-shortlist-v1.pptx
+++ b/business-documents/supplier-analysis/correspondence/aplomb-supplier-shortlist-v1.pptx
@@ -18,6 +18,8 @@
     <p:sldId id="266" r:id="rId17"/>
     <p:sldId id="267" r:id="rId18"/>
     <p:sldId id="268" r:id="rId19"/>
+    <p:sldId id="269" r:id="rId20"/>
+    <p:sldId id="270" r:id="rId21"/>
   </p:sldIdLst>
   <p:sldSz cx="12192000" cy="6858000" type="screen4x3"/>
   <p:notesSz cx="6858000" cy="9144000"/>
@@ -300,7 +302,7 @@
           <a:p>
             <a:fld id="{5BCAD085-E8A6-8845-BD4E-CB4CCA059FC4}" type="datetimeFigureOut">
               <a:rPr lang="en-US"/>
-              <a:t>5/4/26</a:t>
+              <a:t>5/5/26</a:t>
             </a:fld>
             <a:endParaRPr lang="en-US"/>
           </a:p>
@@ -470,7 +472,7 @@
           <a:p>
             <a:fld id="{5BCAD085-E8A6-8845-BD4E-CB4CCA059FC4}" type="datetimeFigureOut">
               <a:rPr lang="en-US"/>
-              <a:t>5/4/26</a:t>
+              <a:t>5/5/26</a:t>
             </a:fld>
             <a:endParaRPr lang="en-US"/>
           </a:p>
@@ -650,7 +652,7 @@
           <a:p>
             <a:fld id="{5BCAD085-E8A6-8845-BD4E-CB4CCA059FC4}" type="datetimeFigureOut">
               <a:rPr lang="en-US"/>
-              <a:t>5/4/26</a:t>
+              <a:t>5/5/26</a:t>
             </a:fld>
             <a:endParaRPr lang="en-US"/>
           </a:p>
@@ -820,7 +822,7 @@
           <a:p>
             <a:fld id="{5BCAD085-E8A6-8845-BD4E-CB4CCA059FC4}" type="datetimeFigureOut">
               <a:rPr lang="en-US"/>
-              <a:t>5/4/26</a:t>
+              <a:t>5/5/26</a:t>
             </a:fld>
             <a:endParaRPr lang="en-US"/>
           </a:p>
@@ -1066,7 +1068,7 @@
           <a:p>
             <a:fld id="{5BCAD085-E8A6-8845-BD4E-CB4CCA059FC4}" type="datetimeFigureOut">
               <a:rPr lang="en-US"/>
-              <a:t>5/4/26</a:t>
+              <a:t>5/5/26</a:t>
             </a:fld>
             <a:endParaRPr lang="en-US"/>
           </a:p>
@@ -1354,7 +1356,7 @@
           <a:p>
             <a:fld id="{5BCAD085-E8A6-8845-BD4E-CB4CCA059FC4}" type="datetimeFigureOut">
               <a:rPr lang="en-US"/>
-              <a:t>5/4/26</a:t>
+              <a:t>5/5/26</a:t>
             </a:fld>
             <a:endParaRPr lang="en-US"/>
           </a:p>
@@ -1776,7 +1778,7 @@
           <a:p>
             <a:fld id="{5BCAD085-E8A6-8845-BD4E-CB4CCA059FC4}" type="datetimeFigureOut">
               <a:rPr lang="en-US"/>
-              <a:t>5/4/26</a:t>
+              <a:t>5/5/26</a:t>
             </a:fld>
             <a:endParaRPr lang="en-US"/>
           </a:p>
@@ -1894,7 +1896,7 @@
           <a:p>
             <a:fld id="{5BCAD085-E8A6-8845-BD4E-CB4CCA059FC4}" type="datetimeFigureOut">
               <a:rPr lang="en-US"/>
-              <a:t>5/4/26</a:t>
+              <a:t>5/5/26</a:t>
             </a:fld>
             <a:endParaRPr lang="en-US"/>
           </a:p>
@@ -1989,7 +1991,7 @@
           <a:p>
             <a:fld id="{5BCAD085-E8A6-8845-BD4E-CB4CCA059FC4}" type="datetimeFigureOut">
               <a:rPr lang="en-US"/>
-              <a:t>5/4/26</a:t>
+              <a:t>5/5/26</a:t>
             </a:fld>
             <a:endParaRPr lang="en-US"/>
           </a:p>
@@ -2266,7 +2268,7 @@
           <a:p>
             <a:fld id="{5BCAD085-E8A6-8845-BD4E-CB4CCA059FC4}" type="datetimeFigureOut">
               <a:rPr lang="en-US"/>
-              <a:t>5/4/26</a:t>
+              <a:t>5/5/26</a:t>
             </a:fld>
             <a:endParaRPr lang="en-US"/>
           </a:p>
@@ -2519,7 +2521,7 @@
           <a:p>
             <a:fld id="{5BCAD085-E8A6-8845-BD4E-CB4CCA059FC4}" type="datetimeFigureOut">
               <a:rPr lang="en-US"/>
-              <a:t>5/4/26</a:t>
+              <a:t>5/5/26</a:t>
             </a:fld>
             <a:endParaRPr lang="en-US"/>
           </a:p>
@@ -2732,7 +2734,7 @@
           <a:p>
             <a:fld id="{5BCAD085-E8A6-8845-BD4E-CB4CCA059FC4}" type="datetimeFigureOut">
               <a:rPr lang="en-US"/>
-              <a:t>5/4/26</a:t>
+              <a:t>5/5/26</a:t>
             </a:fld>
             <a:endParaRPr lang="en-US"/>
           </a:p>
@@ -3282,7 +3284,7 @@
         <p:spPr>
           <a:xfrm>
             <a:off x="548640" y="1828800"/>
-            <a:ext cx="7315200" cy="365760"/>
+            <a:ext cx="10058400" cy="365760"/>
           </a:xfrm>
           <a:prstGeom prst="rect">
             <a:avLst/>
@@ -3307,7 +3309,7 @@
                 </a:solidFill>
                 <a:latin typeface="IBM Plex Sans"/>
               </a:rPr>
-              <a:t>MVP supplier shortlist · 5 side effects · 12 stock-formula vendors</a:t>
+              <a:t>MVP supplier shortlist · 5 side effects · 12 stock-formula vendors · + outer-packaging mailer system (6 vendors)</a:t>
             </a:r>
           </a:p>
         </p:txBody>
@@ -3618,7 +3620,7 @@
                 </a:solidFill>
                 <a:latin typeface="IBM Plex Sans"/>
               </a:rPr>
-              <a:t>For Zachary Poll · Prepared 2026-05-04 · Confidential</a:t>
+              <a:t>For Zachary Poll · Prepared 2026-05-05 · Confidential</a:t>
             </a:r>
           </a:p>
         </p:txBody>
@@ -3657,7 +3659,7 @@
                 </a:solidFill>
                 <a:latin typeface="IBM Plex Sans"/>
               </a:rPr>
-              <a:t>01 / 13</a:t>
+              <a:t>01 / 15</a:t>
             </a:r>
           </a:p>
         </p:txBody>
@@ -4470,7 +4472,7 @@
                           </a:solidFill>
                           <a:latin typeface="IBM Plex Sans"/>
                         </a:rPr>
-                        <a:t>Gingerbon (Alibaba sourced)</a:t>
+                        <a:t>Shaanxi VitaHall Biotechnology</a:t>
                       </a:r>
                     </a:p>
                   </a:txBody>
@@ -4498,7 +4500,7 @@
                           <a:latin typeface="IBM Plex Sans"/>
                           <a:hlinkClick r:id="rId4"/>
                         </a:rPr>
-                        <a:t>alibaba.com/showroom/ginge…</a:t>
+                        <a:t>alibaba.com/product-detail…</a:t>
                       </a:r>
                     </a:p>
                   </a:txBody>
@@ -4525,7 +4527,7 @@
                           </a:solidFill>
                           <a:latin typeface="IBM Plex Sans"/>
                         </a:rPr>
-                        <a:t>Vietnamese ginger candy chew, private-label wrap; B6 add-on possible on custom run</a:t>
+                        <a:t>Vegan ginger root extract gummies, private-label OEM/ODM; chewable digestion-support format</a:t>
                       </a:r>
                     </a:p>
                   </a:txBody>
@@ -4553,7 +4555,7 @@
                           <a:latin typeface="IBM Plex Sans"/>
                           <a:hlinkClick r:id="rId4"/>
                         </a:rPr>
-                        <a:t>Gingerbon Candy Wholesale</a:t>
+                        <a:t>VitaHall Ginger Root Extract Gummies</a:t>
                       </a:r>
                     </a:p>
                   </a:txBody>
@@ -4580,7 +4582,7 @@
                           </a:solidFill>
                           <a:latin typeface="IBM Plex Sans"/>
                         </a:rPr>
-                        <a:t>100</a:t>
+                        <a:t>10</a:t>
                       </a:r>
                     </a:p>
                   </a:txBody>
@@ -4607,7 +4609,7 @@
                           </a:solidFill>
                           <a:latin typeface="IBM Plex Sans"/>
                         </a:rPr>
-                        <a:t>$2.40</a:t>
+                        <a:t>$5.00</a:t>
                       </a:r>
                     </a:p>
                   </a:txBody>
@@ -4634,7 +4636,7 @@
                           </a:solidFill>
                           <a:latin typeface="IBM Plex Sans"/>
                         </a:rPr>
-                        <a:t>$240</a:t>
+                        <a:t>$50</a:t>
                       </a:r>
                     </a:p>
                   </a:txBody>
@@ -4661,7 +4663,7 @@
                           </a:solidFill>
                           <a:latin typeface="IBM Plex Sans"/>
                         </a:rPr>
-                        <a:t>72</a:t>
+                        <a:t>70</a:t>
                       </a:r>
                     </a:p>
                   </a:txBody>
@@ -4688,7 +4690,7 @@
                           </a:solidFill>
                           <a:latin typeface="IBM Plex Sans"/>
                         </a:rPr>
-                        <a:t>Vietnam confectioner via Alibaba. Traditional ginger chew; well-tolerated; B6 not in stock blend — request custom for nausea positioning. Confirm specific seller before PO.</a:t>
+                        <a:t>Shaanxi, China. MOQ 10 bottles (verified on product page) — lowest published in category. Unit price uses high-end of observed $1.70–5 range as conservative low-qty tier. Ginger-as-hero stock SKU; B6 add-on via custom run.</a:t>
                       </a:r>
                     </a:p>
                   </a:txBody>
@@ -4717,7 +4719,7 @@
                           </a:solidFill>
                           <a:latin typeface="IBM Plex Sans"/>
                         </a:rPr>
-                        <a:t>Generic Asian ginger chew (Alibaba)</a:t>
+                        <a:t>Shaanxi Suni Green</a:t>
                       </a:r>
                     </a:p>
                   </a:txBody>
@@ -4745,7 +4747,7 @@
                           <a:latin typeface="IBM Plex Sans"/>
                           <a:hlinkClick r:id="rId5"/>
                         </a:rPr>
-                        <a:t>alibaba.com/showroom/ginge…</a:t>
+                        <a:t>alibaba.com/product-detail…</a:t>
                       </a:r>
                     </a:p>
                   </a:txBody>
@@ -4772,7 +4774,7 @@
                           </a:solidFill>
                           <a:latin typeface="IBM Plex Sans"/>
                         </a:rPr>
-                        <a:t>Private-label ginger chew, custom B6 + ginger blend; 66 suppliers in category</a:t>
+                        <a:t>Organic ginger root extract gummies, private-label OEM/ODM; chewable digestion-support format</a:t>
                       </a:r>
                     </a:p>
                   </a:txBody>
@@ -4800,7 +4802,7 @@
                           <a:latin typeface="IBM Plex Sans"/>
                           <a:hlinkClick r:id="rId5"/>
                         </a:rPr>
-                        <a:t>Ginger Chew OEM Listings</a:t>
+                        <a:t>SUNI Organic Ginger Root Extract Gummies</a:t>
                       </a:r>
                     </a:p>
                   </a:txBody>
@@ -4854,7 +4856,7 @@
                           </a:solidFill>
                           <a:latin typeface="IBM Plex Sans"/>
                         </a:rPr>
-                        <a:t>$2.00</a:t>
+                        <a:t>$2.20</a:t>
                       </a:r>
                     </a:p>
                   </a:txBody>
@@ -4881,7 +4883,7 @@
                           </a:solidFill>
                           <a:latin typeface="IBM Plex Sans"/>
                         </a:rPr>
-                        <a:t>$200</a:t>
+                        <a:t>$220</a:t>
                       </a:r>
                     </a:p>
                   </a:txBody>
@@ -4908,7 +4910,7 @@
                           </a:solidFill>
                           <a:latin typeface="IBM Plex Sans"/>
                         </a:rPr>
-                        <a:t>68</a:t>
+                        <a:t>66</a:t>
                       </a:r>
                     </a:p>
                   </a:txBody>
@@ -4935,7 +4937,7 @@
                           </a:solidFill>
                           <a:latin typeface="IBM Plex Sans"/>
                         </a:rPr>
-                        <a:t>147 ginger chew SKUs across 66 suppliers (most China). Request RFQ from 3-5 sellers; pick best MOQ + B6 spec. ISO9001 + HACCP common.</a:t>
+                        <a:t>Shaanxi, China. MOQ 100 bottles (verified on product page). Unit price $2.20 is high-end of observed $1.55–2.20 range. Vegan + organic certs. Direct competitor to VitaHall.</a:t>
                       </a:r>
                     </a:p>
                   </a:txBody>
@@ -5003,7 +5005,7 @@
         </p:nvSpPr>
         <p:spPr>
           <a:xfrm>
-            <a:off x="777240" y="5577840"/>
+            <a:off x="777240" y="5532120"/>
             <a:ext cx="10607040" cy="640080"/>
           </a:xfrm>
           <a:prstGeom prst="rect">
@@ -5160,7 +5162,7 @@
                 </a:solidFill>
                 <a:latin typeface="IBM Plex Sans"/>
               </a:rPr>
-              <a:t>10 / 13</a:t>
+              <a:t>10 / 15</a:t>
             </a:r>
           </a:p>
         </p:txBody>
@@ -6120,7 +6122,7 @@
                 </a:solidFill>
                 <a:latin typeface="IBM Plex Sans"/>
               </a:rPr>
-              <a:t>11 / 13</a:t>
+              <a:t>11 / 15</a:t>
             </a:r>
           </a:p>
         </p:txBody>
@@ -6350,7 +6352,7 @@
                 </a:solidFill>
                 <a:latin typeface="Cormorant Garamond"/>
               </a:rPr>
-              <a:t>Nutrient Depletion — 3 shortlisted suppliers</a:t>
+              <a:t>Nutrient Depletion — 1 shortlisted supplier</a:t>
             </a:r>
           </a:p>
         </p:txBody>
@@ -6423,7 +6425,7 @@
                 <a:gridCol w="600798"/>
                 <a:gridCol w="3188855"/>
               </a:tblGrid>
-              <a:tr h="800100">
+              <a:tr h="1600200">
                 <a:tc>
                   <a:txBody>
                     <a:bodyPr lIns="45000" rIns="45000" tIns="40000" bIns="40000" wrap="square"/>
@@ -6668,7 +6670,7 @@
                   </a:tcPr>
                 </a:tc>
               </a:tr>
-              <a:tr h="800100">
+              <a:tr h="1600200">
                 <a:tc>
                   <a:txBody>
                     <a:bodyPr lIns="45000" rIns="45000" tIns="40000" bIns="40000" wrap="square"/>
@@ -6915,7 +6917,1917 @@
                   </a:tcPr>
                 </a:tc>
               </a:tr>
-              <a:tr h="800100">
+            </a:tbl>
+          </a:graphicData>
+        </a:graphic>
+      </p:graphicFrame>
+      <p:sp>
+        <p:nvSpPr>
+          <p:cNvPr id="9" name="Rectangle 8"/>
+          <p:cNvSpPr/>
+          <p:nvPr/>
+        </p:nvSpPr>
+        <p:spPr>
+          <a:xfrm>
+            <a:off x="548640" y="5440680"/>
+            <a:ext cx="11091672" cy="868680"/>
+          </a:xfrm>
+          <a:prstGeom prst="rect">
+            <a:avLst/>
+          </a:prstGeom>
+          <a:solidFill>
+            <a:srgbClr val="F7F1E6"/>
+          </a:solidFill>
+          <a:ln>
+            <a:noFill/>
+          </a:ln>
+          <a:effectLst/>
+        </p:spPr>
+        <p:style>
+          <a:lnRef idx="1">
+            <a:schemeClr val="accent1"/>
+          </a:lnRef>
+          <a:fillRef idx="3">
+            <a:schemeClr val="accent1"/>
+          </a:fillRef>
+          <a:effectRef idx="2">
+            <a:schemeClr val="accent1"/>
+          </a:effectRef>
+          <a:fontRef idx="minor">
+            <a:schemeClr val="lt1"/>
+          </a:fontRef>
+        </p:style>
+        <p:txBody>
+          <a:bodyPr rtlCol="0" anchor="ctr"/>
+          <a:lstStyle/>
+          <a:p>
+            <a:pPr algn="ctr"/>
+            <a:endParaRPr/>
+          </a:p>
+        </p:txBody>
+      </p:sp>
+      <p:sp>
+        <p:nvSpPr>
+          <p:cNvPr id="10" name="TextBox 9"/>
+          <p:cNvSpPr txBox="1"/>
+          <p:nvPr/>
+        </p:nvSpPr>
+        <p:spPr>
+          <a:xfrm>
+            <a:off x="777240" y="5532120"/>
+            <a:ext cx="10607040" cy="640080"/>
+          </a:xfrm>
+          <a:prstGeom prst="rect">
+            <a:avLst/>
+          </a:prstGeom>
+          <a:noFill/>
+        </p:spPr>
+        <p:txBody>
+          <a:bodyPr wrap="square" lIns="0" rIns="0" tIns="0" bIns="0" anchor="t">
+            <a:spAutoFit/>
+          </a:bodyPr>
+          <a:lstStyle/>
+          <a:p>
+            <a:pPr algn="l">
+              <a:lnSpc>
+                <a:spcPct val="118000"/>
+              </a:lnSpc>
+            </a:pPr>
+            <a:r>
+              <a:rPr sz="850" b="1" i="0">
+                <a:solidFill>
+                  <a:srgbClr val="7A3D14"/>
+                </a:solidFill>
+                <a:latin typeface="IBM Plex Sans"/>
+              </a:rPr>
+              <a:t>RECOMMENDED LEAD  </a:t>
+            </a:r>
+            <a:r>
+              <a:rPr sz="1200" b="1" i="0">
+                <a:solidFill>
+                  <a:srgbClr val="1A1512"/>
+                </a:solidFill>
+                <a:latin typeface="IBM Plex Sans"/>
+              </a:rPr>
+              <a:t>Aogubio (Xi'an)</a:t>
+            </a:r>
+            <a:r>
+              <a:rPr sz="1100" b="0" i="0">
+                <a:solidFill>
+                  <a:srgbClr val="1A1512"/>
+                </a:solidFill>
+                <a:latin typeface="IBM Plex Sans"/>
+              </a:rPr>
+              <a:t> · score 71/100 · MOQ 100 · $1.75/unit · total $175</a:t>
+            </a:r>
+          </a:p>
+        </p:txBody>
+      </p:sp>
+      <p:cxnSp>
+        <p:nvCxnSpPr>
+          <p:cNvPr id="11" name="Connector 10"/>
+          <p:cNvCxnSpPr/>
+          <p:nvPr/>
+        </p:nvCxnSpPr>
+        <p:spPr>
+          <a:xfrm>
+            <a:off x="548640" y="6446520"/>
+            <a:ext cx="11091672" cy="0"/>
+          </a:xfrm>
+          <a:prstGeom prst="line">
+            <a:avLst/>
+          </a:prstGeom>
+          <a:ln w="9525">
+            <a:solidFill>
+              <a:srgbClr val="D9CFBD"/>
+            </a:solidFill>
+          </a:ln>
+        </p:spPr>
+        <p:style>
+          <a:lnRef idx="2">
+            <a:schemeClr val="accent1"/>
+          </a:lnRef>
+          <a:fillRef idx="0">
+            <a:schemeClr val="accent1"/>
+          </a:fillRef>
+          <a:effectRef idx="1">
+            <a:schemeClr val="accent1"/>
+          </a:effectRef>
+          <a:fontRef idx="minor">
+            <a:schemeClr val="tx1"/>
+          </a:fontRef>
+        </p:style>
+      </p:cxnSp>
+      <p:sp>
+        <p:nvSpPr>
+          <p:cNvPr id="12" name="TextBox 11"/>
+          <p:cNvSpPr txBox="1"/>
+          <p:nvPr/>
+        </p:nvSpPr>
+        <p:spPr>
+          <a:xfrm>
+            <a:off x="548640" y="6519672"/>
+            <a:ext cx="7315200" cy="274320"/>
+          </a:xfrm>
+          <a:prstGeom prst="rect">
+            <a:avLst/>
+          </a:prstGeom>
+          <a:noFill/>
+        </p:spPr>
+        <p:txBody>
+          <a:bodyPr wrap="square" lIns="0" rIns="0" tIns="0" bIns="0" anchor="t">
+            <a:spAutoFit/>
+          </a:bodyPr>
+          <a:lstStyle/>
+          <a:p>
+            <a:pPr algn="l">
+              <a:lnSpc>
+                <a:spcPct val="118000"/>
+              </a:lnSpc>
+            </a:pPr>
+            <a:r>
+              <a:rPr sz="800" b="0" i="0">
+                <a:solidFill>
+                  <a:srgbClr val="6B5D4C"/>
+                </a:solidFill>
+                <a:latin typeface="IBM Plex Sans"/>
+              </a:rPr>
+              <a:t>Aplomb — Supplier shortlist for MVP market test · For Zachary Poll · Confidential</a:t>
+            </a:r>
+          </a:p>
+        </p:txBody>
+      </p:sp>
+      <p:sp>
+        <p:nvSpPr>
+          <p:cNvPr id="13" name="TextBox 12"/>
+          <p:cNvSpPr txBox="1"/>
+          <p:nvPr/>
+        </p:nvSpPr>
+        <p:spPr>
+          <a:xfrm>
+            <a:off x="10332720" y="6519672"/>
+            <a:ext cx="1371600" cy="274320"/>
+          </a:xfrm>
+          <a:prstGeom prst="rect">
+            <a:avLst/>
+          </a:prstGeom>
+          <a:noFill/>
+        </p:spPr>
+        <p:txBody>
+          <a:bodyPr wrap="square" lIns="0" rIns="0" tIns="0" bIns="0" anchor="t">
+            <a:spAutoFit/>
+          </a:bodyPr>
+          <a:lstStyle/>
+          <a:p>
+            <a:pPr algn="r">
+              <a:lnSpc>
+                <a:spcPct val="118000"/>
+              </a:lnSpc>
+            </a:pPr>
+            <a:r>
+              <a:rPr sz="800" b="0" i="0">
+                <a:solidFill>
+                  <a:srgbClr val="6B5D4C"/>
+                </a:solidFill>
+                <a:latin typeface="IBM Plex Sans"/>
+              </a:rPr>
+              <a:t>12 / 15</a:t>
+            </a:r>
+          </a:p>
+        </p:txBody>
+      </p:sp>
+    </p:spTree>
+  </p:cSld>
+  <p:clrMapOvr>
+    <a:masterClrMapping/>
+  </p:clrMapOvr>
+</p:sld>
+</file>
+
+<file path=ppt/slides/slide13.xml><?xml version="1.0" encoding="utf-8"?>
+<p:sld xmlns:a="http://schemas.openxmlformats.org/drawingml/2006/main" xmlns:p="http://schemas.openxmlformats.org/presentationml/2006/main" xmlns:r="http://schemas.openxmlformats.org/officeDocument/2006/relationships">
+  <p:cSld>
+    <p:spTree>
+      <p:nvGrpSpPr>
+        <p:cNvPr id="1" name=""/>
+        <p:cNvGrpSpPr/>
+        <p:nvPr/>
+      </p:nvGrpSpPr>
+      <p:grpSpPr>
+        <a:xfrm>
+          <a:off x="0" y="0"/>
+          <a:ext cx="0" cy="0"/>
+          <a:chOff x="0" y="0"/>
+          <a:chExt cx="0" cy="0"/>
+        </a:xfrm>
+      </p:grpSpPr>
+      <p:sp>
+        <p:nvSpPr>
+          <p:cNvPr id="2" name="Rectangle 1"/>
+          <p:cNvSpPr/>
+          <p:nvPr/>
+        </p:nvSpPr>
+        <p:spPr>
+          <a:xfrm>
+            <a:off x="0" y="0"/>
+            <a:ext cx="12192000" cy="6858000"/>
+          </a:xfrm>
+          <a:prstGeom prst="rect">
+            <a:avLst/>
+          </a:prstGeom>
+          <a:solidFill>
+            <a:srgbClr val="EFE8DC"/>
+          </a:solidFill>
+          <a:ln>
+            <a:noFill/>
+          </a:ln>
+        </p:spPr>
+        <p:style>
+          <a:lnRef idx="1">
+            <a:schemeClr val="accent1"/>
+          </a:lnRef>
+          <a:fillRef idx="3">
+            <a:schemeClr val="accent1"/>
+          </a:fillRef>
+          <a:effectRef idx="2">
+            <a:schemeClr val="accent1"/>
+          </a:effectRef>
+          <a:fontRef idx="minor">
+            <a:schemeClr val="lt1"/>
+          </a:fontRef>
+        </p:style>
+        <p:txBody>
+          <a:bodyPr rtlCol="0" anchor="ctr"/>
+          <a:lstStyle/>
+          <a:p>
+            <a:pPr algn="ctr"/>
+            <a:endParaRPr/>
+          </a:p>
+        </p:txBody>
+      </p:sp>
+      <p:cxnSp>
+        <p:nvCxnSpPr>
+          <p:cNvPr id="3" name="Connector 2"/>
+          <p:cNvCxnSpPr/>
+          <p:nvPr/>
+        </p:nvCxnSpPr>
+        <p:spPr>
+          <a:xfrm>
+            <a:off x="548640" y="502920"/>
+            <a:ext cx="11091672" cy="0"/>
+          </a:xfrm>
+          <a:prstGeom prst="line">
+            <a:avLst/>
+          </a:prstGeom>
+          <a:ln w="9525">
+            <a:solidFill>
+              <a:srgbClr val="D9CFBD"/>
+            </a:solidFill>
+          </a:ln>
+        </p:spPr>
+        <p:style>
+          <a:lnRef idx="2">
+            <a:schemeClr val="accent1"/>
+          </a:lnRef>
+          <a:fillRef idx="0">
+            <a:schemeClr val="accent1"/>
+          </a:fillRef>
+          <a:effectRef idx="1">
+            <a:schemeClr val="accent1"/>
+          </a:effectRef>
+          <a:fontRef idx="minor">
+            <a:schemeClr val="tx1"/>
+          </a:fontRef>
+        </p:style>
+      </p:cxnSp>
+      <p:sp>
+        <p:nvSpPr>
+          <p:cNvPr id="4" name="TextBox 3"/>
+          <p:cNvSpPr txBox="1"/>
+          <p:nvPr/>
+        </p:nvSpPr>
+        <p:spPr>
+          <a:xfrm>
+            <a:off x="548640" y="164592"/>
+            <a:ext cx="7315200" cy="274320"/>
+          </a:xfrm>
+          <a:prstGeom prst="rect">
+            <a:avLst/>
+          </a:prstGeom>
+          <a:noFill/>
+        </p:spPr>
+        <p:txBody>
+          <a:bodyPr wrap="square" lIns="0" rIns="0" tIns="0" bIns="0" anchor="t">
+            <a:spAutoFit/>
+          </a:bodyPr>
+          <a:lstStyle/>
+          <a:p>
+            <a:pPr algn="l">
+              <a:lnSpc>
+                <a:spcPct val="118000"/>
+              </a:lnSpc>
+            </a:pPr>
+            <a:r>
+              <a:rPr sz="900" b="0" i="0">
+                <a:solidFill>
+                  <a:srgbClr val="7A3D14"/>
+                </a:solidFill>
+                <a:latin typeface="IBM Plex Sans"/>
+              </a:rPr>
+              <a:t>§ 06 · Add-on · Two-SKU folding-mailer system</a:t>
+            </a:r>
+          </a:p>
+        </p:txBody>
+      </p:sp>
+      <p:sp>
+        <p:nvSpPr>
+          <p:cNvPr id="5" name="TextBox 4"/>
+          <p:cNvSpPr txBox="1"/>
+          <p:nvPr/>
+        </p:nvSpPr>
+        <p:spPr>
+          <a:xfrm>
+            <a:off x="10058400" y="164592"/>
+            <a:ext cx="1645920" cy="274320"/>
+          </a:xfrm>
+          <a:prstGeom prst="rect">
+            <a:avLst/>
+          </a:prstGeom>
+          <a:noFill/>
+        </p:spPr>
+        <p:txBody>
+          <a:bodyPr wrap="square" lIns="0" rIns="0" tIns="0" bIns="0" anchor="t">
+            <a:spAutoFit/>
+          </a:bodyPr>
+          <a:lstStyle/>
+          <a:p>
+            <a:pPr algn="r">
+              <a:lnSpc>
+                <a:spcPct val="118000"/>
+              </a:lnSpc>
+            </a:pPr>
+            <a:r>
+              <a:rPr sz="1100" b="0" i="1">
+                <a:solidFill>
+                  <a:srgbClr val="1A1512"/>
+                </a:solidFill>
+                <a:latin typeface="Cormorant Garamond"/>
+              </a:rPr>
+              <a:t>Aplomb</a:t>
+            </a:r>
+            <a:r>
+              <a:rPr sz="1100" b="1" i="1">
+                <a:solidFill>
+                  <a:srgbClr val="7A3D14"/>
+                </a:solidFill>
+                <a:latin typeface="Cormorant Garamond"/>
+              </a:rPr>
+              <a:t>.</a:t>
+            </a:r>
+          </a:p>
+        </p:txBody>
+      </p:sp>
+      <p:sp>
+        <p:nvSpPr>
+          <p:cNvPr id="6" name="TextBox 5"/>
+          <p:cNvSpPr txBox="1"/>
+          <p:nvPr/>
+        </p:nvSpPr>
+        <p:spPr>
+          <a:xfrm>
+            <a:off x="548640" y="777240"/>
+            <a:ext cx="10972800" cy="1097280"/>
+          </a:xfrm>
+          <a:prstGeom prst="rect">
+            <a:avLst/>
+          </a:prstGeom>
+          <a:noFill/>
+        </p:spPr>
+        <p:txBody>
+          <a:bodyPr wrap="square" lIns="0" rIns="0" tIns="0" bIns="0" anchor="t">
+            <a:spAutoFit/>
+          </a:bodyPr>
+          <a:lstStyle/>
+          <a:p>
+            <a:pPr algn="l">
+              <a:lnSpc>
+                <a:spcPct val="105000"/>
+              </a:lnSpc>
+            </a:pPr>
+            <a:r>
+              <a:rPr sz="3800" b="0" i="0">
+                <a:solidFill>
+                  <a:srgbClr val="1A1512"/>
+                </a:solidFill>
+                <a:latin typeface="Cormorant Garamond"/>
+              </a:rPr>
+              <a:t>Outer Packaging</a:t>
+            </a:r>
+          </a:p>
+        </p:txBody>
+      </p:sp>
+      <p:sp>
+        <p:nvSpPr>
+          <p:cNvPr id="7" name="Rectangle 6"/>
+          <p:cNvSpPr/>
+          <p:nvPr/>
+        </p:nvSpPr>
+        <p:spPr>
+          <a:xfrm>
+            <a:off x="548640" y="1828800"/>
+            <a:ext cx="5349240" cy="4434840"/>
+          </a:xfrm>
+          <a:prstGeom prst="rect">
+            <a:avLst/>
+          </a:prstGeom>
+          <a:solidFill>
+            <a:srgbClr val="F7F1E6"/>
+          </a:solidFill>
+          <a:ln>
+            <a:noFill/>
+          </a:ln>
+          <a:effectLst/>
+        </p:spPr>
+        <p:style>
+          <a:lnRef idx="1">
+            <a:schemeClr val="accent1"/>
+          </a:lnRef>
+          <a:fillRef idx="3">
+            <a:schemeClr val="accent1"/>
+          </a:fillRef>
+          <a:effectRef idx="2">
+            <a:schemeClr val="accent1"/>
+          </a:effectRef>
+          <a:fontRef idx="minor">
+            <a:schemeClr val="lt1"/>
+          </a:fontRef>
+        </p:style>
+        <p:txBody>
+          <a:bodyPr rtlCol="0" anchor="ctr"/>
+          <a:lstStyle/>
+          <a:p>
+            <a:pPr algn="ctr"/>
+            <a:endParaRPr/>
+          </a:p>
+        </p:txBody>
+      </p:sp>
+      <p:sp>
+        <p:nvSpPr>
+          <p:cNvPr id="8" name="TextBox 7"/>
+          <p:cNvSpPr txBox="1"/>
+          <p:nvPr/>
+        </p:nvSpPr>
+        <p:spPr>
+          <a:xfrm>
+            <a:off x="777240" y="1993392"/>
+            <a:ext cx="4937760" cy="365760"/>
+          </a:xfrm>
+          <a:prstGeom prst="rect">
+            <a:avLst/>
+          </a:prstGeom>
+          <a:noFill/>
+        </p:spPr>
+        <p:txBody>
+          <a:bodyPr wrap="square" lIns="0" rIns="0" tIns="0" bIns="0" anchor="t">
+            <a:spAutoFit/>
+          </a:bodyPr>
+          <a:lstStyle/>
+          <a:p>
+            <a:pPr algn="l">
+              <a:lnSpc>
+                <a:spcPct val="118000"/>
+              </a:lnSpc>
+            </a:pPr>
+            <a:r>
+              <a:rPr sz="850" b="1" i="0">
+                <a:solidFill>
+                  <a:srgbClr val="7A3D14"/>
+                </a:solidFill>
+                <a:latin typeface="IBM Plex Sans"/>
+              </a:rPr>
+              <a:t>THE BRIEF</a:t>
+            </a:r>
+          </a:p>
+        </p:txBody>
+      </p:sp>
+      <p:cxnSp>
+        <p:nvCxnSpPr>
+          <p:cNvPr id="9" name="Connector 8"/>
+          <p:cNvCxnSpPr/>
+          <p:nvPr/>
+        </p:nvCxnSpPr>
+        <p:spPr>
+          <a:xfrm>
+            <a:off x="777240" y="2304288"/>
+            <a:ext cx="4937760" cy="0"/>
+          </a:xfrm>
+          <a:prstGeom prst="line">
+            <a:avLst/>
+          </a:prstGeom>
+          <a:ln w="6350">
+            <a:solidFill>
+              <a:srgbClr val="D9CFBD"/>
+            </a:solidFill>
+          </a:ln>
+        </p:spPr>
+        <p:style>
+          <a:lnRef idx="2">
+            <a:schemeClr val="accent1"/>
+          </a:lnRef>
+          <a:fillRef idx="0">
+            <a:schemeClr val="accent1"/>
+          </a:fillRef>
+          <a:effectRef idx="1">
+            <a:schemeClr val="accent1"/>
+          </a:effectRef>
+          <a:fontRef idx="minor">
+            <a:schemeClr val="tx1"/>
+          </a:fontRef>
+        </p:style>
+      </p:cxnSp>
+      <p:sp>
+        <p:nvSpPr>
+          <p:cNvPr id="10" name="TextBox 9"/>
+          <p:cNvSpPr txBox="1"/>
+          <p:nvPr/>
+        </p:nvSpPr>
+        <p:spPr>
+          <a:xfrm>
+            <a:off x="777240" y="2423160"/>
+            <a:ext cx="4937760" cy="2377440"/>
+          </a:xfrm>
+          <a:prstGeom prst="rect">
+            <a:avLst/>
+          </a:prstGeom>
+          <a:noFill/>
+        </p:spPr>
+        <p:txBody>
+          <a:bodyPr wrap="square" lIns="0" rIns="0" tIns="0" bIns="0" anchor="t">
+            <a:spAutoFit/>
+          </a:bodyPr>
+          <a:lstStyle/>
+          <a:p>
+            <a:pPr algn="l">
+              <a:lnSpc>
+                <a:spcPct val="145000"/>
+              </a:lnSpc>
+            </a:pPr>
+            <a:r>
+              <a:rPr sz="1100" b="0" i="0">
+                <a:solidFill>
+                  <a:srgbClr val="1A1512"/>
+                </a:solidFill>
+                <a:latin typeface="IBM Plex Sans"/>
+              </a:rPr>
+              <a:t>Every Aplomb SKU needs an outer mailer that ships flat, weighs almost nothing, and reads editorial — not generic corrugated. Reference: Musely's matte mauve folding-carton mailer (single-color exterior, branded interior message, soft tactile paperboard). Two carton SKUs cover the line: a small mailer for the serum, capsule bottles, and lozenge tin; a large mailer for the Calm kit.</a:t>
+            </a:r>
+          </a:p>
+        </p:txBody>
+      </p:sp>
+      <p:cxnSp>
+        <p:nvCxnSpPr>
+          <p:cNvPr id="11" name="Connector 10"/>
+          <p:cNvCxnSpPr/>
+          <p:nvPr/>
+        </p:nvCxnSpPr>
+        <p:spPr>
+          <a:xfrm>
+            <a:off x="777240" y="4846320"/>
+            <a:ext cx="4937760" cy="0"/>
+          </a:xfrm>
+          <a:prstGeom prst="line">
+            <a:avLst/>
+          </a:prstGeom>
+          <a:ln w="6350">
+            <a:solidFill>
+              <a:srgbClr val="D9CFBD"/>
+            </a:solidFill>
+          </a:ln>
+        </p:spPr>
+        <p:style>
+          <a:lnRef idx="2">
+            <a:schemeClr val="accent1"/>
+          </a:lnRef>
+          <a:fillRef idx="0">
+            <a:schemeClr val="accent1"/>
+          </a:fillRef>
+          <a:effectRef idx="1">
+            <a:schemeClr val="accent1"/>
+          </a:effectRef>
+          <a:fontRef idx="minor">
+            <a:schemeClr val="tx1"/>
+          </a:fontRef>
+        </p:style>
+      </p:cxnSp>
+      <p:sp>
+        <p:nvSpPr>
+          <p:cNvPr id="12" name="TextBox 11"/>
+          <p:cNvSpPr txBox="1"/>
+          <p:nvPr/>
+        </p:nvSpPr>
+        <p:spPr>
+          <a:xfrm>
+            <a:off x="777240" y="4937760"/>
+            <a:ext cx="4937760" cy="365760"/>
+          </a:xfrm>
+          <a:prstGeom prst="rect">
+            <a:avLst/>
+          </a:prstGeom>
+          <a:noFill/>
+        </p:spPr>
+        <p:txBody>
+          <a:bodyPr wrap="square" lIns="0" rIns="0" tIns="0" bIns="0" anchor="t">
+            <a:spAutoFit/>
+          </a:bodyPr>
+          <a:lstStyle/>
+          <a:p>
+            <a:pPr algn="l">
+              <a:lnSpc>
+                <a:spcPct val="118000"/>
+              </a:lnSpc>
+            </a:pPr>
+            <a:r>
+              <a:rPr sz="850" b="1" i="0">
+                <a:solidFill>
+                  <a:srgbClr val="7A3D14"/>
+                </a:solidFill>
+                <a:latin typeface="IBM Plex Sans"/>
+              </a:rPr>
+              <a:t>MUSELY INTELLIGENCE</a:t>
+            </a:r>
+          </a:p>
+        </p:txBody>
+      </p:sp>
+      <p:sp>
+        <p:nvSpPr>
+          <p:cNvPr id="13" name="TextBox 12"/>
+          <p:cNvSpPr txBox="1"/>
+          <p:nvPr/>
+        </p:nvSpPr>
+        <p:spPr>
+          <a:xfrm>
+            <a:off x="777240" y="5230368"/>
+            <a:ext cx="4937760" cy="1097280"/>
+          </a:xfrm>
+          <a:prstGeom prst="rect">
+            <a:avLst/>
+          </a:prstGeom>
+          <a:noFill/>
+        </p:spPr>
+        <p:txBody>
+          <a:bodyPr wrap="square" lIns="0" rIns="0" tIns="0" bIns="0" anchor="t">
+            <a:spAutoFit/>
+          </a:bodyPr>
+          <a:lstStyle/>
+          <a:p>
+            <a:pPr algn="l">
+              <a:lnSpc>
+                <a:spcPct val="140000"/>
+              </a:lnSpc>
+            </a:pPr>
+            <a:r>
+              <a:rPr sz="950" b="0" i="0">
+                <a:solidFill>
+                  <a:srgbClr val="1A1512"/>
+                </a:solidFill>
+                <a:latin typeface="IBM Plex Sans"/>
+              </a:rPr>
+              <a:t>Musely (telehealth dermatology, founded 2013) commissioned its brand evolution from White and Salt design studio. Musely's specific carton vendor is not public; the closest production-format match for the same paperboard mailer at MOQ 200-400 is Arka or noissue. RFQ both as the path of least resistance to a Musely-equivalent first run.</a:t>
+            </a:r>
+          </a:p>
+        </p:txBody>
+      </p:sp>
+      <p:sp>
+        <p:nvSpPr>
+          <p:cNvPr id="14" name="Rectangle 13"/>
+          <p:cNvSpPr/>
+          <p:nvPr/>
+        </p:nvSpPr>
+        <p:spPr>
+          <a:xfrm>
+            <a:off x="6035040" y="1828800"/>
+            <a:ext cx="5605272" cy="2697480"/>
+          </a:xfrm>
+          <a:prstGeom prst="rect">
+            <a:avLst/>
+          </a:prstGeom>
+          <a:solidFill>
+            <a:srgbClr val="F7F1E6"/>
+          </a:solidFill>
+          <a:ln>
+            <a:noFill/>
+          </a:ln>
+          <a:effectLst/>
+        </p:spPr>
+        <p:style>
+          <a:lnRef idx="1">
+            <a:schemeClr val="accent1"/>
+          </a:lnRef>
+          <a:fillRef idx="3">
+            <a:schemeClr val="accent1"/>
+          </a:fillRef>
+          <a:effectRef idx="2">
+            <a:schemeClr val="accent1"/>
+          </a:effectRef>
+          <a:fontRef idx="minor">
+            <a:schemeClr val="lt1"/>
+          </a:fontRef>
+        </p:style>
+        <p:txBody>
+          <a:bodyPr rtlCol="0" anchor="ctr"/>
+          <a:lstStyle/>
+          <a:p>
+            <a:pPr algn="ctr"/>
+            <a:endParaRPr/>
+          </a:p>
+        </p:txBody>
+      </p:sp>
+      <p:sp>
+        <p:nvSpPr>
+          <p:cNvPr id="15" name="TextBox 14"/>
+          <p:cNvSpPr txBox="1"/>
+          <p:nvPr/>
+        </p:nvSpPr>
+        <p:spPr>
+          <a:xfrm>
+            <a:off x="6263640" y="1993392"/>
+            <a:ext cx="5212080" cy="365760"/>
+          </a:xfrm>
+          <a:prstGeom prst="rect">
+            <a:avLst/>
+          </a:prstGeom>
+          <a:noFill/>
+        </p:spPr>
+        <p:txBody>
+          <a:bodyPr wrap="square" lIns="0" rIns="0" tIns="0" bIns="0" anchor="t">
+            <a:spAutoFit/>
+          </a:bodyPr>
+          <a:lstStyle/>
+          <a:p>
+            <a:pPr algn="l">
+              <a:lnSpc>
+                <a:spcPct val="118000"/>
+              </a:lnSpc>
+            </a:pPr>
+            <a:r>
+              <a:rPr sz="850" b="1" i="0">
+                <a:solidFill>
+                  <a:srgbClr val="7A3D14"/>
+                </a:solidFill>
+                <a:latin typeface="IBM Plex Sans"/>
+              </a:rPr>
+              <a:t>CARTON SPEC</a:t>
+            </a:r>
+          </a:p>
+        </p:txBody>
+      </p:sp>
+      <p:cxnSp>
+        <p:nvCxnSpPr>
+          <p:cNvPr id="16" name="Connector 15"/>
+          <p:cNvCxnSpPr/>
+          <p:nvPr/>
+        </p:nvCxnSpPr>
+        <p:spPr>
+          <a:xfrm>
+            <a:off x="6263640" y="2304288"/>
+            <a:ext cx="5212080" cy="0"/>
+          </a:xfrm>
+          <a:prstGeom prst="line">
+            <a:avLst/>
+          </a:prstGeom>
+          <a:ln w="6350">
+            <a:solidFill>
+              <a:srgbClr val="D9CFBD"/>
+            </a:solidFill>
+          </a:ln>
+        </p:spPr>
+        <p:style>
+          <a:lnRef idx="2">
+            <a:schemeClr val="accent1"/>
+          </a:lnRef>
+          <a:fillRef idx="0">
+            <a:schemeClr val="accent1"/>
+          </a:fillRef>
+          <a:effectRef idx="1">
+            <a:schemeClr val="accent1"/>
+          </a:effectRef>
+          <a:fontRef idx="minor">
+            <a:schemeClr val="tx1"/>
+          </a:fontRef>
+        </p:style>
+      </p:cxnSp>
+      <p:sp>
+        <p:nvSpPr>
+          <p:cNvPr id="17" name="TextBox 16"/>
+          <p:cNvSpPr txBox="1"/>
+          <p:nvPr/>
+        </p:nvSpPr>
+        <p:spPr>
+          <a:xfrm>
+            <a:off x="6263640" y="2395728"/>
+            <a:ext cx="5212080" cy="2121408"/>
+          </a:xfrm>
+          <a:prstGeom prst="rect">
+            <a:avLst/>
+          </a:prstGeom>
+          <a:noFill/>
+        </p:spPr>
+        <p:txBody>
+          <a:bodyPr wrap="square" lIns="0" rIns="0" tIns="0" bIns="0" anchor="t">
+            <a:spAutoFit/>
+          </a:bodyPr>
+          <a:lstStyle/>
+          <a:p>
+            <a:pPr algn="l">
+              <a:lnSpc>
+                <a:spcPct val="132000"/>
+              </a:lnSpc>
+            </a:pPr>
+            <a:r>
+              <a:rPr sz="1050" b="1" i="0">
+                <a:solidFill>
+                  <a:srgbClr val="7A3D14"/>
+                </a:solidFill>
+                <a:latin typeface="IBM Plex Sans"/>
+              </a:rPr>
+              <a:t>•  </a:t>
+            </a:r>
+            <a:r>
+              <a:rPr sz="1050" b="0" i="0">
+                <a:solidFill>
+                  <a:srgbClr val="1A1512"/>
+                </a:solidFill>
+                <a:latin typeface="IBM Plex Sans"/>
+              </a:rPr>
+              <a:t>Small carton — ~120 × 60 × 60 mm interior · fits Serum, Daily, Roots, Composure tin</a:t>
+            </a:r>
+          </a:p>
+          <a:p>
+            <a:pPr algn="l">
+              <a:lnSpc>
+                <a:spcPct val="132000"/>
+              </a:lnSpc>
+            </a:pPr>
+            <a:r>
+              <a:rPr sz="1050" b="1" i="0">
+                <a:solidFill>
+                  <a:srgbClr val="7A3D14"/>
+                </a:solidFill>
+                <a:latin typeface="IBM Plex Sans"/>
+              </a:rPr>
+              <a:t>•  </a:t>
+            </a:r>
+            <a:r>
+              <a:rPr sz="1050" b="0" i="0">
+                <a:solidFill>
+                  <a:srgbClr val="1A1512"/>
+                </a:solidFill>
+                <a:latin typeface="IBM Plex Sans"/>
+              </a:rPr>
+              <a:t>Large carton — ~180 × 110 × 50 mm interior · fits Calm kit (largest single SKU footprint)</a:t>
+            </a:r>
+          </a:p>
+          <a:p>
+            <a:pPr algn="l">
+              <a:lnSpc>
+                <a:spcPct val="132000"/>
+              </a:lnSpc>
+            </a:pPr>
+            <a:r>
+              <a:rPr sz="1050" b="1" i="0">
+                <a:solidFill>
+                  <a:srgbClr val="7A3D14"/>
+                </a:solidFill>
+                <a:latin typeface="IBM Plex Sans"/>
+              </a:rPr>
+              <a:t>•  </a:t>
+            </a:r>
+            <a:r>
+              <a:rPr sz="1050" b="0" i="0">
+                <a:solidFill>
+                  <a:srgbClr val="1A1512"/>
+                </a:solidFill>
+                <a:latin typeface="IBM Plex Sans"/>
+              </a:rPr>
+              <a:t>Style — roll-end tuck-top (RETT) or auto-bottom paperboard mailer · matte uncoated · single-color exterior in amber #7A3D14 on bone #F7F1E6 · interior message in Cormorant Garamond italic</a:t>
+            </a:r>
+          </a:p>
+          <a:p>
+            <a:pPr algn="l">
+              <a:lnSpc>
+                <a:spcPct val="132000"/>
+              </a:lnSpc>
+            </a:pPr>
+            <a:r>
+              <a:rPr sz="1050" b="1" i="0">
+                <a:solidFill>
+                  <a:srgbClr val="7A3D14"/>
+                </a:solidFill>
+                <a:latin typeface="IBM Plex Sans"/>
+              </a:rPr>
+              <a:t>•  </a:t>
+            </a:r>
+            <a:r>
+              <a:rPr sz="1050" b="0" i="0">
+                <a:solidFill>
+                  <a:srgbClr val="1A1512"/>
+                </a:solidFill>
+                <a:latin typeface="IBM Plex Sans"/>
+              </a:rPr>
+              <a:t>MOQ band — 200-400 per carton SKU (so 400-800 cartons total across both die lines for first run)</a:t>
+            </a:r>
+          </a:p>
+          <a:p>
+            <a:pPr algn="l">
+              <a:lnSpc>
+                <a:spcPct val="132000"/>
+              </a:lnSpc>
+            </a:pPr>
+            <a:r>
+              <a:rPr sz="1050" b="1" i="0">
+                <a:solidFill>
+                  <a:srgbClr val="7A3D14"/>
+                </a:solidFill>
+                <a:latin typeface="IBM Plex Sans"/>
+              </a:rPr>
+              <a:t>•  </a:t>
+            </a:r>
+            <a:r>
+              <a:rPr sz="1050" b="0" i="0">
+                <a:solidFill>
+                  <a:srgbClr val="1A1512"/>
+                </a:solidFill>
+                <a:latin typeface="IBM Plex Sans"/>
+              </a:rPr>
+              <a:t>Hard gates — US production · custom interior print · MOQ ≤ 400 per SKU · willing to run two die lines on same project</a:t>
+            </a:r>
+          </a:p>
+        </p:txBody>
+      </p:sp>
+      <p:sp>
+        <p:nvSpPr>
+          <p:cNvPr id="18" name="Rectangle 17"/>
+          <p:cNvSpPr/>
+          <p:nvPr/>
+        </p:nvSpPr>
+        <p:spPr>
+          <a:xfrm>
+            <a:off x="6035040" y="4617720"/>
+            <a:ext cx="5605272" cy="1645920"/>
+          </a:xfrm>
+          <a:prstGeom prst="rect">
+            <a:avLst/>
+          </a:prstGeom>
+          <a:solidFill>
+            <a:srgbClr val="F7F1E6"/>
+          </a:solidFill>
+          <a:ln>
+            <a:noFill/>
+          </a:ln>
+          <a:effectLst/>
+        </p:spPr>
+        <p:style>
+          <a:lnRef idx="1">
+            <a:schemeClr val="accent1"/>
+          </a:lnRef>
+          <a:fillRef idx="3">
+            <a:schemeClr val="accent1"/>
+          </a:fillRef>
+          <a:effectRef idx="2">
+            <a:schemeClr val="accent1"/>
+          </a:effectRef>
+          <a:fontRef idx="minor">
+            <a:schemeClr val="lt1"/>
+          </a:fontRef>
+        </p:style>
+        <p:txBody>
+          <a:bodyPr rtlCol="0" anchor="ctr"/>
+          <a:lstStyle/>
+          <a:p>
+            <a:pPr algn="ctr"/>
+            <a:endParaRPr/>
+          </a:p>
+        </p:txBody>
+      </p:sp>
+      <p:sp>
+        <p:nvSpPr>
+          <p:cNvPr id="19" name="TextBox 18"/>
+          <p:cNvSpPr txBox="1"/>
+          <p:nvPr/>
+        </p:nvSpPr>
+        <p:spPr>
+          <a:xfrm>
+            <a:off x="6263640" y="4754880"/>
+            <a:ext cx="5212080" cy="365760"/>
+          </a:xfrm>
+          <a:prstGeom prst="rect">
+            <a:avLst/>
+          </a:prstGeom>
+          <a:noFill/>
+        </p:spPr>
+        <p:txBody>
+          <a:bodyPr wrap="square" lIns="0" rIns="0" tIns="0" bIns="0" anchor="t">
+            <a:spAutoFit/>
+          </a:bodyPr>
+          <a:lstStyle/>
+          <a:p>
+            <a:pPr algn="l">
+              <a:lnSpc>
+                <a:spcPct val="118000"/>
+              </a:lnSpc>
+            </a:pPr>
+            <a:r>
+              <a:rPr sz="850" b="1" i="0">
+                <a:solidFill>
+                  <a:srgbClr val="7A3D14"/>
+                </a:solidFill>
+                <a:latin typeface="IBM Plex Sans"/>
+              </a:rPr>
+              <a:t>SCORING RUBRIC (0-100)</a:t>
+            </a:r>
+          </a:p>
+        </p:txBody>
+      </p:sp>
+      <p:cxnSp>
+        <p:nvCxnSpPr>
+          <p:cNvPr id="20" name="Connector 19"/>
+          <p:cNvCxnSpPr/>
+          <p:nvPr/>
+        </p:nvCxnSpPr>
+        <p:spPr>
+          <a:xfrm>
+            <a:off x="6263640" y="5047488"/>
+            <a:ext cx="5212080" cy="0"/>
+          </a:xfrm>
+          <a:prstGeom prst="line">
+            <a:avLst/>
+          </a:prstGeom>
+          <a:ln w="6350">
+            <a:solidFill>
+              <a:srgbClr val="D9CFBD"/>
+            </a:solidFill>
+          </a:ln>
+        </p:spPr>
+        <p:style>
+          <a:lnRef idx="2">
+            <a:schemeClr val="accent1"/>
+          </a:lnRef>
+          <a:fillRef idx="0">
+            <a:schemeClr val="accent1"/>
+          </a:fillRef>
+          <a:effectRef idx="1">
+            <a:schemeClr val="accent1"/>
+          </a:effectRef>
+          <a:fontRef idx="minor">
+            <a:schemeClr val="tx1"/>
+          </a:fontRef>
+        </p:style>
+      </p:cxnSp>
+      <p:sp>
+        <p:nvSpPr>
+          <p:cNvPr id="21" name="TextBox 20"/>
+          <p:cNvSpPr txBox="1"/>
+          <p:nvPr/>
+        </p:nvSpPr>
+        <p:spPr>
+          <a:xfrm>
+            <a:off x="6263640" y="5120640"/>
+            <a:ext cx="5212080" cy="1143000"/>
+          </a:xfrm>
+          <a:prstGeom prst="rect">
+            <a:avLst/>
+          </a:prstGeom>
+          <a:noFill/>
+        </p:spPr>
+        <p:txBody>
+          <a:bodyPr wrap="square" lIns="0" rIns="0" tIns="0" bIns="0" anchor="t">
+            <a:spAutoFit/>
+          </a:bodyPr>
+          <a:lstStyle/>
+          <a:p>
+            <a:pPr algn="l">
+              <a:lnSpc>
+                <a:spcPct val="130000"/>
+              </a:lnSpc>
+            </a:pPr>
+            <a:r>
+              <a:rPr sz="900" b="1" i="0">
+                <a:solidFill>
+                  <a:srgbClr val="7A3D14"/>
+                </a:solidFill>
+                <a:latin typeface="IBM Plex Sans"/>
+              </a:rPr>
+              <a:t>•  </a:t>
+            </a:r>
+            <a:r>
+              <a:rPr sz="900" b="0" i="0">
+                <a:solidFill>
+                  <a:srgbClr val="1A1512"/>
+                </a:solidFill>
+                <a:latin typeface="IBM Plex Sans"/>
+              </a:rPr>
+              <a:t>30% Customization fidelity — exterior + interior print, matte uncoated, finishes (foil/deboss optional) — Musely-quality reference match</a:t>
+            </a:r>
+          </a:p>
+          <a:p>
+            <a:pPr algn="l">
+              <a:lnSpc>
+                <a:spcPct val="130000"/>
+              </a:lnSpc>
+            </a:pPr>
+            <a:r>
+              <a:rPr sz="900" b="1" i="0">
+                <a:solidFill>
+                  <a:srgbClr val="7A3D14"/>
+                </a:solidFill>
+                <a:latin typeface="IBM Plex Sans"/>
+              </a:rPr>
+              <a:t>•  </a:t>
+            </a:r>
+            <a:r>
+              <a:rPr sz="900" b="0" i="0">
+                <a:solidFill>
+                  <a:srgbClr val="1A1512"/>
+                </a:solidFill>
+                <a:latin typeface="IBM Plex Sans"/>
+              </a:rPr>
+              <a:t>25% MOQ fit at 200-400 per SKU</a:t>
+            </a:r>
+          </a:p>
+          <a:p>
+            <a:pPr algn="l">
+              <a:lnSpc>
+                <a:spcPct val="130000"/>
+              </a:lnSpc>
+            </a:pPr>
+            <a:r>
+              <a:rPr sz="900" b="1" i="0">
+                <a:solidFill>
+                  <a:srgbClr val="7A3D14"/>
+                </a:solidFill>
+                <a:latin typeface="IBM Plex Sans"/>
+              </a:rPr>
+              <a:t>•  </a:t>
+            </a:r>
+            <a:r>
+              <a:rPr sz="900" b="0" i="0">
+                <a:solidFill>
+                  <a:srgbClr val="1A1512"/>
+                </a:solidFill>
+                <a:latin typeface="IBM Plex Sans"/>
+              </a:rPr>
+              <a:t>20% Lead time + reliability — sub-4-week production ideal</a:t>
+            </a:r>
+          </a:p>
+          <a:p>
+            <a:pPr algn="l">
+              <a:lnSpc>
+                <a:spcPct val="130000"/>
+              </a:lnSpc>
+            </a:pPr>
+            <a:r>
+              <a:rPr sz="900" b="1" i="0">
+                <a:solidFill>
+                  <a:srgbClr val="7A3D14"/>
+                </a:solidFill>
+                <a:latin typeface="IBM Plex Sans"/>
+              </a:rPr>
+              <a:t>•  </a:t>
+            </a:r>
+            <a:r>
+              <a:rPr sz="900" b="0" i="0">
+                <a:solidFill>
+                  <a:srgbClr val="1A1512"/>
+                </a:solidFill>
+                <a:latin typeface="IBM Plex Sans"/>
+              </a:rPr>
+              <a:t>15% Cost at MOQ — combined small + large at 300/300</a:t>
+            </a:r>
+          </a:p>
+          <a:p>
+            <a:pPr algn="l">
+              <a:lnSpc>
+                <a:spcPct val="130000"/>
+              </a:lnSpc>
+            </a:pPr>
+            <a:r>
+              <a:rPr sz="900" b="1" i="0">
+                <a:solidFill>
+                  <a:srgbClr val="7A3D14"/>
+                </a:solidFill>
+                <a:latin typeface="IBM Plex Sans"/>
+              </a:rPr>
+              <a:t>•  </a:t>
+            </a:r>
+            <a:r>
+              <a:rPr sz="900" b="0" i="0">
+                <a:solidFill>
+                  <a:srgbClr val="1A1512"/>
+                </a:solidFill>
+                <a:latin typeface="IBM Plex Sans"/>
+              </a:rPr>
+              <a:t>10% Sustainability + brand fit — FSC / recycled paperboard preferred (not gated)</a:t>
+            </a:r>
+          </a:p>
+        </p:txBody>
+      </p:sp>
+      <p:cxnSp>
+        <p:nvCxnSpPr>
+          <p:cNvPr id="22" name="Connector 21"/>
+          <p:cNvCxnSpPr/>
+          <p:nvPr/>
+        </p:nvCxnSpPr>
+        <p:spPr>
+          <a:xfrm>
+            <a:off x="548640" y="6446520"/>
+            <a:ext cx="11091672" cy="0"/>
+          </a:xfrm>
+          <a:prstGeom prst="line">
+            <a:avLst/>
+          </a:prstGeom>
+          <a:ln w="9525">
+            <a:solidFill>
+              <a:srgbClr val="D9CFBD"/>
+            </a:solidFill>
+          </a:ln>
+        </p:spPr>
+        <p:style>
+          <a:lnRef idx="2">
+            <a:schemeClr val="accent1"/>
+          </a:lnRef>
+          <a:fillRef idx="0">
+            <a:schemeClr val="accent1"/>
+          </a:fillRef>
+          <a:effectRef idx="1">
+            <a:schemeClr val="accent1"/>
+          </a:effectRef>
+          <a:fontRef idx="minor">
+            <a:schemeClr val="tx1"/>
+          </a:fontRef>
+        </p:style>
+      </p:cxnSp>
+      <p:sp>
+        <p:nvSpPr>
+          <p:cNvPr id="23" name="TextBox 22"/>
+          <p:cNvSpPr txBox="1"/>
+          <p:nvPr/>
+        </p:nvSpPr>
+        <p:spPr>
+          <a:xfrm>
+            <a:off x="548640" y="6519672"/>
+            <a:ext cx="7315200" cy="274320"/>
+          </a:xfrm>
+          <a:prstGeom prst="rect">
+            <a:avLst/>
+          </a:prstGeom>
+          <a:noFill/>
+        </p:spPr>
+        <p:txBody>
+          <a:bodyPr wrap="square" lIns="0" rIns="0" tIns="0" bIns="0" anchor="t">
+            <a:spAutoFit/>
+          </a:bodyPr>
+          <a:lstStyle/>
+          <a:p>
+            <a:pPr algn="l">
+              <a:lnSpc>
+                <a:spcPct val="118000"/>
+              </a:lnSpc>
+            </a:pPr>
+            <a:r>
+              <a:rPr sz="800" b="0" i="0">
+                <a:solidFill>
+                  <a:srgbClr val="6B5D4C"/>
+                </a:solidFill>
+                <a:latin typeface="IBM Plex Sans"/>
+              </a:rPr>
+              <a:t>Aplomb — Supplier shortlist for MVP market test · For Zachary Poll · Confidential</a:t>
+            </a:r>
+          </a:p>
+        </p:txBody>
+      </p:sp>
+      <p:sp>
+        <p:nvSpPr>
+          <p:cNvPr id="24" name="TextBox 23"/>
+          <p:cNvSpPr txBox="1"/>
+          <p:nvPr/>
+        </p:nvSpPr>
+        <p:spPr>
+          <a:xfrm>
+            <a:off x="10332720" y="6519672"/>
+            <a:ext cx="1371600" cy="274320"/>
+          </a:xfrm>
+          <a:prstGeom prst="rect">
+            <a:avLst/>
+          </a:prstGeom>
+          <a:noFill/>
+        </p:spPr>
+        <p:txBody>
+          <a:bodyPr wrap="square" lIns="0" rIns="0" tIns="0" bIns="0" anchor="t">
+            <a:spAutoFit/>
+          </a:bodyPr>
+          <a:lstStyle/>
+          <a:p>
+            <a:pPr algn="r">
+              <a:lnSpc>
+                <a:spcPct val="118000"/>
+              </a:lnSpc>
+            </a:pPr>
+            <a:r>
+              <a:rPr sz="800" b="0" i="0">
+                <a:solidFill>
+                  <a:srgbClr val="6B5D4C"/>
+                </a:solidFill>
+                <a:latin typeface="IBM Plex Sans"/>
+              </a:rPr>
+              <a:t>13 / 15</a:t>
+            </a:r>
+          </a:p>
+        </p:txBody>
+      </p:sp>
+    </p:spTree>
+  </p:cSld>
+  <p:clrMapOvr>
+    <a:masterClrMapping/>
+  </p:clrMapOvr>
+</p:sld>
+</file>
+
+<file path=ppt/slides/slide14.xml><?xml version="1.0" encoding="utf-8"?>
+<p:sld xmlns:a="http://schemas.openxmlformats.org/drawingml/2006/main" xmlns:p="http://schemas.openxmlformats.org/presentationml/2006/main" xmlns:r="http://schemas.openxmlformats.org/officeDocument/2006/relationships">
+  <p:cSld>
+    <p:spTree>
+      <p:nvGrpSpPr>
+        <p:cNvPr id="1" name=""/>
+        <p:cNvGrpSpPr/>
+        <p:nvPr/>
+      </p:nvGrpSpPr>
+      <p:grpSpPr>
+        <a:xfrm>
+          <a:off x="0" y="0"/>
+          <a:ext cx="0" cy="0"/>
+          <a:chOff x="0" y="0"/>
+          <a:chExt cx="0" cy="0"/>
+        </a:xfrm>
+      </p:grpSpPr>
+      <p:sp>
+        <p:nvSpPr>
+          <p:cNvPr id="2" name="Rectangle 1"/>
+          <p:cNvSpPr/>
+          <p:nvPr/>
+        </p:nvSpPr>
+        <p:spPr>
+          <a:xfrm>
+            <a:off x="0" y="0"/>
+            <a:ext cx="12192000" cy="6858000"/>
+          </a:xfrm>
+          <a:prstGeom prst="rect">
+            <a:avLst/>
+          </a:prstGeom>
+          <a:solidFill>
+            <a:srgbClr val="EFE8DC"/>
+          </a:solidFill>
+          <a:ln>
+            <a:noFill/>
+          </a:ln>
+        </p:spPr>
+        <p:style>
+          <a:lnRef idx="1">
+            <a:schemeClr val="accent1"/>
+          </a:lnRef>
+          <a:fillRef idx="3">
+            <a:schemeClr val="accent1"/>
+          </a:fillRef>
+          <a:effectRef idx="2">
+            <a:schemeClr val="accent1"/>
+          </a:effectRef>
+          <a:fontRef idx="minor">
+            <a:schemeClr val="lt1"/>
+          </a:fontRef>
+        </p:style>
+        <p:txBody>
+          <a:bodyPr rtlCol="0" anchor="ctr"/>
+          <a:lstStyle/>
+          <a:p>
+            <a:pPr algn="ctr"/>
+            <a:endParaRPr/>
+          </a:p>
+        </p:txBody>
+      </p:sp>
+      <p:cxnSp>
+        <p:nvCxnSpPr>
+          <p:cNvPr id="3" name="Connector 2"/>
+          <p:cNvCxnSpPr/>
+          <p:nvPr/>
+        </p:nvCxnSpPr>
+        <p:spPr>
+          <a:xfrm>
+            <a:off x="548640" y="502920"/>
+            <a:ext cx="11091672" cy="0"/>
+          </a:xfrm>
+          <a:prstGeom prst="line">
+            <a:avLst/>
+          </a:prstGeom>
+          <a:ln w="9525">
+            <a:solidFill>
+              <a:srgbClr val="D9CFBD"/>
+            </a:solidFill>
+          </a:ln>
+        </p:spPr>
+        <p:style>
+          <a:lnRef idx="2">
+            <a:schemeClr val="accent1"/>
+          </a:lnRef>
+          <a:fillRef idx="0">
+            <a:schemeClr val="accent1"/>
+          </a:fillRef>
+          <a:effectRef idx="1">
+            <a:schemeClr val="accent1"/>
+          </a:effectRef>
+          <a:fontRef idx="minor">
+            <a:schemeClr val="tx1"/>
+          </a:fontRef>
+        </p:style>
+      </p:cxnSp>
+      <p:sp>
+        <p:nvSpPr>
+          <p:cNvPr id="4" name="TextBox 3"/>
+          <p:cNvSpPr txBox="1"/>
+          <p:nvPr/>
+        </p:nvSpPr>
+        <p:spPr>
+          <a:xfrm>
+            <a:off x="548640" y="164592"/>
+            <a:ext cx="7315200" cy="274320"/>
+          </a:xfrm>
+          <a:prstGeom prst="rect">
+            <a:avLst/>
+          </a:prstGeom>
+          <a:noFill/>
+        </p:spPr>
+        <p:txBody>
+          <a:bodyPr wrap="square" lIns="0" rIns="0" tIns="0" bIns="0" anchor="t">
+            <a:spAutoFit/>
+          </a:bodyPr>
+          <a:lstStyle/>
+          <a:p>
+            <a:pPr algn="l">
+              <a:lnSpc>
+                <a:spcPct val="118000"/>
+              </a:lnSpc>
+            </a:pPr>
+            <a:r>
+              <a:rPr sz="900" b="0" i="0">
+                <a:solidFill>
+                  <a:srgbClr val="7A3D14"/>
+                </a:solidFill>
+                <a:latin typeface="IBM Plex Sans"/>
+              </a:rPr>
+              <a:t>§ 06 · Add-on · Two-SKU folding-mailer system</a:t>
+            </a:r>
+          </a:p>
+        </p:txBody>
+      </p:sp>
+      <p:sp>
+        <p:nvSpPr>
+          <p:cNvPr id="5" name="TextBox 4"/>
+          <p:cNvSpPr txBox="1"/>
+          <p:nvPr/>
+        </p:nvSpPr>
+        <p:spPr>
+          <a:xfrm>
+            <a:off x="10058400" y="164592"/>
+            <a:ext cx="1645920" cy="274320"/>
+          </a:xfrm>
+          <a:prstGeom prst="rect">
+            <a:avLst/>
+          </a:prstGeom>
+          <a:noFill/>
+        </p:spPr>
+        <p:txBody>
+          <a:bodyPr wrap="square" lIns="0" rIns="0" tIns="0" bIns="0" anchor="t">
+            <a:spAutoFit/>
+          </a:bodyPr>
+          <a:lstStyle/>
+          <a:p>
+            <a:pPr algn="r">
+              <a:lnSpc>
+                <a:spcPct val="118000"/>
+              </a:lnSpc>
+            </a:pPr>
+            <a:r>
+              <a:rPr sz="1100" b="0" i="1">
+                <a:solidFill>
+                  <a:srgbClr val="1A1512"/>
+                </a:solidFill>
+                <a:latin typeface="Cormorant Garamond"/>
+              </a:rPr>
+              <a:t>Aplomb</a:t>
+            </a:r>
+            <a:r>
+              <a:rPr sz="1100" b="1" i="1">
+                <a:solidFill>
+                  <a:srgbClr val="7A3D14"/>
+                </a:solidFill>
+                <a:latin typeface="Cormorant Garamond"/>
+              </a:rPr>
+              <a:t>.</a:t>
+            </a:r>
+          </a:p>
+        </p:txBody>
+      </p:sp>
+      <p:sp>
+        <p:nvSpPr>
+          <p:cNvPr id="6" name="TextBox 5"/>
+          <p:cNvSpPr txBox="1"/>
+          <p:nvPr/>
+        </p:nvSpPr>
+        <p:spPr>
+          <a:xfrm>
+            <a:off x="548640" y="777240"/>
+            <a:ext cx="10972800" cy="1097280"/>
+          </a:xfrm>
+          <a:prstGeom prst="rect">
+            <a:avLst/>
+          </a:prstGeom>
+          <a:noFill/>
+        </p:spPr>
+        <p:txBody>
+          <a:bodyPr wrap="square" lIns="0" rIns="0" tIns="0" bIns="0" anchor="t">
+            <a:spAutoFit/>
+          </a:bodyPr>
+          <a:lstStyle/>
+          <a:p>
+            <a:pPr algn="l">
+              <a:lnSpc>
+                <a:spcPct val="105000"/>
+              </a:lnSpc>
+            </a:pPr>
+            <a:r>
+              <a:rPr sz="3000" b="0" i="0">
+                <a:solidFill>
+                  <a:srgbClr val="1A1512"/>
+                </a:solidFill>
+                <a:latin typeface="Cormorant Garamond"/>
+              </a:rPr>
+              <a:t>Outer Packaging — 5 shortlisted suppliers</a:t>
+            </a:r>
+          </a:p>
+        </p:txBody>
+      </p:sp>
+      <p:sp>
+        <p:nvSpPr>
+          <p:cNvPr id="7" name="TextBox 6"/>
+          <p:cNvSpPr txBox="1"/>
+          <p:nvPr/>
+        </p:nvSpPr>
+        <p:spPr>
+          <a:xfrm>
+            <a:off x="548640" y="1508760"/>
+            <a:ext cx="10972800" cy="365760"/>
+          </a:xfrm>
+          <a:prstGeom prst="rect">
+            <a:avLst/>
+          </a:prstGeom>
+          <a:noFill/>
+        </p:spPr>
+        <p:txBody>
+          <a:bodyPr wrap="square" lIns="0" rIns="0" tIns="0" bIns="0" anchor="t">
+            <a:spAutoFit/>
+          </a:bodyPr>
+          <a:lstStyle/>
+          <a:p>
+            <a:pPr algn="l">
+              <a:lnSpc>
+                <a:spcPct val="118000"/>
+              </a:lnSpc>
+            </a:pPr>
+            <a:r>
+              <a:rPr sz="1000" b="0" i="0">
+                <a:solidFill>
+                  <a:srgbClr val="6B5D4C"/>
+                </a:solidFill>
+                <a:latin typeface="IBM Plex Sans"/>
+              </a:rPr>
+              <a:t>US folding-mailer vendors at MOQ 200-400 per SKU. Pricing reflects 300-unit run of EACH die line (small + large) — combined cost of first order.</a:t>
+            </a:r>
+          </a:p>
+        </p:txBody>
+      </p:sp>
+      <p:graphicFrame>
+        <p:nvGraphicFramePr>
+          <p:cNvPr id="8" name="Table 7"/>
+          <p:cNvGraphicFramePr>
+            <a:graphicFrameLocks noGrp="1"/>
+          </p:cNvGraphicFramePr>
+          <p:nvPr/>
+        </p:nvGraphicFramePr>
+        <p:xfrm>
+          <a:off x="548640" y="1965960"/>
+          <a:ext cx="11091667" cy="3931920"/>
+        </p:xfrm>
+        <a:graphic>
+          <a:graphicData uri="http://schemas.openxmlformats.org/drawingml/2006/table">
+            <a:tbl>
+              <a:tblPr firstRow="1" bandRow="1">
+                <a:tableStyleId>{5C22544A-7EE6-4342-B048-85BDC9FD1C3A}</a:tableStyleId>
+              </a:tblPr>
+              <a:tblGrid>
+                <a:gridCol w="1016736"/>
+                <a:gridCol w="1109167"/>
+                <a:gridCol w="1663750"/>
+                <a:gridCol w="1432674"/>
+                <a:gridCol w="508368"/>
+                <a:gridCol w="693229"/>
+                <a:gridCol w="878090"/>
+                <a:gridCol w="600798"/>
+                <a:gridCol w="3188855"/>
+              </a:tblGrid>
+              <a:tr h="655320">
+                <a:tc>
+                  <a:txBody>
+                    <a:bodyPr lIns="45000" rIns="45000" tIns="40000" bIns="40000" wrap="square"/>
+                    <a:lstStyle/>
+                    <a:p>
+                      <a:pPr algn="l">
+                        <a:lnSpc>
+                          <a:spcPct val="112000"/>
+                        </a:lnSpc>
+                      </a:pPr>
+                      <a:r>
+                        <a:rPr sz="850" b="1">
+                          <a:solidFill>
+                            <a:srgbClr val="EFE8DC"/>
+                          </a:solidFill>
+                          <a:latin typeface="IBM Plex Sans"/>
+                        </a:rPr>
+                        <a:t>Company</a:t>
+                      </a:r>
+                    </a:p>
+                  </a:txBody>
+                  <a:tcPr>
+                    <a:solidFill>
+                      <a:srgbClr val="1A1512"/>
+                    </a:solidFill>
+                  </a:tcPr>
+                </a:tc>
+                <a:tc>
+                  <a:txBody>
+                    <a:bodyPr lIns="45000" rIns="45000" tIns="40000" bIns="40000" wrap="square"/>
+                    <a:lstStyle/>
+                    <a:p>
+                      <a:pPr algn="l">
+                        <a:lnSpc>
+                          <a:spcPct val="112000"/>
+                        </a:lnSpc>
+                      </a:pPr>
+                      <a:r>
+                        <a:rPr sz="850" b="1">
+                          <a:solidFill>
+                            <a:srgbClr val="EFE8DC"/>
+                          </a:solidFill>
+                          <a:latin typeface="IBM Plex Sans"/>
+                        </a:rPr>
+                        <a:t>Website</a:t>
+                      </a:r>
+                    </a:p>
+                  </a:txBody>
+                  <a:tcPr>
+                    <a:solidFill>
+                      <a:srgbClr val="1A1512"/>
+                    </a:solidFill>
+                  </a:tcPr>
+                </a:tc>
+                <a:tc>
+                  <a:txBody>
+                    <a:bodyPr lIns="45000" rIns="45000" tIns="40000" bIns="40000" wrap="square"/>
+                    <a:lstStyle/>
+                    <a:p>
+                      <a:pPr algn="l">
+                        <a:lnSpc>
+                          <a:spcPct val="112000"/>
+                        </a:lnSpc>
+                      </a:pPr>
+                      <a:r>
+                        <a:rPr sz="850" b="1">
+                          <a:solidFill>
+                            <a:srgbClr val="EFE8DC"/>
+                          </a:solidFill>
+                          <a:latin typeface="IBM Plex Sans"/>
+                        </a:rPr>
+                        <a:t>Product</a:t>
+                      </a:r>
+                    </a:p>
+                  </a:txBody>
+                  <a:tcPr>
+                    <a:solidFill>
+                      <a:srgbClr val="1A1512"/>
+                    </a:solidFill>
+                  </a:tcPr>
+                </a:tc>
+                <a:tc>
+                  <a:txBody>
+                    <a:bodyPr lIns="45000" rIns="45000" tIns="40000" bIns="40000" wrap="square"/>
+                    <a:lstStyle/>
+                    <a:p>
+                      <a:pPr algn="l">
+                        <a:lnSpc>
+                          <a:spcPct val="112000"/>
+                        </a:lnSpc>
+                      </a:pPr>
+                      <a:r>
+                        <a:rPr sz="850" b="1">
+                          <a:solidFill>
+                            <a:srgbClr val="EFE8DC"/>
+                          </a:solidFill>
+                          <a:latin typeface="IBM Plex Sans"/>
+                        </a:rPr>
+                        <a:t>Product page</a:t>
+                      </a:r>
+                    </a:p>
+                  </a:txBody>
+                  <a:tcPr>
+                    <a:solidFill>
+                      <a:srgbClr val="1A1512"/>
+                    </a:solidFill>
+                  </a:tcPr>
+                </a:tc>
+                <a:tc>
+                  <a:txBody>
+                    <a:bodyPr lIns="45000" rIns="45000" tIns="40000" bIns="40000" wrap="square"/>
+                    <a:lstStyle/>
+                    <a:p>
+                      <a:pPr algn="l">
+                        <a:lnSpc>
+                          <a:spcPct val="112000"/>
+                        </a:lnSpc>
+                      </a:pPr>
+                      <a:r>
+                        <a:rPr sz="850" b="1">
+                          <a:solidFill>
+                            <a:srgbClr val="EFE8DC"/>
+                          </a:solidFill>
+                          <a:latin typeface="IBM Plex Sans"/>
+                        </a:rPr>
+                        <a:t>MOQ</a:t>
+                      </a:r>
+                    </a:p>
+                  </a:txBody>
+                  <a:tcPr>
+                    <a:solidFill>
+                      <a:srgbClr val="1A1512"/>
+                    </a:solidFill>
+                  </a:tcPr>
+                </a:tc>
+                <a:tc>
+                  <a:txBody>
+                    <a:bodyPr lIns="45000" rIns="45000" tIns="40000" bIns="40000" wrap="square"/>
+                    <a:lstStyle/>
+                    <a:p>
+                      <a:pPr algn="l">
+                        <a:lnSpc>
+                          <a:spcPct val="112000"/>
+                        </a:lnSpc>
+                      </a:pPr>
+                      <a:r>
+                        <a:rPr sz="850" b="1">
+                          <a:solidFill>
+                            <a:srgbClr val="EFE8DC"/>
+                          </a:solidFill>
+                          <a:latin typeface="IBM Plex Sans"/>
+                        </a:rPr>
+                        <a:t>$/unit</a:t>
+                      </a:r>
+                    </a:p>
+                  </a:txBody>
+                  <a:tcPr>
+                    <a:solidFill>
+                      <a:srgbClr val="1A1512"/>
+                    </a:solidFill>
+                  </a:tcPr>
+                </a:tc>
+                <a:tc>
+                  <a:txBody>
+                    <a:bodyPr lIns="45000" rIns="45000" tIns="40000" bIns="40000" wrap="square"/>
+                    <a:lstStyle/>
+                    <a:p>
+                      <a:pPr algn="l">
+                        <a:lnSpc>
+                          <a:spcPct val="112000"/>
+                        </a:lnSpc>
+                      </a:pPr>
+                      <a:r>
+                        <a:rPr sz="850" b="1">
+                          <a:solidFill>
+                            <a:srgbClr val="EFE8DC"/>
+                          </a:solidFill>
+                          <a:latin typeface="IBM Plex Sans"/>
+                        </a:rPr>
+                        <a:t>Total MOQ$</a:t>
+                      </a:r>
+                    </a:p>
+                  </a:txBody>
+                  <a:tcPr>
+                    <a:solidFill>
+                      <a:srgbClr val="1A1512"/>
+                    </a:solidFill>
+                  </a:tcPr>
+                </a:tc>
+                <a:tc>
+                  <a:txBody>
+                    <a:bodyPr lIns="45000" rIns="45000" tIns="40000" bIns="40000" wrap="square"/>
+                    <a:lstStyle/>
+                    <a:p>
+                      <a:pPr algn="l">
+                        <a:lnSpc>
+                          <a:spcPct val="112000"/>
+                        </a:lnSpc>
+                      </a:pPr>
+                      <a:r>
+                        <a:rPr sz="850" b="1">
+                          <a:solidFill>
+                            <a:srgbClr val="EFE8DC"/>
+                          </a:solidFill>
+                          <a:latin typeface="IBM Plex Sans"/>
+                        </a:rPr>
+                        <a:t>Score</a:t>
+                      </a:r>
+                    </a:p>
+                  </a:txBody>
+                  <a:tcPr>
+                    <a:solidFill>
+                      <a:srgbClr val="1A1512"/>
+                    </a:solidFill>
+                  </a:tcPr>
+                </a:tc>
+                <a:tc>
+                  <a:txBody>
+                    <a:bodyPr lIns="45000" rIns="45000" tIns="40000" bIns="40000" wrap="square"/>
+                    <a:lstStyle/>
+                    <a:p>
+                      <a:pPr algn="l">
+                        <a:lnSpc>
+                          <a:spcPct val="112000"/>
+                        </a:lnSpc>
+                      </a:pPr>
+                      <a:r>
+                        <a:rPr sz="850" b="1">
+                          <a:solidFill>
+                            <a:srgbClr val="EFE8DC"/>
+                          </a:solidFill>
+                          <a:latin typeface="IBM Plex Sans"/>
+                        </a:rPr>
+                        <a:t>Notes</a:t>
+                      </a:r>
+                    </a:p>
+                  </a:txBody>
+                  <a:tcPr>
+                    <a:solidFill>
+                      <a:srgbClr val="1A1512"/>
+                    </a:solidFill>
+                  </a:tcPr>
+                </a:tc>
+              </a:tr>
+              <a:tr h="655320">
                 <a:tc>
                   <a:txBody>
                     <a:bodyPr lIns="45000" rIns="45000" tIns="40000" bIns="40000" wrap="square"/>
@@ -6933,7 +8845,254 @@
                           </a:solidFill>
                           <a:latin typeface="IBM Plex Sans"/>
                         </a:rPr>
-                        <a:t>Nutribl</a:t>
+                        <a:t>Arka (Packlane)</a:t>
+                      </a:r>
+                    </a:p>
+                  </a:txBody>
+                  <a:tcPr>
+                    <a:solidFill>
+                      <a:srgbClr val="EFE8DC"/>
+                    </a:solidFill>
+                  </a:tcPr>
+                </a:tc>
+                <a:tc>
+                  <a:txBody>
+                    <a:bodyPr lIns="45000" rIns="45000" tIns="40000" bIns="40000" wrap="square"/>
+                    <a:lstStyle/>
+                    <a:p>
+                      <a:pPr algn="l">
+                        <a:lnSpc>
+                          <a:spcPct val="112000"/>
+                        </a:lnSpc>
+                      </a:pPr>
+                      <a:r>
+                        <a:rPr sz="800" b="0" u="sng">
+                          <a:solidFill>
+                            <a:srgbClr val="7A3D14"/>
+                          </a:solidFill>
+                          <a:latin typeface="IBM Plex Sans"/>
+                          <a:hlinkClick r:id="rId2"/>
+                        </a:rPr>
+                        <a:t>packlane.com</a:t>
+                      </a:r>
+                    </a:p>
+                  </a:txBody>
+                  <a:tcPr>
+                    <a:solidFill>
+                      <a:srgbClr val="EFE8DC"/>
+                    </a:solidFill>
+                  </a:tcPr>
+                </a:tc>
+                <a:tc>
+                  <a:txBody>
+                    <a:bodyPr lIns="45000" rIns="45000" tIns="40000" bIns="40000" wrap="square"/>
+                    <a:lstStyle/>
+                    <a:p>
+                      <a:pPr algn="l">
+                        <a:lnSpc>
+                          <a:spcPct val="112000"/>
+                        </a:lnSpc>
+                      </a:pPr>
+                      <a:r>
+                        <a:rPr sz="750" b="0">
+                          <a:solidFill>
+                            <a:srgbClr val="1A1512"/>
+                          </a:solidFill>
+                          <a:latin typeface="IBM Plex Sans"/>
+                        </a:rPr>
+                        <a:t>Custom paperboard mailer · full-color in/out · matte / satin / Dreamcoat finishes · custom dies</a:t>
+                      </a:r>
+                    </a:p>
+                  </a:txBody>
+                  <a:tcPr>
+                    <a:solidFill>
+                      <a:srgbClr val="EFE8DC"/>
+                    </a:solidFill>
+                  </a:tcPr>
+                </a:tc>
+                <a:tc>
+                  <a:txBody>
+                    <a:bodyPr lIns="45000" rIns="45000" tIns="40000" bIns="40000" wrap="square"/>
+                    <a:lstStyle/>
+                    <a:p>
+                      <a:pPr algn="l">
+                        <a:lnSpc>
+                          <a:spcPct val="112000"/>
+                        </a:lnSpc>
+                      </a:pPr>
+                      <a:r>
+                        <a:rPr sz="800" b="0" u="sng">
+                          <a:solidFill>
+                            <a:srgbClr val="7A3D14"/>
+                          </a:solidFill>
+                          <a:latin typeface="IBM Plex Sans"/>
+                          <a:hlinkClick r:id="rId3"/>
+                        </a:rPr>
+                        <a:t>Mailer Box (custom)</a:t>
+                      </a:r>
+                    </a:p>
+                  </a:txBody>
+                  <a:tcPr>
+                    <a:solidFill>
+                      <a:srgbClr val="EFE8DC"/>
+                    </a:solidFill>
+                  </a:tcPr>
+                </a:tc>
+                <a:tc>
+                  <a:txBody>
+                    <a:bodyPr lIns="45000" rIns="45000" tIns="40000" bIns="40000" wrap="square"/>
+                    <a:lstStyle/>
+                    <a:p>
+                      <a:pPr algn="ctr">
+                        <a:lnSpc>
+                          <a:spcPct val="112000"/>
+                        </a:lnSpc>
+                      </a:pPr>
+                      <a:r>
+                        <a:rPr sz="850" b="0">
+                          <a:solidFill>
+                            <a:srgbClr val="1A1512"/>
+                          </a:solidFill>
+                          <a:latin typeface="IBM Plex Sans"/>
+                        </a:rPr>
+                        <a:t>200</a:t>
+                      </a:r>
+                    </a:p>
+                  </a:txBody>
+                  <a:tcPr>
+                    <a:solidFill>
+                      <a:srgbClr val="EFE8DC"/>
+                    </a:solidFill>
+                  </a:tcPr>
+                </a:tc>
+                <a:tc>
+                  <a:txBody>
+                    <a:bodyPr lIns="45000" rIns="45000" tIns="40000" bIns="40000" wrap="square"/>
+                    <a:lstStyle/>
+                    <a:p>
+                      <a:pPr algn="r">
+                        <a:lnSpc>
+                          <a:spcPct val="112000"/>
+                        </a:lnSpc>
+                      </a:pPr>
+                      <a:r>
+                        <a:rPr sz="850" b="0">
+                          <a:solidFill>
+                            <a:srgbClr val="1A1512"/>
+                          </a:solidFill>
+                          <a:latin typeface="IBM Plex Sans"/>
+                        </a:rPr>
+                        <a:t>$3.40</a:t>
+                      </a:r>
+                    </a:p>
+                  </a:txBody>
+                  <a:tcPr>
+                    <a:solidFill>
+                      <a:srgbClr val="EFE8DC"/>
+                    </a:solidFill>
+                  </a:tcPr>
+                </a:tc>
+                <a:tc>
+                  <a:txBody>
+                    <a:bodyPr lIns="45000" rIns="45000" tIns="40000" bIns="40000" wrap="square"/>
+                    <a:lstStyle/>
+                    <a:p>
+                      <a:pPr algn="r">
+                        <a:lnSpc>
+                          <a:spcPct val="112000"/>
+                        </a:lnSpc>
+                      </a:pPr>
+                      <a:r>
+                        <a:rPr sz="850" b="0">
+                          <a:solidFill>
+                            <a:srgbClr val="1A1512"/>
+                          </a:solidFill>
+                          <a:latin typeface="IBM Plex Sans"/>
+                        </a:rPr>
+                        <a:t>$2,040</a:t>
+                      </a:r>
+                    </a:p>
+                  </a:txBody>
+                  <a:tcPr>
+                    <a:solidFill>
+                      <a:srgbClr val="EFE8DC"/>
+                    </a:solidFill>
+                  </a:tcPr>
+                </a:tc>
+                <a:tc>
+                  <a:txBody>
+                    <a:bodyPr lIns="45000" rIns="45000" tIns="40000" bIns="40000" wrap="square"/>
+                    <a:lstStyle/>
+                    <a:p>
+                      <a:pPr algn="ctr">
+                        <a:lnSpc>
+                          <a:spcPct val="112000"/>
+                        </a:lnSpc>
+                      </a:pPr>
+                      <a:r>
+                        <a:rPr sz="1000" b="1">
+                          <a:solidFill>
+                            <a:srgbClr val="1A1512"/>
+                          </a:solidFill>
+                          <a:latin typeface="IBM Plex Sans"/>
+                        </a:rPr>
+                        <a:t>88</a:t>
+                      </a:r>
+                    </a:p>
+                  </a:txBody>
+                  <a:tcPr>
+                    <a:solidFill>
+                      <a:srgbClr val="E6C99C"/>
+                    </a:solidFill>
+                  </a:tcPr>
+                </a:tc>
+                <a:tc>
+                  <a:txBody>
+                    <a:bodyPr lIns="45000" rIns="45000" tIns="40000" bIns="40000" wrap="square"/>
+                    <a:lstStyle/>
+                    <a:p>
+                      <a:pPr algn="l">
+                        <a:lnSpc>
+                          <a:spcPct val="112000"/>
+                        </a:lnSpc>
+                      </a:pPr>
+                      <a:r>
+                        <a:rPr sz="750" b="0">
+                          <a:solidFill>
+                            <a:srgbClr val="1A1512"/>
+                          </a:solidFill>
+                          <a:latin typeface="IBM Plex Sans"/>
+                        </a:rPr>
+                        <a:t>San Francisco · MOQ 1+ (so 200/400 trivial) · 100% US-made · ~10-day standard lead, 7-day rush · instant online proof · Shopify/WMS integration. Combined cost = 300 small + 300 large @ ~$3.40 weighted avg. RECOMMENDED lead — fastest path to Musely-style sample.</a:t>
+                      </a:r>
+                    </a:p>
+                  </a:txBody>
+                  <a:tcPr>
+                    <a:solidFill>
+                      <a:srgbClr val="EFE8DC"/>
+                    </a:solidFill>
+                  </a:tcPr>
+                </a:tc>
+              </a:tr>
+              <a:tr h="655320">
+                <a:tc>
+                  <a:txBody>
+                    <a:bodyPr lIns="45000" rIns="45000" tIns="40000" bIns="40000" wrap="square"/>
+                    <a:lstStyle/>
+                    <a:p>
+                      <a:pPr algn="l">
+                        <a:lnSpc>
+                          <a:spcPct val="112000"/>
+                        </a:lnSpc>
+                      </a:pPr>
+                      <a:r>
+                        <a:rPr sz="850" b="1">
+                          <a:solidFill>
+                            <a:srgbClr val="1A1512"/>
+                          </a:solidFill>
+                          <a:latin typeface="IBM Plex Sans"/>
+                        </a:rPr>
+                        <a:t>EcoEnclose</a:t>
                       </a:r>
                     </a:p>
                   </a:txBody>
@@ -6961,7 +9120,7 @@
                           <a:latin typeface="IBM Plex Sans"/>
                           <a:hlinkClick r:id="rId4"/>
                         </a:rPr>
-                        <a:t>nutribl.com</a:t>
+                        <a:t>ecoenclose.com</a:t>
                       </a:r>
                     </a:p>
                   </a:txBody>
@@ -6988,7 +9147,7 @@
                           </a:solidFill>
                           <a:latin typeface="IBM Plex Sans"/>
                         </a:rPr>
-                        <a:t>Stock multivitamin capsule (120+ blends with B-complex, Mg, D3); private label</a:t>
+                        <a:t>Custom shipping box · 100% recycled FSC kraft (95% post-consumer) · multi-panel interior print up to 2 colors</a:t>
                       </a:r>
                     </a:p>
                   </a:txBody>
@@ -7016,7 +9175,7 @@
                           <a:latin typeface="IBM Plex Sans"/>
                           <a:hlinkClick r:id="rId5"/>
                         </a:rPr>
-                        <a:t>Vitamin B-Complex Daily 120ct</a:t>
+                        <a:t>Custom Shipping Box</a:t>
                       </a:r>
                     </a:p>
                   </a:txBody>
@@ -7043,7 +9202,7 @@
                           </a:solidFill>
                           <a:latin typeface="IBM Plex Sans"/>
                         </a:rPr>
-                        <a:t>10</a:t>
+                        <a:t>100</a:t>
                       </a:r>
                     </a:p>
                   </a:txBody>
@@ -7070,7 +9229,7 @@
                           </a:solidFill>
                           <a:latin typeface="IBM Plex Sans"/>
                         </a:rPr>
-                        <a:t>$3.50</a:t>
+                        <a:t>$3.85</a:t>
                       </a:r>
                     </a:p>
                   </a:txBody>
@@ -7097,7 +9256,7 @@
                           </a:solidFill>
                           <a:latin typeface="IBM Plex Sans"/>
                         </a:rPr>
-                        <a:t>$35</a:t>
+                        <a:t>$2,310</a:t>
                       </a:r>
                     </a:p>
                   </a:txBody>
@@ -7124,13 +9283,13 @@
                           </a:solidFill>
                           <a:latin typeface="IBM Plex Sans"/>
                         </a:rPr>
-                        <a:t>64</a:t>
+                        <a:t>81</a:t>
                       </a:r>
                     </a:p>
                   </a:txBody>
                   <a:tcPr>
                     <a:solidFill>
-                      <a:srgbClr val="F7F1E6"/>
+                      <a:srgbClr val="E6C99C"/>
                     </a:solidFill>
                   </a:tcPr>
                 </a:tc>
@@ -7151,7 +9310,7 @@
                           </a:solidFill>
                           <a:latin typeface="IBM Plex Sans"/>
                         </a:rPr>
-                        <a:t>Lowest MOQ in market (10 units, stock formulas). UK-based; pricing behind login. Custom blends jump to £4-10K formulation cost. Stock blend works for MVP test.</a:t>
+                        <a:t>Colorado · 100% recycled · FSC SCS-COC-009926 · HydroSoy/Black-Algae inks (no plastic lamination) · made in USA. Best sustainability story; kraft-only exterior reads less Musely-velvet, more clinical/honest.</a:t>
                       </a:r>
                     </a:p>
                   </a:txBody>
@@ -7162,7 +9321,7 @@
                   </a:tcPr>
                 </a:tc>
               </a:tr>
-              <a:tr h="800100">
+              <a:tr h="655320">
                 <a:tc>
                   <a:txBody>
                     <a:bodyPr lIns="45000" rIns="45000" tIns="40000" bIns="40000" wrap="square"/>
@@ -7180,7 +9339,7 @@
                           </a:solidFill>
                           <a:latin typeface="IBM Plex Sans"/>
                         </a:rPr>
-                        <a:t>Custom Nutra</a:t>
+                        <a:t>Refine Packaging</a:t>
                       </a:r>
                     </a:p>
                   </a:txBody>
@@ -7208,7 +9367,7 @@
                           <a:latin typeface="IBM Plex Sans"/>
                           <a:hlinkClick r:id="rId6"/>
                         </a:rPr>
-                        <a:t>customnutra.com</a:t>
+                        <a:t>refinepackaging.com</a:t>
                       </a:r>
                     </a:p>
                   </a:txBody>
@@ -7235,7 +9394,7 @@
                           </a:solidFill>
                           <a:latin typeface="IBM Plex Sans"/>
                         </a:rPr>
-                        <a:t>Multivitamin capsule (250+ stock blends incl. B-complex + Mg + electrolytes)</a:t>
+                        <a:t>Custom mailer box · 10-28pt board (kraft / cardstock / e-flute corrugated) · gloss / matte / spot UV finishes · interior + exterior print</a:t>
                       </a:r>
                     </a:p>
                   </a:txBody>
@@ -7263,7 +9422,7 @@
                           <a:latin typeface="IBM Plex Sans"/>
                           <a:hlinkClick r:id="rId7"/>
                         </a:rPr>
-                        <a:t>Multivitamins PL Catalog</a:t>
+                        <a:t>Custom Mailer Box</a:t>
                       </a:r>
                     </a:p>
                   </a:txBody>
@@ -7290,7 +9449,7 @@
                           </a:solidFill>
                           <a:latin typeface="IBM Plex Sans"/>
                         </a:rPr>
-                        <a:t>48</a:t>
+                        <a:t>100</a:t>
                       </a:r>
                     </a:p>
                   </a:txBody>
@@ -7317,7 +9476,7 @@
                           </a:solidFill>
                           <a:latin typeface="IBM Plex Sans"/>
                         </a:rPr>
-                        <a:t>$2.25</a:t>
+                        <a:t>$3.20</a:t>
                       </a:r>
                     </a:p>
                   </a:txBody>
@@ -7344,7 +9503,7 @@
                           </a:solidFill>
                           <a:latin typeface="IBM Plex Sans"/>
                         </a:rPr>
-                        <a:t>$108</a:t>
+                        <a:t>$1,920</a:t>
                       </a:r>
                     </a:p>
                   </a:txBody>
@@ -7371,7 +9530,91 @@
                           </a:solidFill>
                           <a:latin typeface="IBM Plex Sans"/>
                         </a:rPr>
-                        <a:t>62</a:t>
+                        <a:t>80</a:t>
+                      </a:r>
+                    </a:p>
+                  </a:txBody>
+                  <a:tcPr>
+                    <a:solidFill>
+                      <a:srgbClr val="E6C99C"/>
+                    </a:solidFill>
+                  </a:tcPr>
+                </a:tc>
+                <a:tc>
+                  <a:txBody>
+                    <a:bodyPr lIns="45000" rIns="45000" tIns="40000" bIns="40000" wrap="square"/>
+                    <a:lstStyle/>
+                    <a:p>
+                      <a:pPr algn="l">
+                        <a:lnSpc>
+                          <a:spcPct val="112000"/>
+                        </a:lnSpc>
+                      </a:pPr>
+                      <a:r>
+                        <a:rPr sz="750" b="0">
+                          <a:solidFill>
+                            <a:srgbClr val="1A1512"/>
+                          </a:solidFill>
+                          <a:latin typeface="IBM Plex Sans"/>
+                        </a:rPr>
+                        <a:t>US-based · MOQ 100 · ~$2-5/unit at 100-500 · 8-10 day standard, 4-6 day rush · free US shipping · pre-production mockup included. Best $/unit at MOQ 200-400.</a:t>
+                      </a:r>
+                    </a:p>
+                  </a:txBody>
+                  <a:tcPr>
+                    <a:solidFill>
+                      <a:srgbClr val="EFE8DC"/>
+                    </a:solidFill>
+                  </a:tcPr>
+                </a:tc>
+              </a:tr>
+              <a:tr h="655320">
+                <a:tc>
+                  <a:txBody>
+                    <a:bodyPr lIns="45000" rIns="45000" tIns="40000" bIns="40000" wrap="square"/>
+                    <a:lstStyle/>
+                    <a:p>
+                      <a:pPr algn="l">
+                        <a:lnSpc>
+                          <a:spcPct val="112000"/>
+                        </a:lnSpc>
+                      </a:pPr>
+                      <a:r>
+                        <a:rPr sz="850" b="1">
+                          <a:solidFill>
+                            <a:srgbClr val="1A1512"/>
+                          </a:solidFill>
+                          <a:latin typeface="IBM Plex Sans"/>
+                        </a:rPr>
+                        <a:t>noissue</a:t>
+                      </a:r>
+                    </a:p>
+                  </a:txBody>
+                  <a:tcPr>
+                    <a:solidFill>
+                      <a:srgbClr val="F7F1E6"/>
+                    </a:solidFill>
+                  </a:tcPr>
+                </a:tc>
+                <a:tc>
+                  <a:txBody>
+                    <a:bodyPr lIns="45000" rIns="45000" tIns="40000" bIns="40000" wrap="square"/>
+                    <a:lstStyle/>
+                    <a:p>
+                      <a:pPr algn="l">
+                        <a:lnSpc>
+                          <a:spcPct val="112000"/>
+                        </a:lnSpc>
+                      </a:pPr>
+                      <a:r>
+                        <a:rPr sz="800" b="0" u="sng">
+                          <a:solidFill>
+                            <a:srgbClr val="7A3D14"/>
+                          </a:solidFill>
+                          <a:latin typeface="IBM Plex Sans"/>
+                          <a:hlinkClick r:id="rId8"/>
+                        </a:rPr>
+                        <a:t>noissue.co</a:t>
                       </a:r>
                     </a:p>
                   </a:txBody>
@@ -7398,7 +9641,417 @@
                           </a:solidFill>
                           <a:latin typeface="IBM Plex Sans"/>
                         </a:rPr>
-                        <a:t>Florida cGMP, FDA-registered. Stock blends only at 48 MOQ; custom GLP-1-targeted blend jumps to 1,000+ MOQ. Same supplier as hair-loss section if bundle SKUs.</a:t>
+                        <a:t>Custom mailer box · FSC-certified recycled paperboard · full color in/out · branded-DTC focus</a:t>
+                      </a:r>
+                    </a:p>
+                  </a:txBody>
+                  <a:tcPr>
+                    <a:solidFill>
+                      <a:srgbClr val="F7F1E6"/>
+                    </a:solidFill>
+                  </a:tcPr>
+                </a:tc>
+                <a:tc>
+                  <a:txBody>
+                    <a:bodyPr lIns="45000" rIns="45000" tIns="40000" bIns="40000" wrap="square"/>
+                    <a:lstStyle/>
+                    <a:p>
+                      <a:pPr algn="l">
+                        <a:lnSpc>
+                          <a:spcPct val="112000"/>
+                        </a:lnSpc>
+                      </a:pPr>
+                      <a:r>
+                        <a:rPr sz="800" b="0" u="sng">
+                          <a:solidFill>
+                            <a:srgbClr val="7A3D14"/>
+                          </a:solidFill>
+                          <a:latin typeface="IBM Plex Sans"/>
+                          <a:hlinkClick r:id="rId9"/>
+                        </a:rPr>
+                        <a:t>Custom Mailer Box</a:t>
+                      </a:r>
+                    </a:p>
+                  </a:txBody>
+                  <a:tcPr>
+                    <a:solidFill>
+                      <a:srgbClr val="F7F1E6"/>
+                    </a:solidFill>
+                  </a:tcPr>
+                </a:tc>
+                <a:tc>
+                  <a:txBody>
+                    <a:bodyPr lIns="45000" rIns="45000" tIns="40000" bIns="40000" wrap="square"/>
+                    <a:lstStyle/>
+                    <a:p>
+                      <a:pPr algn="ctr">
+                        <a:lnSpc>
+                          <a:spcPct val="112000"/>
+                        </a:lnSpc>
+                      </a:pPr>
+                      <a:r>
+                        <a:rPr sz="850" b="0">
+                          <a:solidFill>
+                            <a:srgbClr val="1A1512"/>
+                          </a:solidFill>
+                          <a:latin typeface="IBM Plex Sans"/>
+                        </a:rPr>
+                        <a:t>100</a:t>
+                      </a:r>
+                    </a:p>
+                  </a:txBody>
+                  <a:tcPr>
+                    <a:solidFill>
+                      <a:srgbClr val="F7F1E6"/>
+                    </a:solidFill>
+                  </a:tcPr>
+                </a:tc>
+                <a:tc>
+                  <a:txBody>
+                    <a:bodyPr lIns="45000" rIns="45000" tIns="40000" bIns="40000" wrap="square"/>
+                    <a:lstStyle/>
+                    <a:p>
+                      <a:pPr algn="r">
+                        <a:lnSpc>
+                          <a:spcPct val="112000"/>
+                        </a:lnSpc>
+                      </a:pPr>
+                      <a:r>
+                        <a:rPr sz="850" b="0">
+                          <a:solidFill>
+                            <a:srgbClr val="1A1512"/>
+                          </a:solidFill>
+                          <a:latin typeface="IBM Plex Sans"/>
+                        </a:rPr>
+                        <a:t>$4.10</a:t>
+                      </a:r>
+                    </a:p>
+                  </a:txBody>
+                  <a:tcPr>
+                    <a:solidFill>
+                      <a:srgbClr val="F7F1E6"/>
+                    </a:solidFill>
+                  </a:tcPr>
+                </a:tc>
+                <a:tc>
+                  <a:txBody>
+                    <a:bodyPr lIns="45000" rIns="45000" tIns="40000" bIns="40000" wrap="square"/>
+                    <a:lstStyle/>
+                    <a:p>
+                      <a:pPr algn="r">
+                        <a:lnSpc>
+                          <a:spcPct val="112000"/>
+                        </a:lnSpc>
+                      </a:pPr>
+                      <a:r>
+                        <a:rPr sz="850" b="0">
+                          <a:solidFill>
+                            <a:srgbClr val="1A1512"/>
+                          </a:solidFill>
+                          <a:latin typeface="IBM Plex Sans"/>
+                        </a:rPr>
+                        <a:t>$2,460</a:t>
+                      </a:r>
+                    </a:p>
+                  </a:txBody>
+                  <a:tcPr>
+                    <a:solidFill>
+                      <a:srgbClr val="F7F1E6"/>
+                    </a:solidFill>
+                  </a:tcPr>
+                </a:tc>
+                <a:tc>
+                  <a:txBody>
+                    <a:bodyPr lIns="45000" rIns="45000" tIns="40000" bIns="40000" wrap="square"/>
+                    <a:lstStyle/>
+                    <a:p>
+                      <a:pPr algn="ctr">
+                        <a:lnSpc>
+                          <a:spcPct val="112000"/>
+                        </a:lnSpc>
+                      </a:pPr>
+                      <a:r>
+                        <a:rPr sz="1000" b="1">
+                          <a:solidFill>
+                            <a:srgbClr val="1A1512"/>
+                          </a:solidFill>
+                          <a:latin typeface="IBM Plex Sans"/>
+                        </a:rPr>
+                        <a:t>78</a:t>
+                      </a:r>
+                    </a:p>
+                  </a:txBody>
+                  <a:tcPr>
+                    <a:solidFill>
+                      <a:srgbClr val="F7F1E6"/>
+                    </a:solidFill>
+                  </a:tcPr>
+                </a:tc>
+                <a:tc>
+                  <a:txBody>
+                    <a:bodyPr lIns="45000" rIns="45000" tIns="40000" bIns="40000" wrap="square"/>
+                    <a:lstStyle/>
+                    <a:p>
+                      <a:pPr algn="l">
+                        <a:lnSpc>
+                          <a:spcPct val="112000"/>
+                        </a:lnSpc>
+                      </a:pPr>
+                      <a:r>
+                        <a:rPr sz="750" b="0">
+                          <a:solidFill>
+                            <a:srgbClr val="1A1512"/>
+                          </a:solidFill>
+                          <a:latin typeface="IBM Plex Sans"/>
+                        </a:rPr>
+                        <a:t>US distribution · MOQ 100 · FSC + carbon-neutral · in-house brand-design support (closest to Musely's White-and-Salt-led aesthetic). 4-6 wk lead is the trade-off vs. Arka. Premium feel.</a:t>
+                      </a:r>
+                    </a:p>
+                  </a:txBody>
+                  <a:tcPr>
+                    <a:solidFill>
+                      <a:srgbClr val="F7F1E6"/>
+                    </a:solidFill>
+                  </a:tcPr>
+                </a:tc>
+              </a:tr>
+              <a:tr h="655320">
+                <a:tc>
+                  <a:txBody>
+                    <a:bodyPr lIns="45000" rIns="45000" tIns="40000" bIns="40000" wrap="square"/>
+                    <a:lstStyle/>
+                    <a:p>
+                      <a:pPr algn="l">
+                        <a:lnSpc>
+                          <a:spcPct val="112000"/>
+                        </a:lnSpc>
+                      </a:pPr>
+                      <a:r>
+                        <a:rPr sz="850" b="1">
+                          <a:solidFill>
+                            <a:srgbClr val="1A1512"/>
+                          </a:solidFill>
+                          <a:latin typeface="IBM Plex Sans"/>
+                        </a:rPr>
+                        <a:t>PakFactory</a:t>
+                      </a:r>
+                    </a:p>
+                  </a:txBody>
+                  <a:tcPr>
+                    <a:solidFill>
+                      <a:srgbClr val="EFE8DC"/>
+                    </a:solidFill>
+                  </a:tcPr>
+                </a:tc>
+                <a:tc>
+                  <a:txBody>
+                    <a:bodyPr lIns="45000" rIns="45000" tIns="40000" bIns="40000" wrap="square"/>
+                    <a:lstStyle/>
+                    <a:p>
+                      <a:pPr algn="l">
+                        <a:lnSpc>
+                          <a:spcPct val="112000"/>
+                        </a:lnSpc>
+                      </a:pPr>
+                      <a:r>
+                        <a:rPr sz="800" b="0" u="sng">
+                          <a:solidFill>
+                            <a:srgbClr val="7A3D14"/>
+                          </a:solidFill>
+                          <a:latin typeface="IBM Plex Sans"/>
+                          <a:hlinkClick r:id="rId10"/>
+                        </a:rPr>
+                        <a:t>pakfactory.com</a:t>
+                      </a:r>
+                    </a:p>
+                  </a:txBody>
+                  <a:tcPr>
+                    <a:solidFill>
+                      <a:srgbClr val="EFE8DC"/>
+                    </a:solidFill>
+                  </a:tcPr>
+                </a:tc>
+                <a:tc>
+                  <a:txBody>
+                    <a:bodyPr lIns="45000" rIns="45000" tIns="40000" bIns="40000" wrap="square"/>
+                    <a:lstStyle/>
+                    <a:p>
+                      <a:pPr algn="l">
+                        <a:lnSpc>
+                          <a:spcPct val="112000"/>
+                        </a:lnSpc>
+                      </a:pPr>
+                      <a:r>
+                        <a:rPr sz="750" b="0">
+                          <a:solidFill>
+                            <a:srgbClr val="1A1512"/>
+                          </a:solidFill>
+                          <a:latin typeface="IBM Plex Sans"/>
+                        </a:rPr>
+                        <a:t>Custom folding paperboard carton · premium finishes (soft-touch, foil, emboss, UV) · multiple paperboard substrates</a:t>
+                      </a:r>
+                    </a:p>
+                  </a:txBody>
+                  <a:tcPr>
+                    <a:solidFill>
+                      <a:srgbClr val="EFE8DC"/>
+                    </a:solidFill>
+                  </a:tcPr>
+                </a:tc>
+                <a:tc>
+                  <a:txBody>
+                    <a:bodyPr lIns="45000" rIns="45000" tIns="40000" bIns="40000" wrap="square"/>
+                    <a:lstStyle/>
+                    <a:p>
+                      <a:pPr algn="l">
+                        <a:lnSpc>
+                          <a:spcPct val="112000"/>
+                        </a:lnSpc>
+                      </a:pPr>
+                      <a:r>
+                        <a:rPr sz="800" b="0" u="sng">
+                          <a:solidFill>
+                            <a:srgbClr val="7A3D14"/>
+                          </a:solidFill>
+                          <a:latin typeface="IBM Plex Sans"/>
+                          <a:hlinkClick r:id="rId11"/>
+                        </a:rPr>
+                        <a:t>Folding Carton &amp; Paperboard Boxes</a:t>
+                      </a:r>
+                    </a:p>
+                  </a:txBody>
+                  <a:tcPr>
+                    <a:solidFill>
+                      <a:srgbClr val="EFE8DC"/>
+                    </a:solidFill>
+                  </a:tcPr>
+                </a:tc>
+                <a:tc>
+                  <a:txBody>
+                    <a:bodyPr lIns="45000" rIns="45000" tIns="40000" bIns="40000" wrap="square"/>
+                    <a:lstStyle/>
+                    <a:p>
+                      <a:pPr algn="ctr">
+                        <a:lnSpc>
+                          <a:spcPct val="112000"/>
+                        </a:lnSpc>
+                      </a:pPr>
+                      <a:r>
+                        <a:rPr sz="850" b="0">
+                          <a:solidFill>
+                            <a:srgbClr val="1A1512"/>
+                          </a:solidFill>
+                          <a:latin typeface="IBM Plex Sans"/>
+                        </a:rPr>
+                        <a:t>100</a:t>
+                      </a:r>
+                    </a:p>
+                  </a:txBody>
+                  <a:tcPr>
+                    <a:solidFill>
+                      <a:srgbClr val="EFE8DC"/>
+                    </a:solidFill>
+                  </a:tcPr>
+                </a:tc>
+                <a:tc>
+                  <a:txBody>
+                    <a:bodyPr lIns="45000" rIns="45000" tIns="40000" bIns="40000" wrap="square"/>
+                    <a:lstStyle/>
+                    <a:p>
+                      <a:pPr algn="r">
+                        <a:lnSpc>
+                          <a:spcPct val="112000"/>
+                        </a:lnSpc>
+                      </a:pPr>
+                      <a:r>
+                        <a:rPr sz="850" b="0">
+                          <a:solidFill>
+                            <a:srgbClr val="1A1512"/>
+                          </a:solidFill>
+                          <a:latin typeface="IBM Plex Sans"/>
+                        </a:rPr>
+                        <a:t>$2.95</a:t>
+                      </a:r>
+                    </a:p>
+                  </a:txBody>
+                  <a:tcPr>
+                    <a:solidFill>
+                      <a:srgbClr val="EFE8DC"/>
+                    </a:solidFill>
+                  </a:tcPr>
+                </a:tc>
+                <a:tc>
+                  <a:txBody>
+                    <a:bodyPr lIns="45000" rIns="45000" tIns="40000" bIns="40000" wrap="square"/>
+                    <a:lstStyle/>
+                    <a:p>
+                      <a:pPr algn="r">
+                        <a:lnSpc>
+                          <a:spcPct val="112000"/>
+                        </a:lnSpc>
+                      </a:pPr>
+                      <a:r>
+                        <a:rPr sz="850" b="0">
+                          <a:solidFill>
+                            <a:srgbClr val="1A1512"/>
+                          </a:solidFill>
+                          <a:latin typeface="IBM Plex Sans"/>
+                        </a:rPr>
+                        <a:t>$1,770</a:t>
+                      </a:r>
+                    </a:p>
+                  </a:txBody>
+                  <a:tcPr>
+                    <a:solidFill>
+                      <a:srgbClr val="EFE8DC"/>
+                    </a:solidFill>
+                  </a:tcPr>
+                </a:tc>
+                <a:tc>
+                  <a:txBody>
+                    <a:bodyPr lIns="45000" rIns="45000" tIns="40000" bIns="40000" wrap="square"/>
+                    <a:lstStyle/>
+                    <a:p>
+                      <a:pPr algn="ctr">
+                        <a:lnSpc>
+                          <a:spcPct val="112000"/>
+                        </a:lnSpc>
+                      </a:pPr>
+                      <a:r>
+                        <a:rPr sz="1000" b="1">
+                          <a:solidFill>
+                            <a:srgbClr val="1A1512"/>
+                          </a:solidFill>
+                          <a:latin typeface="IBM Plex Sans"/>
+                        </a:rPr>
+                        <a:t>75</a:t>
+                      </a:r>
+                    </a:p>
+                  </a:txBody>
+                  <a:tcPr>
+                    <a:solidFill>
+                      <a:srgbClr val="F7F1E6"/>
+                    </a:solidFill>
+                  </a:tcPr>
+                </a:tc>
+                <a:tc>
+                  <a:txBody>
+                    <a:bodyPr lIns="45000" rIns="45000" tIns="40000" bIns="40000" wrap="square"/>
+                    <a:lstStyle/>
+                    <a:p>
+                      <a:pPr algn="l">
+                        <a:lnSpc>
+                          <a:spcPct val="112000"/>
+                        </a:lnSpc>
+                      </a:pPr>
+                      <a:r>
+                        <a:rPr sz="750" b="0">
+                          <a:solidFill>
+                            <a:srgbClr val="1A1512"/>
+                          </a:solidFill>
+                          <a:latin typeface="IBM Plex Sans"/>
+                        </a:rPr>
+                        <a:t>HQ Markham, Ontario (Canada — soft-fails the US-only gate; included for cost-comparison). Best premium-finish range (soft-touch matches Musely's tactile feel). 3-4 wk lead. Pakible (US, RFQ-only) is a sixth alternative if needed.</a:t>
                       </a:r>
                     </a:p>
                   </a:txBody>
@@ -7421,8 +10074,8 @@
         </p:nvSpPr>
         <p:spPr>
           <a:xfrm>
-            <a:off x="548640" y="5440680"/>
-            <a:ext cx="11091672" cy="868680"/>
+            <a:off x="548640" y="5943600"/>
+            <a:ext cx="11091672" cy="502920"/>
           </a:xfrm>
           <a:prstGeom prst="rect">
             <a:avLst/>
@@ -7466,7 +10119,7 @@
         </p:nvSpPr>
         <p:spPr>
           <a:xfrm>
-            <a:off x="777240" y="5577840"/>
+            <a:off x="777240" y="6035040"/>
             <a:ext cx="10607040" cy="640080"/>
           </a:xfrm>
           <a:prstGeom prst="rect">
@@ -7501,7 +10154,7 @@
                 </a:solidFill>
                 <a:latin typeface="IBM Plex Sans"/>
               </a:rPr>
-              <a:t>Aogubio (Xi'an)</a:t>
+              <a:t>Arka (Packlane)</a:t>
             </a:r>
             <a:r>
               <a:rPr sz="1100" b="0" i="0">
@@ -7510,7 +10163,7 @@
                 </a:solidFill>
                 <a:latin typeface="IBM Plex Sans"/>
               </a:rPr>
-              <a:t> · score 71/100 · MOQ 100 · $1.75/unit · total $175</a:t>
+              <a:t> · score 88/100 · MOQ 200 · $3.40/unit · total $2,040</a:t>
             </a:r>
           </a:p>
         </p:txBody>
@@ -7623,7 +10276,7 @@
                 </a:solidFill>
                 <a:latin typeface="IBM Plex Sans"/>
               </a:rPr>
-              <a:t>12 / 13</a:t>
+              <a:t>14 / 15</a:t>
             </a:r>
           </a:p>
         </p:txBody>
@@ -7636,7 +10289,7 @@
 </p:sld>
 </file>
 
-<file path=ppt/slides/slide13.xml><?xml version="1.0" encoding="utf-8"?>
+<file path=ppt/slides/slide15.xml><?xml version="1.0" encoding="utf-8"?>
 <p:sld xmlns:a="http://schemas.openxmlformats.org/drawingml/2006/main" xmlns:p="http://schemas.openxmlformats.org/presentationml/2006/main" xmlns:r="http://schemas.openxmlformats.org/officeDocument/2006/relationships">
   <p:cSld>
     <p:spTree>
@@ -7766,7 +10419,7 @@
                 </a:solidFill>
                 <a:latin typeface="IBM Plex Sans"/>
               </a:rPr>
-              <a:t>§ 06 · Next steps</a:t>
+              <a:t>§ 07 · Next steps</a:t>
             </a:r>
           </a:p>
         </p:txBody>
@@ -8168,6 +10821,40 @@
               <a:t>  ·  score 71/100  ·  MOQ 100  ·  total $175</a:t>
             </a:r>
           </a:p>
+          <a:p>
+            <a:pPr algn="l">
+              <a:lnSpc>
+                <a:spcPct val="155000"/>
+              </a:lnSpc>
+            </a:pPr>
+            <a:r>
+              <a:rPr sz="1100" b="0" i="0">
+                <a:solidFill>
+                  <a:srgbClr val="6B5D4C"/>
+                </a:solidFill>
+                <a:latin typeface="IBM Plex Sans"/>
+              </a:rPr>
+              <a:t>Outer Packaging          </a:t>
+            </a:r>
+            <a:r>
+              <a:rPr sz="1200" b="1" i="0">
+                <a:solidFill>
+                  <a:srgbClr val="1A1512"/>
+                </a:solidFill>
+                <a:latin typeface="IBM Plex Sans"/>
+              </a:rPr>
+              <a:t>Arka (Packlane)</a:t>
+            </a:r>
+            <a:r>
+              <a:rPr sz="1050" b="0" i="0">
+                <a:solidFill>
+                  <a:srgbClr val="6B5D4C"/>
+                </a:solidFill>
+                <a:latin typeface="IBM Plex Sans"/>
+              </a:rPr>
+              <a:t>  ·  score 88/100  ·  MOQ 200  ·  total $2,040</a:t>
+            </a:r>
+          </a:p>
         </p:txBody>
       </p:sp>
       <p:sp>
@@ -8332,7 +11019,7 @@
                 </a:solidFill>
                 <a:latin typeface="IBM Plex Sans"/>
               </a:rPr>
-              <a:t>Send the RFQ template (in AFTER_supplier_directory_v1.xlsx Sheet 5) to all 5 lead suppliers this week.</a:t>
+              <a:t>Send the RFQ template (in AFTER_supplier_directory_v1.xlsx Sheet 5) to all 6 lead suppliers this week — five formula vendors plus the packaging lead (Arka).</a:t>
             </a:r>
           </a:p>
           <a:p>
@@ -8357,7 +11044,7 @@
                 </a:solidFill>
                 <a:latin typeface="IBM Plex Sans"/>
               </a:rPr>
-              <a:t>Negotiate sample units (3–5 per SKU) for in-house QC before committing to MOQ runs.</a:t>
+              <a:t>Order packaging samples in parallel with formula RFQs: one small carton + one large carton from the top two packaging vendors (Arka + Refine Packaging) at $0 commitment to validate the Musely-style tactile quality.</a:t>
             </a:r>
           </a:p>
           <a:p>
@@ -8382,7 +11069,7 @@
                 </a:solidFill>
                 <a:latin typeface="IBM Plex Sans"/>
               </a:rPr>
-              <a:t>Lock packaging + label artwork with the brand designer before the first PO — fastest path to shippable inventory.</a:t>
+              <a:t>Negotiate sample units (3–5 per SKU) for in-house QC before committing to MOQ runs on the formula side.</a:t>
             </a:r>
           </a:p>
           <a:p>
@@ -8399,6 +11086,31 @@
                 <a:latin typeface="IBM Plex Sans"/>
               </a:rPr>
               <a:t>4.  </a:t>
+            </a:r>
+            <a:r>
+              <a:rPr sz="1050" b="0" i="0">
+                <a:solidFill>
+                  <a:srgbClr val="1A1512"/>
+                </a:solidFill>
+                <a:latin typeface="IBM Plex Sans"/>
+              </a:rPr>
+              <a:t>Lock packaging + label artwork with the brand designer before the first PO — fastest path to shippable inventory.</a:t>
+            </a:r>
+          </a:p>
+          <a:p>
+            <a:pPr algn="l">
+              <a:lnSpc>
+                <a:spcPct val="140000"/>
+              </a:lnSpc>
+            </a:pPr>
+            <a:r>
+              <a:rPr sz="1050" b="1" i="0">
+                <a:solidFill>
+                  <a:srgbClr val="7A3D14"/>
+                </a:solidFill>
+                <a:latin typeface="IBM Plex Sans"/>
+              </a:rPr>
+              <a:t>5.  </a:t>
             </a:r>
             <a:r>
               <a:rPr sz="1050" b="0" i="0">
@@ -8520,7 +11232,7 @@
                 </a:solidFill>
                 <a:latin typeface="IBM Plex Sans"/>
               </a:rPr>
-              <a:t>13 / 13</a:t>
+              <a:t>15 / 15</a:t>
             </a:r>
           </a:p>
         </p:txBody>
@@ -9565,7 +12277,7 @@
                 </a:solidFill>
                 <a:latin typeface="IBM Plex Sans"/>
               </a:rPr>
-              <a:t>02 / 13</a:t>
+              <a:t>02 / 15</a:t>
             </a:r>
           </a:p>
         </p:txBody>
@@ -10525,7 +13237,7 @@
                 </a:solidFill>
                 <a:latin typeface="IBM Plex Sans"/>
               </a:rPr>
-              <a:t>03 / 13</a:t>
+              <a:t>03 / 15</a:t>
             </a:r>
           </a:p>
         </p:txBody>
@@ -11871,7 +14583,7 @@
         </p:nvSpPr>
         <p:spPr>
           <a:xfrm>
-            <a:off x="777240" y="5577840"/>
+            <a:off x="777240" y="5532120"/>
             <a:ext cx="10607040" cy="640080"/>
           </a:xfrm>
           <a:prstGeom prst="rect">
@@ -12028,7 +14740,7 @@
                 </a:solidFill>
                 <a:latin typeface="IBM Plex Sans"/>
               </a:rPr>
-              <a:t>04 / 13</a:t>
+              <a:t>04 / 15</a:t>
             </a:r>
           </a:p>
         </p:txBody>
@@ -12988,7 +15700,7 @@
                 </a:solidFill>
                 <a:latin typeface="IBM Plex Sans"/>
               </a:rPr>
-              <a:t>05 / 13</a:t>
+              <a:t>05 / 15</a:t>
             </a:r>
           </a:p>
         </p:txBody>
@@ -13840,7 +16552,7 @@
         </p:nvSpPr>
         <p:spPr>
           <a:xfrm>
-            <a:off x="777240" y="5577840"/>
+            <a:off x="777240" y="5532120"/>
             <a:ext cx="10607040" cy="640080"/>
           </a:xfrm>
           <a:prstGeom prst="rect">
@@ -13997,7 +16709,7 @@
                 </a:solidFill>
                 <a:latin typeface="IBM Plex Sans"/>
               </a:rPr>
-              <a:t>06 / 13</a:t>
+              <a:t>06 / 15</a:t>
             </a:r>
           </a:p>
         </p:txBody>
@@ -14957,7 +17669,7 @@
                 </a:solidFill>
                 <a:latin typeface="IBM Plex Sans"/>
               </a:rPr>
-              <a:t>07 / 13</a:t>
+              <a:t>07 / 15</a:t>
             </a:r>
           </a:p>
         </p:txBody>
@@ -15187,7 +17899,7 @@
                 </a:solidFill>
                 <a:latin typeface="Cormorant Garamond"/>
               </a:rPr>
-              <a:t>Hair Loss — 2 shortlisted suppliers</a:t>
+              <a:t>Hair Loss — 1 shortlisted supplier</a:t>
             </a:r>
           </a:p>
         </p:txBody>
@@ -15260,7 +17972,7 @@
                 <a:gridCol w="600798"/>
                 <a:gridCol w="3188855"/>
               </a:tblGrid>
-              <a:tr h="1066800">
+              <a:tr h="1600200">
                 <a:tc>
                   <a:txBody>
                     <a:bodyPr lIns="45000" rIns="45000" tIns="40000" bIns="40000" wrap="square"/>
@@ -15505,7 +18217,7 @@
                   </a:tcPr>
                 </a:tc>
               </a:tr>
-              <a:tr h="1066800">
+              <a:tr h="1600200">
                 <a:tc>
                   <a:txBody>
                     <a:bodyPr lIns="45000" rIns="45000" tIns="40000" bIns="40000" wrap="square"/>
@@ -15752,253 +18464,6 @@
                   </a:tcPr>
                 </a:tc>
               </a:tr>
-              <a:tr h="1066800">
-                <a:tc>
-                  <a:txBody>
-                    <a:bodyPr lIns="45000" rIns="45000" tIns="40000" bIns="40000" wrap="square"/>
-                    <a:lstStyle/>
-                    <a:p>
-                      <a:pPr algn="l">
-                        <a:lnSpc>
-                          <a:spcPct val="112000"/>
-                        </a:lnSpc>
-                      </a:pPr>
-                      <a:r>
-                        <a:rPr sz="850" b="1">
-                          <a:solidFill>
-                            <a:srgbClr val="1A1512"/>
-                          </a:solidFill>
-                          <a:latin typeface="IBM Plex Sans"/>
-                        </a:rPr>
-                        <a:t>Custom Nutra</a:t>
-                      </a:r>
-                    </a:p>
-                  </a:txBody>
-                  <a:tcPr>
-                    <a:solidFill>
-                      <a:srgbClr val="F7F1E6"/>
-                    </a:solidFill>
-                  </a:tcPr>
-                </a:tc>
-                <a:tc>
-                  <a:txBody>
-                    <a:bodyPr lIns="45000" rIns="45000" tIns="40000" bIns="40000" wrap="square"/>
-                    <a:lstStyle/>
-                    <a:p>
-                      <a:pPr algn="l">
-                        <a:lnSpc>
-                          <a:spcPct val="112000"/>
-                        </a:lnSpc>
-                      </a:pPr>
-                      <a:r>
-                        <a:rPr sz="800" b="0" u="sng">
-                          <a:solidFill>
-                            <a:srgbClr val="7A3D14"/>
-                          </a:solidFill>
-                          <a:latin typeface="IBM Plex Sans"/>
-                          <a:hlinkClick r:id="rId4"/>
-                        </a:rPr>
-                        <a:t>customnutra.com</a:t>
-                      </a:r>
-                    </a:p>
-                  </a:txBody>
-                  <a:tcPr>
-                    <a:solidFill>
-                      <a:srgbClr val="F7F1E6"/>
-                    </a:solidFill>
-                  </a:tcPr>
-                </a:tc>
-                <a:tc>
-                  <a:txBody>
-                    <a:bodyPr lIns="45000" rIns="45000" tIns="40000" bIns="40000" wrap="square"/>
-                    <a:lstStyle/>
-                    <a:p>
-                      <a:pPr algn="l">
-                        <a:lnSpc>
-                          <a:spcPct val="112000"/>
-                        </a:lnSpc>
-                      </a:pPr>
-                      <a:r>
-                        <a:rPr sz="750" b="0">
-                          <a:solidFill>
-                            <a:srgbClr val="1A1512"/>
-                          </a:solidFill>
-                          <a:latin typeface="IBM Plex Sans"/>
-                        </a:rPr>
-                        <a:t>Biotin + collagen capsule (250+ stock blends); custom B-vitamin add-on</a:t>
-                      </a:r>
-                    </a:p>
-                  </a:txBody>
-                  <a:tcPr>
-                    <a:solidFill>
-                      <a:srgbClr val="F7F1E6"/>
-                    </a:solidFill>
-                  </a:tcPr>
-                </a:tc>
-                <a:tc>
-                  <a:txBody>
-                    <a:bodyPr lIns="45000" rIns="45000" tIns="40000" bIns="40000" wrap="square"/>
-                    <a:lstStyle/>
-                    <a:p>
-                      <a:pPr algn="l">
-                        <a:lnSpc>
-                          <a:spcPct val="112000"/>
-                        </a:lnSpc>
-                      </a:pPr>
-                      <a:r>
-                        <a:rPr sz="800" b="0" u="sng">
-                          <a:solidFill>
-                            <a:srgbClr val="7A3D14"/>
-                          </a:solidFill>
-                          <a:latin typeface="IBM Plex Sans"/>
-                          <a:hlinkClick r:id="rId5"/>
-                        </a:rPr>
-                        <a:t>Hair, Skin &amp; Nail PL Catalog</a:t>
-                      </a:r>
-                    </a:p>
-                  </a:txBody>
-                  <a:tcPr>
-                    <a:solidFill>
-                      <a:srgbClr val="F7F1E6"/>
-                    </a:solidFill>
-                  </a:tcPr>
-                </a:tc>
-                <a:tc>
-                  <a:txBody>
-                    <a:bodyPr lIns="45000" rIns="45000" tIns="40000" bIns="40000" wrap="square"/>
-                    <a:lstStyle/>
-                    <a:p>
-                      <a:pPr algn="ctr">
-                        <a:lnSpc>
-                          <a:spcPct val="112000"/>
-                        </a:lnSpc>
-                      </a:pPr>
-                      <a:r>
-                        <a:rPr sz="850" b="0">
-                          <a:solidFill>
-                            <a:srgbClr val="1A1512"/>
-                          </a:solidFill>
-                          <a:latin typeface="IBM Plex Sans"/>
-                        </a:rPr>
-                        <a:t>48</a:t>
-                      </a:r>
-                    </a:p>
-                  </a:txBody>
-                  <a:tcPr>
-                    <a:solidFill>
-                      <a:srgbClr val="F7F1E6"/>
-                    </a:solidFill>
-                  </a:tcPr>
-                </a:tc>
-                <a:tc>
-                  <a:txBody>
-                    <a:bodyPr lIns="45000" rIns="45000" tIns="40000" bIns="40000" wrap="square"/>
-                    <a:lstStyle/>
-                    <a:p>
-                      <a:pPr algn="r">
-                        <a:lnSpc>
-                          <a:spcPct val="112000"/>
-                        </a:lnSpc>
-                      </a:pPr>
-                      <a:r>
-                        <a:rPr sz="850" b="0">
-                          <a:solidFill>
-                            <a:srgbClr val="1A1512"/>
-                          </a:solidFill>
-                          <a:latin typeface="IBM Plex Sans"/>
-                        </a:rPr>
-                        <a:t>$2.50</a:t>
-                      </a:r>
-                    </a:p>
-                  </a:txBody>
-                  <a:tcPr>
-                    <a:solidFill>
-                      <a:srgbClr val="F7F1E6"/>
-                    </a:solidFill>
-                  </a:tcPr>
-                </a:tc>
-                <a:tc>
-                  <a:txBody>
-                    <a:bodyPr lIns="45000" rIns="45000" tIns="40000" bIns="40000" wrap="square"/>
-                    <a:lstStyle/>
-                    <a:p>
-                      <a:pPr algn="r">
-                        <a:lnSpc>
-                          <a:spcPct val="112000"/>
-                        </a:lnSpc>
-                      </a:pPr>
-                      <a:r>
-                        <a:rPr sz="850" b="0">
-                          <a:solidFill>
-                            <a:srgbClr val="1A1512"/>
-                          </a:solidFill>
-                          <a:latin typeface="IBM Plex Sans"/>
-                        </a:rPr>
-                        <a:t>$120</a:t>
-                      </a:r>
-                    </a:p>
-                  </a:txBody>
-                  <a:tcPr>
-                    <a:solidFill>
-                      <a:srgbClr val="F7F1E6"/>
-                    </a:solidFill>
-                  </a:tcPr>
-                </a:tc>
-                <a:tc>
-                  <a:txBody>
-                    <a:bodyPr lIns="45000" rIns="45000" tIns="40000" bIns="40000" wrap="square"/>
-                    <a:lstStyle/>
-                    <a:p>
-                      <a:pPr algn="ctr">
-                        <a:lnSpc>
-                          <a:spcPct val="112000"/>
-                        </a:lnSpc>
-                      </a:pPr>
-                      <a:r>
-                        <a:rPr sz="1000" b="1">
-                          <a:solidFill>
-                            <a:srgbClr val="1A1512"/>
-                          </a:solidFill>
-                          <a:latin typeface="IBM Plex Sans"/>
-                        </a:rPr>
-                        <a:t>64</a:t>
-                      </a:r>
-                    </a:p>
-                  </a:txBody>
-                  <a:tcPr>
-                    <a:solidFill>
-                      <a:srgbClr val="F7F1E6"/>
-                    </a:solidFill>
-                  </a:tcPr>
-                </a:tc>
-                <a:tc>
-                  <a:txBody>
-                    <a:bodyPr lIns="45000" rIns="45000" tIns="40000" bIns="40000" wrap="square"/>
-                    <a:lstStyle/>
-                    <a:p>
-                      <a:pPr algn="l">
-                        <a:lnSpc>
-                          <a:spcPct val="112000"/>
-                        </a:lnSpc>
-                      </a:pPr>
-                      <a:r>
-                        <a:rPr sz="750" b="0">
-                          <a:solidFill>
-                            <a:srgbClr val="1A1512"/>
-                          </a:solidFill>
-                          <a:latin typeface="IBM Plex Sans"/>
-                        </a:rPr>
-                        <a:t>Florida cGMP, FDA-registered. Lowest published stock-formula MOQ (48). Custom (vs stock) blends jump to 1,000+ MOQ. Stock biotin/collagen blend works for an MVP test.</a:t>
-                      </a:r>
-                    </a:p>
-                  </a:txBody>
-                  <a:tcPr>
-                    <a:solidFill>
-                      <a:srgbClr val="F7F1E6"/>
-                    </a:solidFill>
-                  </a:tcPr>
-                </a:tc>
-              </a:tr>
             </a:tbl>
           </a:graphicData>
         </a:graphic>
@@ -16056,7 +18521,7 @@
         </p:nvSpPr>
         <p:spPr>
           <a:xfrm>
-            <a:off x="777240" y="5577840"/>
+            <a:off x="777240" y="5532120"/>
             <a:ext cx="10607040" cy="640080"/>
           </a:xfrm>
           <a:prstGeom prst="rect">
@@ -16213,7 +18678,7 @@
                 </a:solidFill>
                 <a:latin typeface="IBM Plex Sans"/>
               </a:rPr>
-              <a:t>08 / 13</a:t>
+              <a:t>08 / 15</a:t>
             </a:r>
           </a:p>
         </p:txBody>
@@ -17173,7 +19638,7 @@
                 </a:solidFill>
                 <a:latin typeface="IBM Plex Sans"/>
               </a:rPr>
-              <a:t>09 / 13</a:t>
+              <a:t>09 / 15</a:t>
             </a:r>
           </a:p>
         </p:txBody>

</xml_diff>